<commit_message>
Presentacion resumen: agregar media y mediana de convenios con traslado terrestre mayor a 1 h
Co-Authored-By: Claude Sonnet 5 <noreply@anthropic.com>
</commit_message>
<xml_diff>
--- a/datos/Resumen_tiempos_convenios_BS.pptx
+++ b/datos/Resumen_tiempos_convenios_BS.pptx
@@ -820,8 +820,8 @@
         </p:nvSpPr>
         <p:spPr>
           <a:xfrm>
-            <a:off x="640000" y="1450000"/>
-            <a:ext cx="10900000" cy="4600000"/>
+            <a:off x="640000" y="1330000"/>
+            <a:ext cx="10900000" cy="4900000"/>
           </a:xfrm>
           <a:prstGeom prst="rect">
             <a:avLst/>
@@ -837,13 +837,139 @@
               <a:buNone/>
             </a:pPr>
             <a:r>
-              <a:rPr lang="es-PE" sz="1500" dirty="0">
+              <a:rPr lang="es-PE" sz="1400" dirty="0">
                 <a:solidFill>
                   <a:srgbClr val="022300"/>
                 </a:solidFill>
                 <a:latin typeface="Calibri"/>
               </a:rPr>
               <a:t>Distribucion de los 246 convenios por tiempo de traslado terrestre (auto particular):</a:t>
+            </a:r>
+            <a:endParaRPr lang="es-PE" sz="1400"/>
+          </a:p>
+          <a:p>
+            <a:pPr marL="0" lvl="0">
+              <a:buFont typeface="Arial"/>
+              <a:buChar char="•"/>
+            </a:pPr>
+            <a:r>
+              <a:rPr lang="es-PE" sz="1400" dirty="0">
+                <a:solidFill>
+                  <a:srgbClr val="022300"/>
+                </a:solidFill>
+                <a:latin typeface="Calibri"/>
+              </a:rPr>
+              <a:t>Hasta 1 h ............ 183</a:t>
+            </a:r>
+            <a:endParaRPr lang="es-PE" sz="1400"/>
+          </a:p>
+          <a:p>
+            <a:pPr marL="0" lvl="0">
+              <a:buFont typeface="Arial"/>
+              <a:buChar char="•"/>
+            </a:pPr>
+            <a:r>
+              <a:rPr lang="es-PE" sz="1400" dirty="0">
+                <a:solidFill>
+                  <a:srgbClr val="022300"/>
+                </a:solidFill>
+                <a:latin typeface="Calibri"/>
+              </a:rPr>
+              <a:t>1 a 3 h .............. 39</a:t>
+            </a:r>
+            <a:endParaRPr lang="es-PE" sz="1400"/>
+          </a:p>
+          <a:p>
+            <a:pPr marL="0" lvl="0">
+              <a:buFont typeface="Arial"/>
+              <a:buChar char="•"/>
+            </a:pPr>
+            <a:r>
+              <a:rPr lang="es-PE" sz="1400" dirty="0">
+                <a:solidFill>
+                  <a:srgbClr val="022300"/>
+                </a:solidFill>
+                <a:latin typeface="Calibri"/>
+              </a:rPr>
+              <a:t>3 a 6 h .............. 12</a:t>
+            </a:r>
+            <a:endParaRPr lang="es-PE" sz="1400"/>
+          </a:p>
+          <a:p>
+            <a:pPr marL="0" lvl="0">
+              <a:buFont typeface="Arial"/>
+              <a:buChar char="•"/>
+            </a:pPr>
+            <a:r>
+              <a:rPr lang="es-PE" sz="1400" dirty="0">
+                <a:solidFill>
+                  <a:srgbClr val="022300"/>
+                </a:solidFill>
+                <a:latin typeface="Calibri"/>
+              </a:rPr>
+              <a:t>6 a 12 h ............. 5</a:t>
+            </a:r>
+            <a:endParaRPr lang="es-PE" sz="1400"/>
+          </a:p>
+          <a:p>
+            <a:pPr marL="0" lvl="0">
+              <a:buFont typeface="Arial"/>
+              <a:buChar char="•"/>
+            </a:pPr>
+            <a:r>
+              <a:rPr lang="es-PE" sz="1400" dirty="0">
+                <a:solidFill>
+                  <a:srgbClr val="022300"/>
+                </a:solidFill>
+                <a:latin typeface="Calibri"/>
+              </a:rPr>
+              <a:t>12 a 24 h ............ 5</a:t>
+            </a:r>
+            <a:endParaRPr lang="es-PE" sz="1400"/>
+          </a:p>
+          <a:p>
+            <a:pPr marL="0" lvl="0">
+              <a:buFont typeface="Arial"/>
+              <a:buChar char="•"/>
+            </a:pPr>
+            <a:r>
+              <a:rPr lang="es-PE" sz="1400" dirty="0">
+                <a:solidFill>
+                  <a:srgbClr val="B03A2E"/>
+                </a:solidFill>
+                <a:latin typeface="Calibri"/>
+              </a:rPr>
+              <a:t>Mas de 24 h ......... 2</a:t>
+            </a:r>
+            <a:endParaRPr lang="es-PE" sz="1400"/>
+          </a:p>
+          <a:p>
+            <a:pPr marL="0" lvl="0">
+              <a:buNone/>
+            </a:pPr>
+            <a:r>
+              <a:rPr lang="es-PE" sz="1300" dirty="0">
+                <a:solidFill>
+                  <a:srgbClr val="7A8699"/>
+                </a:solidFill>
+                <a:latin typeface="Calibri"/>
+              </a:rPr>
+              <a:t>Conjunto completo (246 convenios): mediana 0 h 25 min, media 1 h 42 min.</a:t>
+            </a:r>
+            <a:endParaRPr lang="es-PE" sz="1300"/>
+          </a:p>
+          <a:p>
+            <a:pPr marL="0" lvl="0">
+              <a:buNone/>
+            </a:pPr>
+            <a:r>
+              <a:rPr lang="es-PE" sz="1500" b="1" dirty="0">
+                <a:solidFill>
+                  <a:srgbClr val="1F2A44"/>
+                </a:solidFill>
+                <a:latin typeface="Calibri"/>
+              </a:rPr>
+              <a:t>IPRESS con traslado terrestre mayor a 1 h: 63 convenios (26 % del total).</a:t>
             </a:r>
             <a:endParaRPr lang="es-PE" sz="1500"/>
           </a:p>
@@ -859,87 +985,7 @@
                 </a:solidFill>
                 <a:latin typeface="Calibri"/>
               </a:rPr>
-              <a:t>Hasta 1 h ............ 183</a:t>
-            </a:r>
-            <a:endParaRPr lang="es-PE" sz="1500"/>
-          </a:p>
-          <a:p>
-            <a:pPr marL="0" lvl="0">
-              <a:buFont typeface="Arial"/>
-              <a:buChar char="•"/>
-            </a:pPr>
-            <a:r>
-              <a:rPr lang="es-PE" sz="1500" dirty="0">
-                <a:solidFill>
-                  <a:srgbClr val="022300"/>
-                </a:solidFill>
-                <a:latin typeface="Calibri"/>
-              </a:rPr>
-              <a:t>1 a 3 h .............. 39</a:t>
-            </a:r>
-            <a:endParaRPr lang="es-PE" sz="1500"/>
-          </a:p>
-          <a:p>
-            <a:pPr marL="0" lvl="0">
-              <a:buFont typeface="Arial"/>
-              <a:buChar char="•"/>
-            </a:pPr>
-            <a:r>
-              <a:rPr lang="es-PE" sz="1500" dirty="0">
-                <a:solidFill>
-                  <a:srgbClr val="022300"/>
-                </a:solidFill>
-                <a:latin typeface="Calibri"/>
-              </a:rPr>
-              <a:t>3 a 6 h .............. 12</a:t>
-            </a:r>
-            <a:endParaRPr lang="es-PE" sz="1500"/>
-          </a:p>
-          <a:p>
-            <a:pPr marL="0" lvl="0">
-              <a:buFont typeface="Arial"/>
-              <a:buChar char="•"/>
-            </a:pPr>
-            <a:r>
-              <a:rPr lang="es-PE" sz="1500" dirty="0">
-                <a:solidFill>
-                  <a:srgbClr val="022300"/>
-                </a:solidFill>
-                <a:latin typeface="Calibri"/>
-              </a:rPr>
-              <a:t>6 a 12 h ............. 5</a:t>
-            </a:r>
-            <a:endParaRPr lang="es-PE" sz="1500"/>
-          </a:p>
-          <a:p>
-            <a:pPr marL="0" lvl="0">
-              <a:buFont typeface="Arial"/>
-              <a:buChar char="•"/>
-            </a:pPr>
-            <a:r>
-              <a:rPr lang="es-PE" sz="1500" dirty="0">
-                <a:solidFill>
-                  <a:srgbClr val="022300"/>
-                </a:solidFill>
-                <a:latin typeface="Calibri"/>
-              </a:rPr>
-              <a:t>12 a 24 h ............ 5</a:t>
-            </a:r>
-            <a:endParaRPr lang="es-PE" sz="1500"/>
-          </a:p>
-          <a:p>
-            <a:pPr marL="0" lvl="0">
-              <a:buFont typeface="Arial"/>
-              <a:buChar char="•"/>
-            </a:pPr>
-            <a:r>
-              <a:rPr lang="es-PE" sz="1500" dirty="0">
-                <a:solidFill>
-                  <a:srgbClr val="B03A2E"/>
-                </a:solidFill>
-                <a:latin typeface="Calibri"/>
-              </a:rPr>
-              <a:t>Mas de 24 h ......... 2</a:t>
+              <a:t>En ese grupo la mediana del tiempo de ruta es 2 h 30 min y la media es 5 h 30 min.</a:t>
             </a:r>
             <a:endParaRPr lang="es-PE" sz="1500"/>
           </a:p>
@@ -948,15 +994,15 @@
               <a:buNone/>
             </a:pPr>
             <a:r>
-              <a:rPr lang="es-PE" sz="1300" dirty="0">
+              <a:rPr lang="es-PE" sz="1200" dirty="0">
                 <a:solidFill>
                   <a:srgbClr val="7A8699"/>
                 </a:solidFill>
                 <a:latin typeface="Calibri"/>
               </a:rPr>
-              <a:t>Mediana: 25 min h. La gran mayoria son traslados intra-ciudad o intra-region de menos de 3 h.</a:t>
+              <a:t>La media es mayor que la mediana porque unos pocos convenios inter-regionales de sierra y selva (12 h a 2 dias) elevan el promedio; para la mitad del grupo el traslado sigue por debajo de 2 h 30 min.</a:t>
             </a:r>
-            <a:endParaRPr lang="es-PE" sz="1300"/>
+            <a:endParaRPr lang="es-PE" sz="1200"/>
           </a:p>
         </p:txBody>
       </p:sp>
@@ -1032,7 +1078,7 @@
         </p:nvGraphicFramePr>
         <p:xfrm>
           <a:off x="500000" y="1350000"/>
-          <a:ext cx="11200000" cy="4700000"/>
+          <a:ext cx="11200000" cy="1000000"/>
         </p:xfrm>
         <a:graphic>
           <a:graphicData uri="http://schemas.openxmlformats.org/drawingml/2006/table">
@@ -2755,7 +2801,7 @@
         </p:nvGraphicFramePr>
         <p:xfrm>
           <a:off x="500000" y="1350000"/>
-          <a:ext cx="11200000" cy="3980000"/>
+          <a:ext cx="11200000" cy="1000000"/>
         </p:xfrm>
         <a:graphic>
           <a:graphicData uri="http://schemas.openxmlformats.org/drawingml/2006/table">

</xml_diff>

<commit_message>
Actualizar red de convenios desde nueva base semaforo (relacion por RENIPRESS)
La nueva base ubica la relacion productor-receptor en la hoja Hoja1
(antes en Sheet1); build_conv.ps1 se ajusta para leerla de ahi.
Corrige 7 vinculos de convenio via RENIPRESS y recalcula tiempos reales
de ruta terrestre, aerea y fluvial para los 278 convenios (Excel y
presentacion resumen actualizados).

Co-Authored-By: Claude Sonnet 5 <noreply@anthropic.com>
</commit_message>
<xml_diff>
--- a/datos/Resumen_tiempos_convenios_BS.pptx
+++ b/datos/Resumen_tiempos_convenios_BS.pptx
@@ -557,7 +557,7 @@
                 </a:solidFill>
                 <a:latin typeface="Calibri"/>
               </a:rPr>
-              <a:t>Verificacion semaforo de convenios (agosto 2026) - 2026-09-03</a:t>
+              <a:t>Verificacion semaforo de convenios (agosto 2026) - 2026-09-04</a:t>
             </a:r>
             <a:endParaRPr lang="es-PE" sz="1400"/>
           </a:p>
@@ -677,7 +677,7 @@
                 </a:solidFill>
                 <a:latin typeface="Calibri"/>
               </a:rPr>
-              <a:t>246 con ruta terrestre calculada. Ningun convenio resulto sin acceso por carretera.</a:t>
+              <a:t>248 con ruta terrestre calculada. Ningun convenio resulto sin acceso por carretera.</a:t>
             </a:r>
             <a:endParaRPr lang="es-PE" sz="1600"/>
           </a:p>
@@ -693,7 +693,7 @@
                 </a:solidFill>
                 <a:latin typeface="Calibri"/>
               </a:rPr>
-              <a:t>20 con opcion de via aerea util (origen y destino en ciudades con aeropuertos distintos).</a:t>
+              <a:t>18 con opcion de via aerea util (origen y destino en ciudades con aeropuertos distintos).</a:t>
             </a:r>
             <a:endParaRPr lang="es-PE" sz="1600"/>
           </a:p>
@@ -725,7 +725,7 @@
                 </a:solidFill>
                 <a:latin typeface="Calibri"/>
               </a:rPr>
-              <a:t>32 sin dato: el hospital receptor no figura con ubicacion en el Registro Nacional (RENIPRESS no encontrado).</a:t>
+              <a:t>30 sin dato: el hospital receptor no figura con ubicacion en el Registro Nacional (RENIPRESS no encontrado).</a:t>
             </a:r>
             <a:endParaRPr lang="es-PE" sz="1600"/>
           </a:p>
@@ -843,7 +843,7 @@
                 </a:solidFill>
                 <a:latin typeface="Calibri"/>
               </a:rPr>
-              <a:t>Distribucion de los 246 convenios por tiempo de traslado terrestre (auto particular):</a:t>
+              <a:t>Distribucion de los 248 convenios por tiempo de traslado terrestre (auto particular):</a:t>
             </a:r>
             <a:endParaRPr lang="es-PE" sz="1400"/>
           </a:p>
@@ -859,7 +859,7 @@
                 </a:solidFill>
                 <a:latin typeface="Calibri"/>
               </a:rPr>
-              <a:t>Hasta 1 h ............ 183</a:t>
+              <a:t>Hasta 1 h ............ 189</a:t>
             </a:r>
             <a:endParaRPr lang="es-PE" sz="1400"/>
           </a:p>
@@ -875,7 +875,7 @@
                 </a:solidFill>
                 <a:latin typeface="Calibri"/>
               </a:rPr>
-              <a:t>1 a 3 h .............. 39</a:t>
+              <a:t>1 a 3 h .............. 37</a:t>
             </a:r>
             <a:endParaRPr lang="es-PE" sz="1400"/>
           </a:p>
@@ -891,7 +891,7 @@
                 </a:solidFill>
                 <a:latin typeface="Calibri"/>
               </a:rPr>
-              <a:t>3 a 6 h .............. 12</a:t>
+              <a:t>3 a 6 h .............. 11</a:t>
             </a:r>
             <a:endParaRPr lang="es-PE" sz="1400"/>
           </a:p>
@@ -907,7 +907,7 @@
                 </a:solidFill>
                 <a:latin typeface="Calibri"/>
               </a:rPr>
-              <a:t>6 a 12 h ............. 5</a:t>
+              <a:t>6 a 12 h ............. 6</a:t>
             </a:r>
             <a:endParaRPr lang="es-PE" sz="1400"/>
           </a:p>
@@ -923,7 +923,7 @@
                 </a:solidFill>
                 <a:latin typeface="Calibri"/>
               </a:rPr>
-              <a:t>12 a 24 h ............ 5</a:t>
+              <a:t>12 a 24 h ............ 4</a:t>
             </a:r>
             <a:endParaRPr lang="es-PE" sz="1400"/>
           </a:p>
@@ -939,7 +939,7 @@
                 </a:solidFill>
                 <a:latin typeface="Calibri"/>
               </a:rPr>
-              <a:t>Mas de 24 h ......... 2</a:t>
+              <a:t>Mas de 24 h ......... 1</a:t>
             </a:r>
             <a:endParaRPr lang="es-PE" sz="1400"/>
           </a:p>
@@ -954,7 +954,7 @@
                 </a:solidFill>
                 <a:latin typeface="Calibri"/>
               </a:rPr>
-              <a:t>Conjunto completo (246 convenios): mediana 0 h 25 min, media 1 h 42 min.</a:t>
+              <a:t>Conjunto completo (248 convenios): mediana 0 h 26 min, media 1 h 27 min.</a:t>
             </a:r>
             <a:endParaRPr lang="es-PE" sz="1300"/>
           </a:p>
@@ -969,7 +969,7 @@
                 </a:solidFill>
                 <a:latin typeface="Calibri"/>
               </a:rPr>
-              <a:t>IPRESS con traslado terrestre mayor a 1 h: 63 convenios (26 % del total).</a:t>
+              <a:t>IPRESS con traslado terrestre mayor a 1 h: 59 convenios (24 % del total).</a:t>
             </a:r>
             <a:endParaRPr lang="es-PE" sz="1500"/>
           </a:p>
@@ -985,7 +985,7 @@
                 </a:solidFill>
                 <a:latin typeface="Calibri"/>
               </a:rPr>
-              <a:t>En ese grupo la mediana del tiempo de ruta es 2 h 30 min y la media es 5 h 30 min.</a:t>
+              <a:t>En ese grupo la mediana del tiempo de ruta es 2 h 30 min y la media es 4 h 52 min.</a:t>
             </a:r>
             <a:endParaRPr lang="es-PE" sz="1500"/>
           </a:p>
@@ -1359,7 +1359,7 @@
                         <a:rPr lang="es-PE" sz="1050">
                           <a:latin typeface="Calibri"/>
                         </a:rPr>
-                        <a:t>2 d 6 h</a:t>
+                        <a:t>2 d 5 h</a:t>
                       </a:r>
                     </a:p>
                   </a:txBody>
@@ -1404,102 +1404,102 @@
                         <a:rPr lang="es-PE" sz="1050">
                           <a:latin typeface="Calibri"/>
                         </a:rPr>
-                        <a:t>24</a:t>
-                      </a:r>
-                    </a:p>
-                  </a:txBody>
-                  <a:tcPr>
-                    <a:solidFill>
-                      <a:srgbClr val="EEF1F6"/>
-                    </a:solidFill>
-                  </a:tcPr>
-                </a:tc>
-                <a:tc>
-                  <a:txBody>
-                    <a:bodyPr/>
-                    <a:lstStyle/>
-                    <a:p>
-                      <a:r>
-                        <a:rPr lang="es-PE" sz="1050">
-                          <a:latin typeface="Calibri"/>
-                        </a:rPr>
-                        <a:t>INSTITUTO REGIONAL DE ENF…</a:t>
-                      </a:r>
-                    </a:p>
-                  </a:txBody>
-                  <a:tcPr>
-                    <a:solidFill>
-                      <a:srgbClr val="EEF1F6"/>
-                    </a:solidFill>
-                  </a:tcPr>
-                </a:tc>
-                <a:tc>
-                  <a:txBody>
-                    <a:bodyPr/>
-                    <a:lstStyle/>
-                    <a:p>
-                      <a:r>
-                        <a:rPr lang="es-PE" sz="1050">
-                          <a:latin typeface="Calibri"/>
-                        </a:rPr>
-                        <a:t>Hospital Militar Division…</a:t>
-                      </a:r>
-                    </a:p>
-                  </a:txBody>
-                  <a:tcPr>
-                    <a:solidFill>
-                      <a:srgbClr val="EEF1F6"/>
-                    </a:solidFill>
-                  </a:tcPr>
-                </a:tc>
-                <a:tc>
-                  <a:txBody>
-                    <a:bodyPr/>
-                    <a:lstStyle/>
-                    <a:p>
-                      <a:r>
-                        <a:rPr lang="es-PE" sz="1050">
-                          <a:latin typeface="Calibri"/>
-                        </a:rPr>
-                        <a:t>1,974</a:t>
-                      </a:r>
-                    </a:p>
-                  </a:txBody>
-                  <a:tcPr>
-                    <a:solidFill>
-                      <a:srgbClr val="EEF1F6"/>
-                    </a:solidFill>
-                  </a:tcPr>
-                </a:tc>
-                <a:tc>
-                  <a:txBody>
-                    <a:bodyPr/>
-                    <a:lstStyle/>
-                    <a:p>
-                      <a:r>
-                        <a:rPr lang="es-PE" sz="1050">
-                          <a:latin typeface="Calibri"/>
-                        </a:rPr>
-                        <a:t>1 d 16 h</a:t>
-                      </a:r>
-                    </a:p>
-                  </a:txBody>
-                  <a:tcPr>
-                    <a:solidFill>
-                      <a:srgbClr val="EEF1F6"/>
-                    </a:solidFill>
-                  </a:tcPr>
-                </a:tc>
-                <a:tc>
-                  <a:txBody>
-                    <a:bodyPr/>
-                    <a:lstStyle/>
-                    <a:p>
-                      <a:r>
-                        <a:rPr lang="es-PE" sz="1050">
-                          <a:latin typeface="Calibri"/>
-                        </a:rPr>
-                        <a:t>sierra / ceja de selva</a:t>
+                        <a:t>211</a:t>
+                      </a:r>
+                    </a:p>
+                  </a:txBody>
+                  <a:tcPr>
+                    <a:solidFill>
+                      <a:srgbClr val="EEF1F6"/>
+                    </a:solidFill>
+                  </a:tcPr>
+                </a:tc>
+                <a:tc>
+                  <a:txBody>
+                    <a:bodyPr/>
+                    <a:lstStyle/>
+                    <a:p>
+                      <a:r>
+                        <a:rPr lang="es-PE" sz="1050">
+                          <a:latin typeface="Calibri"/>
+                        </a:rPr>
+                        <a:t>MEDIC SER SAC -AUNA CLINI…</a:t>
+                      </a:r>
+                    </a:p>
+                  </a:txBody>
+                  <a:tcPr>
+                    <a:solidFill>
+                      <a:srgbClr val="EEF1F6"/>
+                    </a:solidFill>
+                  </a:tcPr>
+                </a:tc>
+                <a:tc>
+                  <a:txBody>
+                    <a:bodyPr/>
+                    <a:lstStyle/>
+                    <a:p>
+                      <a:r>
+                        <a:rPr lang="es-PE" sz="1050">
+                          <a:latin typeface="Calibri"/>
+                        </a:rPr>
+                        <a:t>CLÍNICAS AUNA SEDE PIURA -</a:t>
+                      </a:r>
+                    </a:p>
+                  </a:txBody>
+                  <a:tcPr>
+                    <a:solidFill>
+                      <a:srgbClr val="EEF1F6"/>
+                    </a:solidFill>
+                  </a:tcPr>
+                </a:tc>
+                <a:tc>
+                  <a:txBody>
+                    <a:bodyPr/>
+                    <a:lstStyle/>
+                    <a:p>
+                      <a:r>
+                        <a:rPr lang="es-PE" sz="1050">
+                          <a:latin typeface="Calibri"/>
+                        </a:rPr>
+                        <a:t>977</a:t>
+                      </a:r>
+                    </a:p>
+                  </a:txBody>
+                  <a:tcPr>
+                    <a:solidFill>
+                      <a:srgbClr val="EEF1F6"/>
+                    </a:solidFill>
+                  </a:tcPr>
+                </a:tc>
+                <a:tc>
+                  <a:txBody>
+                    <a:bodyPr/>
+                    <a:lstStyle/>
+                    <a:p>
+                      <a:r>
+                        <a:rPr lang="es-PE" sz="1050">
+                          <a:latin typeface="Calibri"/>
+                        </a:rPr>
+                        <a:t>18 h 21 min</a:t>
+                      </a:r>
+                    </a:p>
+                  </a:txBody>
+                  <a:tcPr>
+                    <a:solidFill>
+                      <a:srgbClr val="EEF1F6"/>
+                    </a:solidFill>
+                  </a:tcPr>
+                </a:tc>
+                <a:tc>
+                  <a:txBody>
+                    <a:bodyPr/>
+                    <a:lstStyle/>
+                    <a:p>
+                      <a:r>
+                        <a:rPr lang="es-PE" sz="1050">
+                          <a:latin typeface="Calibri"/>
+                        </a:rPr>
+                        <a:t>costa / llano</a:t>
                       </a:r>
                     </a:p>
                   </a:txBody>
@@ -1582,26 +1582,26 @@
                         <a:rPr lang="es-PE" sz="1050">
                           <a:latin typeface="Calibri"/>
                         </a:rPr>
-                        <a:t>977</a:t>
-                      </a:r>
-                    </a:p>
-                  </a:txBody>
-                  <a:tcPr>
-                    <a:solidFill>
-                      <a:srgbClr val="FFFFFF"/>
-                    </a:solidFill>
-                  </a:tcPr>
-                </a:tc>
-                <a:tc>
-                  <a:txBody>
-                    <a:bodyPr/>
-                    <a:lstStyle/>
-                    <a:p>
-                      <a:r>
-                        <a:rPr lang="es-PE" sz="1050">
-                          <a:latin typeface="Calibri"/>
-                        </a:rPr>
-                        <a:t>18 h 21 min</a:t>
+                        <a:t>978</a:t>
+                      </a:r>
+                    </a:p>
+                  </a:txBody>
+                  <a:tcPr>
+                    <a:solidFill>
+                      <a:srgbClr val="FFFFFF"/>
+                    </a:solidFill>
+                  </a:tcPr>
+                </a:tc>
+                <a:tc>
+                  <a:txBody>
+                    <a:bodyPr/>
+                    <a:lstStyle/>
+                    <a:p>
+                      <a:r>
+                        <a:rPr lang="es-PE" sz="1050">
+                          <a:latin typeface="Calibri"/>
+                        </a:rPr>
+                        <a:t>18 h 20 min</a:t>
                       </a:r>
                     </a:p>
                   </a:txBody>
@@ -1646,7 +1646,7 @@
                         <a:rPr lang="es-PE" sz="1050">
                           <a:latin typeface="Calibri"/>
                         </a:rPr>
-                        <a:t>211</a:t>
+                        <a:t>209</a:t>
                       </a:r>
                     </a:p>
                   </a:txBody>
@@ -1684,64 +1684,64 @@
                         <a:rPr lang="es-PE" sz="1050">
                           <a:latin typeface="Calibri"/>
                         </a:rPr>
-                        <a:t>CLÍNICAS AUNA SEDE PIURA -</a:t>
-                      </a:r>
-                    </a:p>
-                  </a:txBody>
-                  <a:tcPr>
-                    <a:solidFill>
-                      <a:srgbClr val="EEF1F6"/>
-                    </a:solidFill>
-                  </a:tcPr>
-                </a:tc>
-                <a:tc>
-                  <a:txBody>
-                    <a:bodyPr/>
-                    <a:lstStyle/>
-                    <a:p>
-                      <a:r>
-                        <a:rPr lang="es-PE" sz="1050">
-                          <a:latin typeface="Calibri"/>
-                        </a:rPr>
-                        <a:t>977</a:t>
-                      </a:r>
-                    </a:p>
-                  </a:txBody>
-                  <a:tcPr>
-                    <a:solidFill>
-                      <a:srgbClr val="EEF1F6"/>
-                    </a:solidFill>
-                  </a:tcPr>
-                </a:tc>
-                <a:tc>
-                  <a:txBody>
-                    <a:bodyPr/>
-                    <a:lstStyle/>
-                    <a:p>
-                      <a:r>
-                        <a:rPr lang="es-PE" sz="1050">
-                          <a:latin typeface="Calibri"/>
-                        </a:rPr>
-                        <a:t>18 h 20 min</a:t>
-                      </a:r>
-                    </a:p>
-                  </a:txBody>
-                  <a:tcPr>
-                    <a:solidFill>
-                      <a:srgbClr val="EEF1F6"/>
-                    </a:solidFill>
-                  </a:tcPr>
-                </a:tc>
-                <a:tc>
-                  <a:txBody>
-                    <a:bodyPr/>
-                    <a:lstStyle/>
-                    <a:p>
-                      <a:r>
-                        <a:rPr lang="es-PE" sz="1050">
-                          <a:latin typeface="Calibri"/>
-                        </a:rPr>
-                        <a:t>costa / llano</a:t>
+                        <a:t>CLINICAS AUNA SEDE VALLE…</a:t>
+                      </a:r>
+                    </a:p>
+                  </a:txBody>
+                  <a:tcPr>
+                    <a:solidFill>
+                      <a:srgbClr val="EEF1F6"/>
+                    </a:solidFill>
+                  </a:tcPr>
+                </a:tc>
+                <a:tc>
+                  <a:txBody>
+                    <a:bodyPr/>
+                    <a:lstStyle/>
+                    <a:p>
+                      <a:r>
+                        <a:rPr lang="es-PE" sz="1050">
+                          <a:latin typeface="Calibri"/>
+                        </a:rPr>
+                        <a:t>993</a:t>
+                      </a:r>
+                    </a:p>
+                  </a:txBody>
+                  <a:tcPr>
+                    <a:solidFill>
+                      <a:srgbClr val="EEF1F6"/>
+                    </a:solidFill>
+                  </a:tcPr>
+                </a:tc>
+                <a:tc>
+                  <a:txBody>
+                    <a:bodyPr/>
+                    <a:lstStyle/>
+                    <a:p>
+                      <a:r>
+                        <a:rPr lang="es-PE" sz="1050">
+                          <a:latin typeface="Calibri"/>
+                        </a:rPr>
+                        <a:t>17 h 36 min</a:t>
+                      </a:r>
+                    </a:p>
+                  </a:txBody>
+                  <a:tcPr>
+                    <a:solidFill>
+                      <a:srgbClr val="EEF1F6"/>
+                    </a:solidFill>
+                  </a:tcPr>
+                </a:tc>
+                <a:tc>
+                  <a:txBody>
+                    <a:bodyPr/>
+                    <a:lstStyle/>
+                    <a:p>
+                      <a:r>
+                        <a:rPr lang="es-PE" sz="1050">
+                          <a:latin typeface="Calibri"/>
+                        </a:rPr>
+                        <a:t>tramos de altura</a:t>
                       </a:r>
                     </a:p>
                   </a:txBody>
@@ -1767,83 +1767,83 @@
                         <a:rPr lang="es-PE" sz="1050">
                           <a:latin typeface="Calibri"/>
                         </a:rPr>
-                        <a:t>246</a:t>
-                      </a:r>
-                    </a:p>
-                  </a:txBody>
-                  <a:tcPr>
-                    <a:solidFill>
-                      <a:srgbClr val="FFFFFF"/>
-                    </a:solidFill>
-                  </a:tcPr>
-                </a:tc>
-                <a:tc>
-                  <a:txBody>
-                    <a:bodyPr/>
-                    <a:lstStyle/>
-                    <a:p>
-                      <a:r>
-                        <a:rPr lang="es-PE" sz="1050">
-                          <a:latin typeface="Calibri"/>
-                        </a:rPr>
-                        <a:t>HOSPITAL DE LA AMISTAD PE…</a:t>
-                      </a:r>
-                    </a:p>
-                  </a:txBody>
-                  <a:tcPr>
-                    <a:solidFill>
-                      <a:srgbClr val="FFFFFF"/>
-                    </a:solidFill>
-                  </a:tcPr>
-                </a:tc>
-                <a:tc>
-                  <a:txBody>
-                    <a:bodyPr/>
-                    <a:lstStyle/>
-                    <a:p>
-                      <a:r>
-                        <a:rPr lang="es-PE" sz="1050">
-                          <a:latin typeface="Calibri"/>
-                        </a:rPr>
-                        <a:t>HOGAR CLÍNICA MONTE SINAÍ</a:t>
-                      </a:r>
-                    </a:p>
-                  </a:txBody>
-                  <a:tcPr>
-                    <a:solidFill>
-                      <a:srgbClr val="FFFFFF"/>
-                    </a:solidFill>
-                  </a:tcPr>
-                </a:tc>
-                <a:tc>
-                  <a:txBody>
-                    <a:bodyPr/>
-                    <a:lstStyle/>
-                    <a:p>
-                      <a:r>
-                        <a:rPr lang="es-PE" sz="1050">
-                          <a:latin typeface="Calibri"/>
-                        </a:rPr>
-                        <a:t>968</a:t>
-                      </a:r>
-                    </a:p>
-                  </a:txBody>
-                  <a:tcPr>
-                    <a:solidFill>
-                      <a:srgbClr val="FFFFFF"/>
-                    </a:solidFill>
-                  </a:tcPr>
-                </a:tc>
-                <a:tc>
-                  <a:txBody>
-                    <a:bodyPr/>
-                    <a:lstStyle/>
-                    <a:p>
-                      <a:r>
-                        <a:rPr lang="es-PE" sz="1050">
-                          <a:latin typeface="Calibri"/>
-                        </a:rPr>
-                        <a:t>17 h 40 min</a:t>
+                        <a:t>212</a:t>
+                      </a:r>
+                    </a:p>
+                  </a:txBody>
+                  <a:tcPr>
+                    <a:solidFill>
+                      <a:srgbClr val="FFFFFF"/>
+                    </a:solidFill>
+                  </a:tcPr>
+                </a:tc>
+                <a:tc>
+                  <a:txBody>
+                    <a:bodyPr/>
+                    <a:lstStyle/>
+                    <a:p>
+                      <a:r>
+                        <a:rPr lang="es-PE" sz="1050">
+                          <a:latin typeface="Calibri"/>
+                        </a:rPr>
+                        <a:t>MEDIC SER SAC -AUNA CLINI…</a:t>
+                      </a:r>
+                    </a:p>
+                  </a:txBody>
+                  <a:tcPr>
+                    <a:solidFill>
+                      <a:srgbClr val="FFFFFF"/>
+                    </a:solidFill>
+                  </a:tcPr>
+                </a:tc>
+                <a:tc>
+                  <a:txBody>
+                    <a:bodyPr/>
+                    <a:lstStyle/>
+                    <a:p>
+                      <a:r>
+                        <a:rPr lang="es-PE" sz="1050">
+                          <a:latin typeface="Calibri"/>
+                        </a:rPr>
+                        <a:t>GSP TRUJILLO</a:t>
+                      </a:r>
+                    </a:p>
+                  </a:txBody>
+                  <a:tcPr>
+                    <a:solidFill>
+                      <a:srgbClr val="FFFFFF"/>
+                    </a:solidFill>
+                  </a:tcPr>
+                </a:tc>
+                <a:tc>
+                  <a:txBody>
+                    <a:bodyPr/>
+                    <a:lstStyle/>
+                    <a:p>
+                      <a:r>
+                        <a:rPr lang="es-PE" sz="1050">
+                          <a:latin typeface="Calibri"/>
+                        </a:rPr>
+                        <a:t>764</a:t>
+                      </a:r>
+                    </a:p>
+                  </a:txBody>
+                  <a:tcPr>
+                    <a:solidFill>
+                      <a:srgbClr val="FFFFFF"/>
+                    </a:solidFill>
+                  </a:tcPr>
+                </a:tc>
+                <a:tc>
+                  <a:txBody>
+                    <a:bodyPr/>
+                    <a:lstStyle/>
+                    <a:p>
+                      <a:r>
+                        <a:rPr lang="es-PE" sz="1050">
+                          <a:latin typeface="Calibri"/>
+                        </a:rPr>
+                        <a:t>14 h 56 min</a:t>
                       </a:r>
                     </a:p>
                   </a:txBody>
@@ -1888,102 +1888,102 @@
                         <a:rPr lang="es-PE" sz="1050">
                           <a:latin typeface="Calibri"/>
                         </a:rPr>
-                        <a:t>209</a:t>
-                      </a:r>
-                    </a:p>
-                  </a:txBody>
-                  <a:tcPr>
-                    <a:solidFill>
-                      <a:srgbClr val="EEF1F6"/>
-                    </a:solidFill>
-                  </a:tcPr>
-                </a:tc>
-                <a:tc>
-                  <a:txBody>
-                    <a:bodyPr/>
-                    <a:lstStyle/>
-                    <a:p>
-                      <a:r>
-                        <a:rPr lang="es-PE" sz="1050">
-                          <a:latin typeface="Calibri"/>
-                        </a:rPr>
-                        <a:t>MEDIC SER SAC -AUNA CLINI…</a:t>
-                      </a:r>
-                    </a:p>
-                  </a:txBody>
-                  <a:tcPr>
-                    <a:solidFill>
-                      <a:srgbClr val="EEF1F6"/>
-                    </a:solidFill>
-                  </a:tcPr>
-                </a:tc>
-                <a:tc>
-                  <a:txBody>
-                    <a:bodyPr/>
-                    <a:lstStyle/>
-                    <a:p>
-                      <a:r>
-                        <a:rPr lang="es-PE" sz="1050">
-                          <a:latin typeface="Calibri"/>
-                        </a:rPr>
-                        <a:t>CLINICAS AUNA SEDE VALLE…</a:t>
-                      </a:r>
-                    </a:p>
-                  </a:txBody>
-                  <a:tcPr>
-                    <a:solidFill>
-                      <a:srgbClr val="EEF1F6"/>
-                    </a:solidFill>
-                  </a:tcPr>
-                </a:tc>
-                <a:tc>
-                  <a:txBody>
-                    <a:bodyPr/>
-                    <a:lstStyle/>
-                    <a:p>
-                      <a:r>
-                        <a:rPr lang="es-PE" sz="1050">
-                          <a:latin typeface="Calibri"/>
-                        </a:rPr>
-                        <a:t>991</a:t>
-                      </a:r>
-                    </a:p>
-                  </a:txBody>
-                  <a:tcPr>
-                    <a:solidFill>
-                      <a:srgbClr val="EEF1F6"/>
-                    </a:solidFill>
-                  </a:tcPr>
-                </a:tc>
-                <a:tc>
-                  <a:txBody>
-                    <a:bodyPr/>
-                    <a:lstStyle/>
-                    <a:p>
-                      <a:r>
-                        <a:rPr lang="es-PE" sz="1050">
-                          <a:latin typeface="Calibri"/>
-                        </a:rPr>
-                        <a:t>17 h 32 min</a:t>
-                      </a:r>
-                    </a:p>
-                  </a:txBody>
-                  <a:tcPr>
-                    <a:solidFill>
-                      <a:srgbClr val="EEF1F6"/>
-                    </a:solidFill>
-                  </a:tcPr>
-                </a:tc>
-                <a:tc>
-                  <a:txBody>
-                    <a:bodyPr/>
-                    <a:lstStyle/>
-                    <a:p>
-                      <a:r>
-                        <a:rPr lang="es-PE" sz="1050">
-                          <a:latin typeface="Calibri"/>
-                        </a:rPr>
-                        <a:t>tramos de altura</a:t>
+                        <a:t>100</a:t>
+                      </a:r>
+                    </a:p>
+                  </a:txBody>
+                  <a:tcPr>
+                    <a:solidFill>
+                      <a:srgbClr val="EEF1F6"/>
+                    </a:solidFill>
+                  </a:tcPr>
+                </a:tc>
+                <a:tc>
+                  <a:txBody>
+                    <a:bodyPr/>
+                    <a:lstStyle/>
+                    <a:p>
+                      <a:r>
+                        <a:rPr lang="es-PE" sz="1050">
+                          <a:latin typeface="Calibri"/>
+                        </a:rPr>
+                        <a:t>HOSPITAL REGIONAL DOCENTE…</a:t>
+                      </a:r>
+                    </a:p>
+                  </a:txBody>
+                  <a:tcPr>
+                    <a:solidFill>
+                      <a:srgbClr val="EEF1F6"/>
+                    </a:solidFill>
+                  </a:tcPr>
+                </a:tc>
+                <a:tc>
+                  <a:txBody>
+                    <a:bodyPr/>
+                    <a:lstStyle/>
+                    <a:p>
+                      <a:r>
+                        <a:rPr lang="es-PE" sz="1050">
+                          <a:latin typeface="Calibri"/>
+                        </a:rPr>
+                        <a:t>CLINICA CAMINO REAL</a:t>
+                      </a:r>
+                    </a:p>
+                  </a:txBody>
+                  <a:tcPr>
+                    <a:solidFill>
+                      <a:srgbClr val="EEF1F6"/>
+                    </a:solidFill>
+                  </a:tcPr>
+                </a:tc>
+                <a:tc>
+                  <a:txBody>
+                    <a:bodyPr/>
+                    <a:lstStyle/>
+                    <a:p>
+                      <a:r>
+                        <a:rPr lang="es-PE" sz="1050">
+                          <a:latin typeface="Calibri"/>
+                        </a:rPr>
+                        <a:t>559</a:t>
+                      </a:r>
+                    </a:p>
+                  </a:txBody>
+                  <a:tcPr>
+                    <a:solidFill>
+                      <a:srgbClr val="EEF1F6"/>
+                    </a:solidFill>
+                  </a:tcPr>
+                </a:tc>
+                <a:tc>
+                  <a:txBody>
+                    <a:bodyPr/>
+                    <a:lstStyle/>
+                    <a:p>
+                      <a:r>
+                        <a:rPr lang="es-PE" sz="1050">
+                          <a:latin typeface="Calibri"/>
+                        </a:rPr>
+                        <a:t>10 h 24 min</a:t>
+                      </a:r>
+                    </a:p>
+                  </a:txBody>
+                  <a:tcPr>
+                    <a:solidFill>
+                      <a:srgbClr val="EEF1F6"/>
+                    </a:solidFill>
+                  </a:tcPr>
+                </a:tc>
+                <a:tc>
+                  <a:txBody>
+                    <a:bodyPr/>
+                    <a:lstStyle/>
+                    <a:p>
+                      <a:r>
+                        <a:rPr lang="es-PE" sz="1050">
+                          <a:latin typeface="Calibri"/>
+                        </a:rPr>
+                        <a:t>costa / llano</a:t>
                       </a:r>
                     </a:p>
                   </a:txBody>
@@ -2009,102 +2009,102 @@
                         <a:rPr lang="es-PE" sz="1050">
                           <a:latin typeface="Calibri"/>
                         </a:rPr>
-                        <a:t>212</a:t>
-                      </a:r>
-                    </a:p>
-                  </a:txBody>
-                  <a:tcPr>
-                    <a:solidFill>
-                      <a:srgbClr val="FFFFFF"/>
-                    </a:solidFill>
-                  </a:tcPr>
-                </a:tc>
-                <a:tc>
-                  <a:txBody>
-                    <a:bodyPr/>
-                    <a:lstStyle/>
-                    <a:p>
-                      <a:r>
-                        <a:rPr lang="es-PE" sz="1050">
-                          <a:latin typeface="Calibri"/>
-                        </a:rPr>
-                        <a:t>MEDIC SER SAC -AUNA CLINI…</a:t>
-                      </a:r>
-                    </a:p>
-                  </a:txBody>
-                  <a:tcPr>
-                    <a:solidFill>
-                      <a:srgbClr val="FFFFFF"/>
-                    </a:solidFill>
-                  </a:tcPr>
-                </a:tc>
-                <a:tc>
-                  <a:txBody>
-                    <a:bodyPr/>
-                    <a:lstStyle/>
-                    <a:p>
-                      <a:r>
-                        <a:rPr lang="es-PE" sz="1050">
-                          <a:latin typeface="Calibri"/>
-                        </a:rPr>
-                        <a:t>GSP TRUJILLO</a:t>
-                      </a:r>
-                    </a:p>
-                  </a:txBody>
-                  <a:tcPr>
-                    <a:solidFill>
-                      <a:srgbClr val="FFFFFF"/>
-                    </a:solidFill>
-                  </a:tcPr>
-                </a:tc>
-                <a:tc>
-                  <a:txBody>
-                    <a:bodyPr/>
-                    <a:lstStyle/>
-                    <a:p>
-                      <a:r>
-                        <a:rPr lang="es-PE" sz="1050">
-                          <a:latin typeface="Calibri"/>
-                        </a:rPr>
-                        <a:t>765</a:t>
-                      </a:r>
-                    </a:p>
-                  </a:txBody>
-                  <a:tcPr>
-                    <a:solidFill>
-                      <a:srgbClr val="FFFFFF"/>
-                    </a:solidFill>
-                  </a:tcPr>
-                </a:tc>
-                <a:tc>
-                  <a:txBody>
-                    <a:bodyPr/>
-                    <a:lstStyle/>
-                    <a:p>
-                      <a:r>
-                        <a:rPr lang="es-PE" sz="1050">
-                          <a:latin typeface="Calibri"/>
-                        </a:rPr>
-                        <a:t>14 h 56 min</a:t>
-                      </a:r>
-                    </a:p>
-                  </a:txBody>
-                  <a:tcPr>
-                    <a:solidFill>
-                      <a:srgbClr val="FFFFFF"/>
-                    </a:solidFill>
-                  </a:tcPr>
-                </a:tc>
-                <a:tc>
-                  <a:txBody>
-                    <a:bodyPr/>
-                    <a:lstStyle/>
-                    <a:p>
-                      <a:r>
-                        <a:rPr lang="es-PE" sz="1050">
-                          <a:latin typeface="Calibri"/>
-                        </a:rPr>
-                        <a:t>costa / llano</a:t>
+                        <a:t>48</a:t>
+                      </a:r>
+                    </a:p>
+                  </a:txBody>
+                  <a:tcPr>
+                    <a:solidFill>
+                      <a:srgbClr val="FFFFFF"/>
+                    </a:solidFill>
+                  </a:tcPr>
+                </a:tc>
+                <a:tc>
+                  <a:txBody>
+                    <a:bodyPr/>
+                    <a:lstStyle/>
+                    <a:p>
+                      <a:r>
+                        <a:rPr lang="es-PE" sz="1050">
+                          <a:latin typeface="Calibri"/>
+                        </a:rPr>
+                        <a:t>Hospital Antonio Lorena d…</a:t>
+                      </a:r>
+                    </a:p>
+                  </a:txBody>
+                  <a:tcPr>
+                    <a:solidFill>
+                      <a:srgbClr val="FFFFFF"/>
+                    </a:solidFill>
+                  </a:tcPr>
+                </a:tc>
+                <a:tc>
+                  <a:txBody>
+                    <a:bodyPr/>
+                    <a:lstStyle/>
+                    <a:p>
+                      <a:r>
+                        <a:rPr lang="es-PE" sz="1050">
+                          <a:latin typeface="Calibri"/>
+                        </a:rPr>
+                        <a:t>QUILLABAMBA-ESSALUD</a:t>
+                      </a:r>
+                    </a:p>
+                  </a:txBody>
+                  <a:tcPr>
+                    <a:solidFill>
+                      <a:srgbClr val="FFFFFF"/>
+                    </a:solidFill>
+                  </a:tcPr>
+                </a:tc>
+                <a:tc>
+                  <a:txBody>
+                    <a:bodyPr/>
+                    <a:lstStyle/>
+                    <a:p>
+                      <a:r>
+                        <a:rPr lang="es-PE" sz="1050">
+                          <a:latin typeface="Calibri"/>
+                        </a:rPr>
+                        <a:t>202</a:t>
+                      </a:r>
+                    </a:p>
+                  </a:txBody>
+                  <a:tcPr>
+                    <a:solidFill>
+                      <a:srgbClr val="FFFFFF"/>
+                    </a:solidFill>
+                  </a:tcPr>
+                </a:tc>
+                <a:tc>
+                  <a:txBody>
+                    <a:bodyPr/>
+                    <a:lstStyle/>
+                    <a:p>
+                      <a:r>
+                        <a:rPr lang="es-PE" sz="1050">
+                          <a:latin typeface="Calibri"/>
+                        </a:rPr>
+                        <a:t>6 h 57 min</a:t>
+                      </a:r>
+                    </a:p>
+                  </a:txBody>
+                  <a:tcPr>
+                    <a:solidFill>
+                      <a:srgbClr val="FFFFFF"/>
+                    </a:solidFill>
+                  </a:tcPr>
+                </a:tc>
+                <a:tc>
+                  <a:txBody>
+                    <a:bodyPr/>
+                    <a:lstStyle/>
+                    <a:p>
+                      <a:r>
+                        <a:rPr lang="es-PE" sz="1050">
+                          <a:latin typeface="Calibri"/>
+                        </a:rPr>
+                        <a:t>sierra alta sostenida</a:t>
                       </a:r>
                     </a:p>
                   </a:txBody>
@@ -2130,102 +2130,102 @@
                         <a:rPr lang="es-PE" sz="1050">
                           <a:latin typeface="Calibri"/>
                         </a:rPr>
-                        <a:t>100</a:t>
-                      </a:r>
-                    </a:p>
-                  </a:txBody>
-                  <a:tcPr>
-                    <a:solidFill>
-                      <a:srgbClr val="EEF1F6"/>
-                    </a:solidFill>
-                  </a:tcPr>
-                </a:tc>
-                <a:tc>
-                  <a:txBody>
-                    <a:bodyPr/>
-                    <a:lstStyle/>
-                    <a:p>
-                      <a:r>
-                        <a:rPr lang="es-PE" sz="1050">
-                          <a:latin typeface="Calibri"/>
-                        </a:rPr>
-                        <a:t>HOSPITAL REGIONAL DOCENTE…</a:t>
-                      </a:r>
-                    </a:p>
-                  </a:txBody>
-                  <a:tcPr>
-                    <a:solidFill>
-                      <a:srgbClr val="EEF1F6"/>
-                    </a:solidFill>
-                  </a:tcPr>
-                </a:tc>
-                <a:tc>
-                  <a:txBody>
-                    <a:bodyPr/>
-                    <a:lstStyle/>
-                    <a:p>
-                      <a:r>
-                        <a:rPr lang="es-PE" sz="1050">
-                          <a:latin typeface="Calibri"/>
-                        </a:rPr>
-                        <a:t>CLINICA CAMINO REAL</a:t>
-                      </a:r>
-                    </a:p>
-                  </a:txBody>
-                  <a:tcPr>
-                    <a:solidFill>
-                      <a:srgbClr val="EEF1F6"/>
-                    </a:solidFill>
-                  </a:tcPr>
-                </a:tc>
-                <a:tc>
-                  <a:txBody>
-                    <a:bodyPr/>
-                    <a:lstStyle/>
-                    <a:p>
-                      <a:r>
-                        <a:rPr lang="es-PE" sz="1050">
-                          <a:latin typeface="Calibri"/>
-                        </a:rPr>
-                        <a:t>559</a:t>
-                      </a:r>
-                    </a:p>
-                  </a:txBody>
-                  <a:tcPr>
-                    <a:solidFill>
-                      <a:srgbClr val="EEF1F6"/>
-                    </a:solidFill>
-                  </a:tcPr>
-                </a:tc>
-                <a:tc>
-                  <a:txBody>
-                    <a:bodyPr/>
-                    <a:lstStyle/>
-                    <a:p>
-                      <a:r>
-                        <a:rPr lang="es-PE" sz="1050">
-                          <a:latin typeface="Calibri"/>
-                        </a:rPr>
-                        <a:t>10 h 22 min</a:t>
-                      </a:r>
-                    </a:p>
-                  </a:txBody>
-                  <a:tcPr>
-                    <a:solidFill>
-                      <a:srgbClr val="EEF1F6"/>
-                    </a:solidFill>
-                  </a:tcPr>
-                </a:tc>
-                <a:tc>
-                  <a:txBody>
-                    <a:bodyPr/>
-                    <a:lstStyle/>
-                    <a:p>
-                      <a:r>
-                        <a:rPr lang="es-PE" sz="1050">
-                          <a:latin typeface="Calibri"/>
-                        </a:rPr>
-                        <a:t>costa / llano</a:t>
+                        <a:t>57</a:t>
+                      </a:r>
+                    </a:p>
+                  </a:txBody>
+                  <a:tcPr>
+                    <a:solidFill>
+                      <a:srgbClr val="EEF1F6"/>
+                    </a:solidFill>
+                  </a:tcPr>
+                </a:tc>
+                <a:tc>
+                  <a:txBody>
+                    <a:bodyPr/>
+                    <a:lstStyle/>
+                    <a:p>
+                      <a:r>
+                        <a:rPr lang="es-PE" sz="1050">
+                          <a:latin typeface="Calibri"/>
+                        </a:rPr>
+                        <a:t>Hospital Antonio Lorena d…</a:t>
+                      </a:r>
+                    </a:p>
+                  </a:txBody>
+                  <a:tcPr>
+                    <a:solidFill>
+                      <a:srgbClr val="EEF1F6"/>
+                    </a:solidFill>
+                  </a:tcPr>
+                </a:tc>
+                <a:tc>
+                  <a:txBody>
+                    <a:bodyPr/>
+                    <a:lstStyle/>
+                    <a:p>
+                      <a:r>
+                        <a:rPr lang="es-PE" sz="1050">
+                          <a:latin typeface="Calibri"/>
+                        </a:rPr>
+                        <a:t>SR DE TORRECHAYOC</a:t>
+                      </a:r>
+                    </a:p>
+                  </a:txBody>
+                  <a:tcPr>
+                    <a:solidFill>
+                      <a:srgbClr val="EEF1F6"/>
+                    </a:solidFill>
+                  </a:tcPr>
+                </a:tc>
+                <a:tc>
+                  <a:txBody>
+                    <a:bodyPr/>
+                    <a:lstStyle/>
+                    <a:p>
+                      <a:r>
+                        <a:rPr lang="es-PE" sz="1050">
+                          <a:latin typeface="Calibri"/>
+                        </a:rPr>
+                        <a:t>202</a:t>
+                      </a:r>
+                    </a:p>
+                  </a:txBody>
+                  <a:tcPr>
+                    <a:solidFill>
+                      <a:srgbClr val="EEF1F6"/>
+                    </a:solidFill>
+                  </a:tcPr>
+                </a:tc>
+                <a:tc>
+                  <a:txBody>
+                    <a:bodyPr/>
+                    <a:lstStyle/>
+                    <a:p>
+                      <a:r>
+                        <a:rPr lang="es-PE" sz="1050">
+                          <a:latin typeface="Calibri"/>
+                        </a:rPr>
+                        <a:t>6 h 57 min</a:t>
+                      </a:r>
+                    </a:p>
+                  </a:txBody>
+                  <a:tcPr>
+                    <a:solidFill>
+                      <a:srgbClr val="EEF1F6"/>
+                    </a:solidFill>
+                  </a:tcPr>
+                </a:tc>
+                <a:tc>
+                  <a:txBody>
+                    <a:bodyPr/>
+                    <a:lstStyle/>
+                    <a:p>
+                      <a:r>
+                        <a:rPr lang="es-PE" sz="1050">
+                          <a:latin typeface="Calibri"/>
+                        </a:rPr>
+                        <a:t>sierra alta sostenida</a:t>
                       </a:r>
                     </a:p>
                   </a:txBody>
@@ -2251,7 +2251,7 @@
                         <a:rPr lang="es-PE" sz="1050">
                           <a:latin typeface="Calibri"/>
                         </a:rPr>
-                        <a:t>48</a:t>
+                        <a:t>49</a:t>
                       </a:r>
                     </a:p>
                   </a:txBody>
@@ -2289,45 +2289,45 @@
                         <a:rPr lang="es-PE" sz="1050">
                           <a:latin typeface="Calibri"/>
                         </a:rPr>
-                        <a:t>QUILLABAMBA-ESSALUD</a:t>
-                      </a:r>
-                    </a:p>
-                  </a:txBody>
-                  <a:tcPr>
-                    <a:solidFill>
-                      <a:srgbClr val="FFFFFF"/>
-                    </a:solidFill>
-                  </a:tcPr>
-                </a:tc>
-                <a:tc>
-                  <a:txBody>
-                    <a:bodyPr/>
-                    <a:lstStyle/>
-                    <a:p>
-                      <a:r>
-                        <a:rPr lang="es-PE" sz="1050">
-                          <a:latin typeface="Calibri"/>
-                        </a:rPr>
-                        <a:t>204</a:t>
-                      </a:r>
-                    </a:p>
-                  </a:txBody>
-                  <a:tcPr>
-                    <a:solidFill>
-                      <a:srgbClr val="FFFFFF"/>
-                    </a:solidFill>
-                  </a:tcPr>
-                </a:tc>
-                <a:tc>
-                  <a:txBody>
-                    <a:bodyPr/>
-                    <a:lstStyle/>
-                    <a:p>
-                      <a:r>
-                        <a:rPr lang="es-PE" sz="1050">
-                          <a:latin typeface="Calibri"/>
-                        </a:rPr>
-                        <a:t>7 h 04 min</a:t>
+                        <a:t>HOSPITAL DE ESPINAR</a:t>
+                      </a:r>
+                    </a:p>
+                  </a:txBody>
+                  <a:tcPr>
+                    <a:solidFill>
+                      <a:srgbClr val="FFFFFF"/>
+                    </a:solidFill>
+                  </a:tcPr>
+                </a:tc>
+                <a:tc>
+                  <a:txBody>
+                    <a:bodyPr/>
+                    <a:lstStyle/>
+                    <a:p>
+                      <a:r>
+                        <a:rPr lang="es-PE" sz="1050">
+                          <a:latin typeface="Calibri"/>
+                        </a:rPr>
+                        <a:t>221</a:t>
+                      </a:r>
+                    </a:p>
+                  </a:txBody>
+                  <a:tcPr>
+                    <a:solidFill>
+                      <a:srgbClr val="FFFFFF"/>
+                    </a:solidFill>
+                  </a:tcPr>
+                </a:tc>
+                <a:tc>
+                  <a:txBody>
+                    <a:bodyPr/>
+                    <a:lstStyle/>
+                    <a:p>
+                      <a:r>
+                        <a:rPr lang="es-PE" sz="1050">
+                          <a:latin typeface="Calibri"/>
+                        </a:rPr>
+                        <a:t>6 h 09 min</a:t>
                       </a:r>
                     </a:p>
                   </a:txBody>
@@ -2372,83 +2372,83 @@
                         <a:rPr lang="es-PE" sz="1050">
                           <a:latin typeface="Calibri"/>
                         </a:rPr>
-                        <a:t>57</a:t>
-                      </a:r>
-                    </a:p>
-                  </a:txBody>
-                  <a:tcPr>
-                    <a:solidFill>
-                      <a:srgbClr val="EEF1F6"/>
-                    </a:solidFill>
-                  </a:tcPr>
-                </a:tc>
-                <a:tc>
-                  <a:txBody>
-                    <a:bodyPr/>
-                    <a:lstStyle/>
-                    <a:p>
-                      <a:r>
-                        <a:rPr lang="es-PE" sz="1050">
-                          <a:latin typeface="Calibri"/>
-                        </a:rPr>
-                        <a:t>Hospital Antonio Lorena d…</a:t>
-                      </a:r>
-                    </a:p>
-                  </a:txBody>
-                  <a:tcPr>
-                    <a:solidFill>
-                      <a:srgbClr val="EEF1F6"/>
-                    </a:solidFill>
-                  </a:tcPr>
-                </a:tc>
-                <a:tc>
-                  <a:txBody>
-                    <a:bodyPr/>
-                    <a:lstStyle/>
-                    <a:p>
-                      <a:r>
-                        <a:rPr lang="es-PE" sz="1050">
-                          <a:latin typeface="Calibri"/>
-                        </a:rPr>
-                        <a:t>SR DE TORRECHAYOC</a:t>
-                      </a:r>
-                    </a:p>
-                  </a:txBody>
-                  <a:tcPr>
-                    <a:solidFill>
-                      <a:srgbClr val="EEF1F6"/>
-                    </a:solidFill>
-                  </a:tcPr>
-                </a:tc>
-                <a:tc>
-                  <a:txBody>
-                    <a:bodyPr/>
-                    <a:lstStyle/>
-                    <a:p>
-                      <a:r>
-                        <a:rPr lang="es-PE" sz="1050">
-                          <a:latin typeface="Calibri"/>
-                        </a:rPr>
-                        <a:t>203</a:t>
-                      </a:r>
-                    </a:p>
-                  </a:txBody>
-                  <a:tcPr>
-                    <a:solidFill>
-                      <a:srgbClr val="EEF1F6"/>
-                    </a:solidFill>
-                  </a:tcPr>
-                </a:tc>
-                <a:tc>
-                  <a:txBody>
-                    <a:bodyPr/>
-                    <a:lstStyle/>
-                    <a:p>
-                      <a:r>
-                        <a:rPr lang="es-PE" sz="1050">
-                          <a:latin typeface="Calibri"/>
-                        </a:rPr>
-                        <a:t>7 h 01 min</a:t>
+                        <a:t>40</a:t>
+                      </a:r>
+                    </a:p>
+                  </a:txBody>
+                  <a:tcPr>
+                    <a:solidFill>
+                      <a:srgbClr val="EEF1F6"/>
+                    </a:solidFill>
+                  </a:tcPr>
+                </a:tc>
+                <a:tc>
+                  <a:txBody>
+                    <a:bodyPr/>
+                    <a:lstStyle/>
+                    <a:p>
+                      <a:r>
+                        <a:rPr lang="es-PE" sz="1050">
+                          <a:latin typeface="Calibri"/>
+                        </a:rPr>
+                        <a:t>Hospital Regional de Ayac…</a:t>
+                      </a:r>
+                    </a:p>
+                  </a:txBody>
+                  <a:tcPr>
+                    <a:solidFill>
+                      <a:srgbClr val="EEF1F6"/>
+                    </a:solidFill>
+                  </a:tcPr>
+                </a:tc>
+                <a:tc>
+                  <a:txBody>
+                    <a:bodyPr/>
+                    <a:lstStyle/>
+                    <a:p>
+                      <a:r>
+                        <a:rPr lang="es-PE" sz="1050">
+                          <a:latin typeface="Calibri"/>
+                        </a:rPr>
+                        <a:t>SAN JUAN DE KIMBIRI-VRAEM</a:t>
+                      </a:r>
+                    </a:p>
+                  </a:txBody>
+                  <a:tcPr>
+                    <a:solidFill>
+                      <a:srgbClr val="EEF1F6"/>
+                    </a:solidFill>
+                  </a:tcPr>
+                </a:tc>
+                <a:tc>
+                  <a:txBody>
+                    <a:bodyPr/>
+                    <a:lstStyle/>
+                    <a:p>
+                      <a:r>
+                        <a:rPr lang="es-PE" sz="1050">
+                          <a:latin typeface="Calibri"/>
+                        </a:rPr>
+                        <a:t>186</a:t>
+                      </a:r>
+                    </a:p>
+                  </a:txBody>
+                  <a:tcPr>
+                    <a:solidFill>
+                      <a:srgbClr val="EEF1F6"/>
+                    </a:solidFill>
+                  </a:tcPr>
+                </a:tc>
+                <a:tc>
+                  <a:txBody>
+                    <a:bodyPr/>
+                    <a:lstStyle/>
+                    <a:p>
+                      <a:r>
+                        <a:rPr lang="es-PE" sz="1050">
+                          <a:latin typeface="Calibri"/>
+                        </a:rPr>
+                        <a:t>6 h 04 min</a:t>
                       </a:r>
                     </a:p>
                   </a:txBody>
@@ -2493,83 +2493,83 @@
                         <a:rPr lang="es-PE" sz="1050">
                           <a:latin typeface="Calibri"/>
                         </a:rPr>
-                        <a:t>49</a:t>
-                      </a:r>
-                    </a:p>
-                  </a:txBody>
-                  <a:tcPr>
-                    <a:solidFill>
-                      <a:srgbClr val="FFFFFF"/>
-                    </a:solidFill>
-                  </a:tcPr>
-                </a:tc>
-                <a:tc>
-                  <a:txBody>
-                    <a:bodyPr/>
-                    <a:lstStyle/>
-                    <a:p>
-                      <a:r>
-                        <a:rPr lang="es-PE" sz="1050">
-                          <a:latin typeface="Calibri"/>
-                        </a:rPr>
-                        <a:t>Hospital Antonio Lorena d…</a:t>
-                      </a:r>
-                    </a:p>
-                  </a:txBody>
-                  <a:tcPr>
-                    <a:solidFill>
-                      <a:srgbClr val="FFFFFF"/>
-                    </a:solidFill>
-                  </a:tcPr>
-                </a:tc>
-                <a:tc>
-                  <a:txBody>
-                    <a:bodyPr/>
-                    <a:lstStyle/>
-                    <a:p>
-                      <a:r>
-                        <a:rPr lang="es-PE" sz="1050">
-                          <a:latin typeface="Calibri"/>
-                        </a:rPr>
-                        <a:t>HOSPITAL DE ESPINAR</a:t>
-                      </a:r>
-                    </a:p>
-                  </a:txBody>
-                  <a:tcPr>
-                    <a:solidFill>
-                      <a:srgbClr val="FFFFFF"/>
-                    </a:solidFill>
-                  </a:tcPr>
-                </a:tc>
-                <a:tc>
-                  <a:txBody>
-                    <a:bodyPr/>
-                    <a:lstStyle/>
-                    <a:p>
-                      <a:r>
-                        <a:rPr lang="es-PE" sz="1050">
-                          <a:latin typeface="Calibri"/>
-                        </a:rPr>
-                        <a:t>222</a:t>
-                      </a:r>
-                    </a:p>
-                  </a:txBody>
-                  <a:tcPr>
-                    <a:solidFill>
-                      <a:srgbClr val="FFFFFF"/>
-                    </a:solidFill>
-                  </a:tcPr>
-                </a:tc>
-                <a:tc>
-                  <a:txBody>
-                    <a:bodyPr/>
-                    <a:lstStyle/>
-                    <a:p>
-                      <a:r>
-                        <a:rPr lang="es-PE" sz="1050">
-                          <a:latin typeface="Calibri"/>
-                        </a:rPr>
-                        <a:t>6 h 12 min</a:t>
+                        <a:t>241</a:t>
+                      </a:r>
+                    </a:p>
+                  </a:txBody>
+                  <a:tcPr>
+                    <a:solidFill>
+                      <a:srgbClr val="FFFFFF"/>
+                    </a:solidFill>
+                  </a:tcPr>
+                </a:tc>
+                <a:tc>
+                  <a:txBody>
+                    <a:bodyPr/>
+                    <a:lstStyle/>
+                    <a:p>
+                      <a:r>
+                        <a:rPr lang="es-PE" sz="1050">
+                          <a:latin typeface="Calibri"/>
+                        </a:rPr>
+                        <a:t>HOSPITAL II PASCO</a:t>
+                      </a:r>
+                    </a:p>
+                  </a:txBody>
+                  <a:tcPr>
+                    <a:solidFill>
+                      <a:srgbClr val="FFFFFF"/>
+                    </a:solidFill>
+                  </a:tcPr>
+                </a:tc>
+                <a:tc>
+                  <a:txBody>
+                    <a:bodyPr/>
+                    <a:lstStyle/>
+                    <a:p>
+                      <a:r>
+                        <a:rPr lang="es-PE" sz="1050">
+                          <a:latin typeface="Calibri"/>
+                        </a:rPr>
+                        <a:t>HOSPITAL I OXAPAMPA</a:t>
+                      </a:r>
+                    </a:p>
+                  </a:txBody>
+                  <a:tcPr>
+                    <a:solidFill>
+                      <a:srgbClr val="FFFFFF"/>
+                    </a:solidFill>
+                  </a:tcPr>
+                </a:tc>
+                <a:tc>
+                  <a:txBody>
+                    <a:bodyPr/>
+                    <a:lstStyle/>
+                    <a:p>
+                      <a:r>
+                        <a:rPr lang="es-PE" sz="1050">
+                          <a:latin typeface="Calibri"/>
+                        </a:rPr>
+                        <a:t>175</a:t>
+                      </a:r>
+                    </a:p>
+                  </a:txBody>
+                  <a:tcPr>
+                    <a:solidFill>
+                      <a:srgbClr val="FFFFFF"/>
+                    </a:solidFill>
+                  </a:tcPr>
+                </a:tc>
+                <a:tc>
+                  <a:txBody>
+                    <a:bodyPr/>
+                    <a:lstStyle/>
+                    <a:p>
+                      <a:r>
+                        <a:rPr lang="es-PE" sz="1050">
+                          <a:latin typeface="Calibri"/>
+                        </a:rPr>
+                        <a:t>6 h 02 min</a:t>
                       </a:r>
                     </a:p>
                   </a:txBody>
@@ -2614,83 +2614,83 @@
                         <a:rPr lang="es-PE" sz="1050">
                           <a:latin typeface="Calibri"/>
                         </a:rPr>
-                        <a:t>241</a:t>
-                      </a:r>
-                    </a:p>
-                  </a:txBody>
-                  <a:tcPr>
-                    <a:solidFill>
-                      <a:srgbClr val="EEF1F6"/>
-                    </a:solidFill>
-                  </a:tcPr>
-                </a:tc>
-                <a:tc>
-                  <a:txBody>
-                    <a:bodyPr/>
-                    <a:lstStyle/>
-                    <a:p>
-                      <a:r>
-                        <a:rPr lang="es-PE" sz="1050">
-                          <a:latin typeface="Calibri"/>
-                        </a:rPr>
-                        <a:t>HOSPITAL II PASCO</a:t>
-                      </a:r>
-                    </a:p>
-                  </a:txBody>
-                  <a:tcPr>
-                    <a:solidFill>
-                      <a:srgbClr val="EEF1F6"/>
-                    </a:solidFill>
-                  </a:tcPr>
-                </a:tc>
-                <a:tc>
-                  <a:txBody>
-                    <a:bodyPr/>
-                    <a:lstStyle/>
-                    <a:p>
-                      <a:r>
-                        <a:rPr lang="es-PE" sz="1050">
-                          <a:latin typeface="Calibri"/>
-                        </a:rPr>
-                        <a:t>HOSPITAL I OXAPAMPA</a:t>
-                      </a:r>
-                    </a:p>
-                  </a:txBody>
-                  <a:tcPr>
-                    <a:solidFill>
-                      <a:srgbClr val="EEF1F6"/>
-                    </a:solidFill>
-                  </a:tcPr>
-                </a:tc>
-                <a:tc>
-                  <a:txBody>
-                    <a:bodyPr/>
-                    <a:lstStyle/>
-                    <a:p>
-                      <a:r>
-                        <a:rPr lang="es-PE" sz="1050">
-                          <a:latin typeface="Calibri"/>
-                        </a:rPr>
-                        <a:t>176</a:t>
-                      </a:r>
-                    </a:p>
-                  </a:txBody>
-                  <a:tcPr>
-                    <a:solidFill>
-                      <a:srgbClr val="EEF1F6"/>
-                    </a:solidFill>
-                  </a:tcPr>
-                </a:tc>
-                <a:tc>
-                  <a:txBody>
-                    <a:bodyPr/>
-                    <a:lstStyle/>
-                    <a:p>
-                      <a:r>
-                        <a:rPr lang="es-PE" sz="1050">
-                          <a:latin typeface="Calibri"/>
-                        </a:rPr>
-                        <a:t>6 h 04 min</a:t>
+                        <a:t>41</a:t>
+                      </a:r>
+                    </a:p>
+                  </a:txBody>
+                  <a:tcPr>
+                    <a:solidFill>
+                      <a:srgbClr val="EEF1F6"/>
+                    </a:solidFill>
+                  </a:tcPr>
+                </a:tc>
+                <a:tc>
+                  <a:txBody>
+                    <a:bodyPr/>
+                    <a:lstStyle/>
+                    <a:p>
+                      <a:r>
+                        <a:rPr lang="es-PE" sz="1050">
+                          <a:latin typeface="Calibri"/>
+                        </a:rPr>
+                        <a:t>Hospital Regional de Ayac…</a:t>
+                      </a:r>
+                    </a:p>
+                  </a:txBody>
+                  <a:tcPr>
+                    <a:solidFill>
+                      <a:srgbClr val="EEF1F6"/>
+                    </a:solidFill>
+                  </a:tcPr>
+                </a:tc>
+                <a:tc>
+                  <a:txBody>
+                    <a:bodyPr/>
+                    <a:lstStyle/>
+                    <a:p>
+                      <a:r>
+                        <a:rPr lang="es-PE" sz="1050">
+                          <a:latin typeface="Calibri"/>
+                        </a:rPr>
+                        <a:t>HOSPITAL DE APOYO SAN FRA…</a:t>
+                      </a:r>
+                    </a:p>
+                  </a:txBody>
+                  <a:tcPr>
+                    <a:solidFill>
+                      <a:srgbClr val="EEF1F6"/>
+                    </a:solidFill>
+                  </a:tcPr>
+                </a:tc>
+                <a:tc>
+                  <a:txBody>
+                    <a:bodyPr/>
+                    <a:lstStyle/>
+                    <a:p>
+                      <a:r>
+                        <a:rPr lang="es-PE" sz="1050">
+                          <a:latin typeface="Calibri"/>
+                        </a:rPr>
+                        <a:t>175</a:t>
+                      </a:r>
+                    </a:p>
+                  </a:txBody>
+                  <a:tcPr>
+                    <a:solidFill>
+                      <a:srgbClr val="EEF1F6"/>
+                    </a:solidFill>
+                  </a:tcPr>
+                </a:tc>
+                <a:tc>
+                  <a:txBody>
+                    <a:bodyPr/>
+                    <a:lstStyle/>
+                    <a:p>
+                      <a:r>
+                        <a:rPr lang="es-PE" sz="1050">
+                          <a:latin typeface="Calibri"/>
+                        </a:rPr>
+                        <a:t>5 h 25 min</a:t>
                       </a:r>
                     </a:p>
                   </a:txBody>
@@ -2787,7 +2787,7 @@
                 </a:solidFill>
                 <a:latin typeface="Calibri"/>
               </a:rPr>
-              <a:t>Via aerea - 20 convenios con opcion aerea (por tiempo)</a:t>
+              <a:t>Via aerea - 18 convenios con opcion aerea (por tiempo)</a:t>
             </a:r>
             <a:endParaRPr lang="es-PE" sz="2600"/>
           </a:p>
@@ -2995,7 +2995,7 @@
                         <a:rPr lang="es-PE" sz="1050">
                           <a:latin typeface="Calibri"/>
                         </a:rPr>
-                        <a:t>Juliaca (JUL) -&gt; LIM -&gt; Jaen (JAE)</a:t>
+                        <a:t>Juliaca (JUL) -&gt; LIM -&gt; Jaén (JAE)</a:t>
                       </a:r>
                     </a:p>
                   </a:txBody>
@@ -3033,7 +3033,7 @@
                         <a:rPr lang="es-PE" sz="1050">
                           <a:latin typeface="Calibri"/>
                         </a:rPr>
-                        <a:t>9 h 45 min</a:t>
+                        <a:t>9 h 08 min</a:t>
                       </a:r>
                     </a:p>
                   </a:txBody>
@@ -3078,83 +3078,83 @@
                         <a:rPr lang="es-PE" sz="1050">
                           <a:latin typeface="Calibri"/>
                         </a:rPr>
-                        <a:t>177</a:t>
-                      </a:r>
-                    </a:p>
-                  </a:txBody>
-                  <a:tcPr>
-                    <a:solidFill>
-                      <a:srgbClr val="EEF1F6"/>
-                    </a:solidFill>
-                  </a:tcPr>
-                </a:tc>
-                <a:tc>
-                  <a:txBody>
-                    <a:bodyPr/>
-                    <a:lstStyle/>
-                    <a:p>
-                      <a:r>
-                        <a:rPr lang="es-PE" sz="1050">
-                          <a:latin typeface="Calibri"/>
-                        </a:rPr>
-                        <a:t>Lima (LIM) -&gt; Huaraz (ATA)</a:t>
-                      </a:r>
-                    </a:p>
-                  </a:txBody>
-                  <a:tcPr>
-                    <a:solidFill>
-                      <a:srgbClr val="EEF1F6"/>
-                    </a:solidFill>
-                  </a:tcPr>
-                </a:tc>
-                <a:tc>
-                  <a:txBody>
-                    <a:bodyPr/>
-                    <a:lstStyle/>
-                    <a:p>
-                      <a:r>
-                        <a:rPr lang="es-PE" sz="1050">
-                          <a:latin typeface="Calibri"/>
-                        </a:rPr>
-                        <a:t>302</a:t>
-                      </a:r>
-                    </a:p>
-                  </a:txBody>
-                  <a:tcPr>
-                    <a:solidFill>
-                      <a:srgbClr val="EEF1F6"/>
-                    </a:solidFill>
-                  </a:tcPr>
-                </a:tc>
-                <a:tc>
-                  <a:txBody>
-                    <a:bodyPr/>
-                    <a:lstStyle/>
-                    <a:p>
-                      <a:r>
-                        <a:rPr lang="es-PE" sz="1050">
-                          <a:latin typeface="Calibri"/>
-                        </a:rPr>
-                        <a:t>9 h 34 min</a:t>
-                      </a:r>
-                    </a:p>
-                  </a:txBody>
-                  <a:tcPr>
-                    <a:solidFill>
-                      <a:srgbClr val="EEF1F6"/>
-                    </a:solidFill>
-                  </a:tcPr>
-                </a:tc>
-                <a:tc>
-                  <a:txBody>
-                    <a:bodyPr/>
-                    <a:lstStyle/>
-                    <a:p>
-                      <a:r>
-                        <a:rPr lang="es-PE" sz="1050">
-                          <a:latin typeface="Calibri"/>
-                        </a:rPr>
-                        <a:t>HOSPITAL BARRANCA CAJAT…</a:t>
+                        <a:t>69</a:t>
+                      </a:r>
+                    </a:p>
+                  </a:txBody>
+                  <a:tcPr>
+                    <a:solidFill>
+                      <a:srgbClr val="EEF1F6"/>
+                    </a:solidFill>
+                  </a:tcPr>
+                </a:tc>
+                <a:tc>
+                  <a:txBody>
+                    <a:bodyPr/>
+                    <a:lstStyle/>
+                    <a:p>
+                      <a:r>
+                        <a:rPr lang="es-PE" sz="1050">
+                          <a:latin typeface="Calibri"/>
+                        </a:rPr>
+                        <a:t>Jauja (JAU) -&gt; LIM -&gt; Ayacucho (AYP)</a:t>
+                      </a:r>
+                    </a:p>
+                  </a:txBody>
+                  <a:tcPr>
+                    <a:solidFill>
+                      <a:srgbClr val="EEF1F6"/>
+                    </a:solidFill>
+                  </a:tcPr>
+                </a:tc>
+                <a:tc>
+                  <a:txBody>
+                    <a:bodyPr/>
+                    <a:lstStyle/>
+                    <a:p>
+                      <a:r>
+                        <a:rPr lang="es-PE" sz="1050">
+                          <a:latin typeface="Calibri"/>
+                        </a:rPr>
+                        <a:t>520</a:t>
+                      </a:r>
+                    </a:p>
+                  </a:txBody>
+                  <a:tcPr>
+                    <a:solidFill>
+                      <a:srgbClr val="EEF1F6"/>
+                    </a:solidFill>
+                  </a:tcPr>
+                </a:tc>
+                <a:tc>
+                  <a:txBody>
+                    <a:bodyPr/>
+                    <a:lstStyle/>
+                    <a:p>
+                      <a:r>
+                        <a:rPr lang="es-PE" sz="1050">
+                          <a:latin typeface="Calibri"/>
+                        </a:rPr>
+                        <a:t>7 h 49 min</a:t>
+                      </a:r>
+                    </a:p>
+                  </a:txBody>
+                  <a:tcPr>
+                    <a:solidFill>
+                      <a:srgbClr val="EEF1F6"/>
+                    </a:solidFill>
+                  </a:tcPr>
+                </a:tc>
+                <a:tc>
+                  <a:txBody>
+                    <a:bodyPr/>
+                    <a:lstStyle/>
+                    <a:p>
+                      <a:r>
+                        <a:rPr lang="es-PE" sz="1050">
+                          <a:latin typeface="Calibri"/>
+                        </a:rPr>
+                        <a:t>HOSPITAL DE LIRCAY</a:t>
                       </a:r>
                     </a:p>
                   </a:txBody>
@@ -3237,7 +3237,7 @@
                         <a:rPr lang="es-PE" sz="1050">
                           <a:latin typeface="Calibri"/>
                         </a:rPr>
-                        <a:t>8 h 04 min</a:t>
+                        <a:t>7 h 42 min</a:t>
                       </a:r>
                     </a:p>
                   </a:txBody>
@@ -3282,7 +3282,7 @@
                         <a:rPr lang="es-PE" sz="1050">
                           <a:latin typeface="Calibri"/>
                         </a:rPr>
-                        <a:t>69</a:t>
+                        <a:t>68</a:t>
                       </a:r>
                     </a:p>
                   </a:txBody>
@@ -3339,26 +3339,26 @@
                         <a:rPr lang="es-PE" sz="1050">
                           <a:latin typeface="Calibri"/>
                         </a:rPr>
-                        <a:t>7 h 06 min</a:t>
-                      </a:r>
-                    </a:p>
-                  </a:txBody>
-                  <a:tcPr>
-                    <a:solidFill>
-                      <a:srgbClr val="EEF1F6"/>
-                    </a:solidFill>
-                  </a:tcPr>
-                </a:tc>
-                <a:tc>
-                  <a:txBody>
-                    <a:bodyPr/>
-                    <a:lstStyle/>
-                    <a:p>
-                      <a:r>
-                        <a:rPr lang="es-PE" sz="1050">
-                          <a:latin typeface="Calibri"/>
-                        </a:rPr>
-                        <a:t>HOSPITAL DE LIRCAY</a:t>
+                        <a:t>7 h 34 min</a:t>
+                      </a:r>
+                    </a:p>
+                  </a:txBody>
+                  <a:tcPr>
+                    <a:solidFill>
+                      <a:srgbClr val="EEF1F6"/>
+                    </a:solidFill>
+                  </a:tcPr>
+                </a:tc>
+                <a:tc>
+                  <a:txBody>
+                    <a:bodyPr/>
+                    <a:lstStyle/>
+                    <a:p>
+                      <a:r>
+                        <a:rPr lang="es-PE" sz="1050">
+                          <a:latin typeface="Calibri"/>
+                        </a:rPr>
+                        <a:t>HOSPITAL PROVINCIAL DE…</a:t>
                       </a:r>
                     </a:p>
                   </a:txBody>
@@ -3384,83 +3384,83 @@
                         <a:rPr lang="es-PE" sz="1050">
                           <a:latin typeface="Calibri"/>
                         </a:rPr>
-                        <a:t>102</a:t>
-                      </a:r>
-                    </a:p>
-                  </a:txBody>
-                  <a:tcPr>
-                    <a:solidFill>
-                      <a:srgbClr val="FFFFFF"/>
-                    </a:solidFill>
-                  </a:tcPr>
-                </a:tc>
-                <a:tc>
-                  <a:txBody>
-                    <a:bodyPr/>
-                    <a:lstStyle/>
-                    <a:p>
-                      <a:r>
-                        <a:rPr lang="es-PE" sz="1050">
-                          <a:latin typeface="Calibri"/>
-                        </a:rPr>
-                        <a:t>Trujillo (TRU) -&gt; LIM -&gt; Chiclayo (CIX)</a:t>
-                      </a:r>
-                    </a:p>
-                  </a:txBody>
-                  <a:tcPr>
-                    <a:solidFill>
-                      <a:srgbClr val="FFFFFF"/>
-                    </a:solidFill>
-                  </a:tcPr>
-                </a:tc>
-                <a:tc>
-                  <a:txBody>
-                    <a:bodyPr/>
-                    <a:lstStyle/>
-                    <a:p>
-                      <a:r>
-                        <a:rPr lang="es-PE" sz="1050">
-                          <a:latin typeface="Calibri"/>
-                        </a:rPr>
-                        <a:t>1,143</a:t>
-                      </a:r>
-                    </a:p>
-                  </a:txBody>
-                  <a:tcPr>
-                    <a:solidFill>
-                      <a:srgbClr val="FFFFFF"/>
-                    </a:solidFill>
-                  </a:tcPr>
-                </a:tc>
-                <a:tc>
-                  <a:txBody>
-                    <a:bodyPr/>
-                    <a:lstStyle/>
-                    <a:p>
-                      <a:r>
-                        <a:rPr lang="es-PE" sz="1050">
-                          <a:latin typeface="Calibri"/>
-                        </a:rPr>
-                        <a:t>6 h 57 min</a:t>
-                      </a:r>
-                    </a:p>
-                  </a:txBody>
-                  <a:tcPr>
-                    <a:solidFill>
-                      <a:srgbClr val="FFFFFF"/>
-                    </a:solidFill>
-                  </a:tcPr>
-                </a:tc>
-                <a:tc>
-                  <a:txBody>
-                    <a:bodyPr/>
-                    <a:lstStyle/>
-                    <a:p>
-                      <a:r>
-                        <a:rPr lang="es-PE" sz="1050">
-                          <a:latin typeface="Calibri"/>
-                        </a:rPr>
-                        <a:t>HOSPITAL TOMAS LA FORA</a:t>
+                        <a:t>177</a:t>
+                      </a:r>
+                    </a:p>
+                  </a:txBody>
+                  <a:tcPr>
+                    <a:solidFill>
+                      <a:srgbClr val="FFFFFF"/>
+                    </a:solidFill>
+                  </a:tcPr>
+                </a:tc>
+                <a:tc>
+                  <a:txBody>
+                    <a:bodyPr/>
+                    <a:lstStyle/>
+                    <a:p>
+                      <a:r>
+                        <a:rPr lang="es-PE" sz="1050">
+                          <a:latin typeface="Calibri"/>
+                        </a:rPr>
+                        <a:t>Lima (LIM) -&gt; Huaraz (Anta) (ATA)</a:t>
+                      </a:r>
+                    </a:p>
+                  </a:txBody>
+                  <a:tcPr>
+                    <a:solidFill>
+                      <a:srgbClr val="FFFFFF"/>
+                    </a:solidFill>
+                  </a:tcPr>
+                </a:tc>
+                <a:tc>
+                  <a:txBody>
+                    <a:bodyPr/>
+                    <a:lstStyle/>
+                    <a:p>
+                      <a:r>
+                        <a:rPr lang="es-PE" sz="1050">
+                          <a:latin typeface="Calibri"/>
+                        </a:rPr>
+                        <a:t>302</a:t>
+                      </a:r>
+                    </a:p>
+                  </a:txBody>
+                  <a:tcPr>
+                    <a:solidFill>
+                      <a:srgbClr val="FFFFFF"/>
+                    </a:solidFill>
+                  </a:tcPr>
+                </a:tc>
+                <a:tc>
+                  <a:txBody>
+                    <a:bodyPr/>
+                    <a:lstStyle/>
+                    <a:p>
+                      <a:r>
+                        <a:rPr lang="es-PE" sz="1050">
+                          <a:latin typeface="Calibri"/>
+                        </a:rPr>
+                        <a:t>7 h 10 min</a:t>
+                      </a:r>
+                    </a:p>
+                  </a:txBody>
+                  <a:tcPr>
+                    <a:solidFill>
+                      <a:srgbClr val="FFFFFF"/>
+                    </a:solidFill>
+                  </a:tcPr>
+                </a:tc>
+                <a:tc>
+                  <a:txBody>
+                    <a:bodyPr/>
+                    <a:lstStyle/>
+                    <a:p>
+                      <a:r>
+                        <a:rPr lang="es-PE" sz="1050">
+                          <a:latin typeface="Calibri"/>
+                        </a:rPr>
+                        <a:t>HOSPITAL BARRANCA CAJAT…</a:t>
                       </a:r>
                     </a:p>
                   </a:txBody>
@@ -3486,83 +3486,83 @@
                         <a:rPr lang="es-PE" sz="1050">
                           <a:latin typeface="Calibri"/>
                         </a:rPr>
-                        <a:t>68</a:t>
-                      </a:r>
-                    </a:p>
-                  </a:txBody>
-                  <a:tcPr>
-                    <a:solidFill>
-                      <a:srgbClr val="EEF1F6"/>
-                    </a:solidFill>
-                  </a:tcPr>
-                </a:tc>
-                <a:tc>
-                  <a:txBody>
-                    <a:bodyPr/>
-                    <a:lstStyle/>
-                    <a:p>
-                      <a:r>
-                        <a:rPr lang="es-PE" sz="1050">
-                          <a:latin typeface="Calibri"/>
-                        </a:rPr>
-                        <a:t>Jauja (JAU) -&gt; LIM -&gt; Ayacucho (AYP)</a:t>
-                      </a:r>
-                    </a:p>
-                  </a:txBody>
-                  <a:tcPr>
-                    <a:solidFill>
-                      <a:srgbClr val="EEF1F6"/>
-                    </a:solidFill>
-                  </a:tcPr>
-                </a:tc>
-                <a:tc>
-                  <a:txBody>
-                    <a:bodyPr/>
-                    <a:lstStyle/>
-                    <a:p>
-                      <a:r>
-                        <a:rPr lang="es-PE" sz="1050">
-                          <a:latin typeface="Calibri"/>
-                        </a:rPr>
-                        <a:t>520</a:t>
-                      </a:r>
-                    </a:p>
-                  </a:txBody>
-                  <a:tcPr>
-                    <a:solidFill>
-                      <a:srgbClr val="EEF1F6"/>
-                    </a:solidFill>
-                  </a:tcPr>
-                </a:tc>
-                <a:tc>
-                  <a:txBody>
-                    <a:bodyPr/>
-                    <a:lstStyle/>
-                    <a:p>
-                      <a:r>
-                        <a:rPr lang="es-PE" sz="1050">
-                          <a:latin typeface="Calibri"/>
-                        </a:rPr>
-                        <a:t>6 h 54 min</a:t>
-                      </a:r>
-                    </a:p>
-                  </a:txBody>
-                  <a:tcPr>
-                    <a:solidFill>
-                      <a:srgbClr val="EEF1F6"/>
-                    </a:solidFill>
-                  </a:tcPr>
-                </a:tc>
-                <a:tc>
-                  <a:txBody>
-                    <a:bodyPr/>
-                    <a:lstStyle/>
-                    <a:p>
-                      <a:r>
-                        <a:rPr lang="es-PE" sz="1050">
-                          <a:latin typeface="Calibri"/>
-                        </a:rPr>
-                        <a:t>HOSPITAL PROVINCIAL DE…</a:t>
+                        <a:t>102</a:t>
+                      </a:r>
+                    </a:p>
+                  </a:txBody>
+                  <a:tcPr>
+                    <a:solidFill>
+                      <a:srgbClr val="EEF1F6"/>
+                    </a:solidFill>
+                  </a:tcPr>
+                </a:tc>
+                <a:tc>
+                  <a:txBody>
+                    <a:bodyPr/>
+                    <a:lstStyle/>
+                    <a:p>
+                      <a:r>
+                        <a:rPr lang="es-PE" sz="1050">
+                          <a:latin typeface="Calibri"/>
+                        </a:rPr>
+                        <a:t>Trujillo (TRU) -&gt; LIM -&gt; Chiclayo (CIX)</a:t>
+                      </a:r>
+                    </a:p>
+                  </a:txBody>
+                  <a:tcPr>
+                    <a:solidFill>
+                      <a:srgbClr val="EEF1F6"/>
+                    </a:solidFill>
+                  </a:tcPr>
+                </a:tc>
+                <a:tc>
+                  <a:txBody>
+                    <a:bodyPr/>
+                    <a:lstStyle/>
+                    <a:p>
+                      <a:r>
+                        <a:rPr lang="es-PE" sz="1050">
+                          <a:latin typeface="Calibri"/>
+                        </a:rPr>
+                        <a:t>1,143</a:t>
+                      </a:r>
+                    </a:p>
+                  </a:txBody>
+                  <a:tcPr>
+                    <a:solidFill>
+                      <a:srgbClr val="EEF1F6"/>
+                    </a:solidFill>
+                  </a:tcPr>
+                </a:tc>
+                <a:tc>
+                  <a:txBody>
+                    <a:bodyPr/>
+                    <a:lstStyle/>
+                    <a:p>
+                      <a:r>
+                        <a:rPr lang="es-PE" sz="1050">
+                          <a:latin typeface="Calibri"/>
+                        </a:rPr>
+                        <a:t>6 h 31 min</a:t>
+                      </a:r>
+                    </a:p>
+                  </a:txBody>
+                  <a:tcPr>
+                    <a:solidFill>
+                      <a:srgbClr val="EEF1F6"/>
+                    </a:solidFill>
+                  </a:tcPr>
+                </a:tc>
+                <a:tc>
+                  <a:txBody>
+                    <a:bodyPr/>
+                    <a:lstStyle/>
+                    <a:p>
+                      <a:r>
+                        <a:rPr lang="es-PE" sz="1050">
+                          <a:latin typeface="Calibri"/>
+                        </a:rPr>
+                        <a:t>HOSPITAL TOMAS LA FORA</a:t>
                       </a:r>
                     </a:p>
                   </a:txBody>
@@ -3588,7 +3588,7 @@
                         <a:rPr lang="es-PE" sz="1050">
                           <a:latin typeface="Calibri"/>
                         </a:rPr>
-                        <a:t>274</a:t>
+                        <a:t>263</a:t>
                       </a:r>
                     </a:p>
                   </a:txBody>
@@ -3645,26 +3645,26 @@
                         <a:rPr lang="es-PE" sz="1050">
                           <a:latin typeface="Calibri"/>
                         </a:rPr>
-                        <a:t>5 h 45 min</a:t>
-                      </a:r>
-                    </a:p>
-                  </a:txBody>
-                  <a:tcPr>
-                    <a:solidFill>
-                      <a:srgbClr val="FFFFFF"/>
-                    </a:solidFill>
-                  </a:tcPr>
-                </a:tc>
-                <a:tc>
-                  <a:txBody>
-                    <a:bodyPr/>
-                    <a:lstStyle/>
-                    <a:p>
-                      <a:r>
-                        <a:rPr lang="es-PE" sz="1050">
-                          <a:latin typeface="Calibri"/>
-                        </a:rPr>
-                        <a:t>CENTRO MEDICO LUZ DIVINA</a:t>
+                        <a:t>5 h 35 min</a:t>
+                      </a:r>
+                    </a:p>
+                  </a:txBody>
+                  <a:tcPr>
+                    <a:solidFill>
+                      <a:srgbClr val="FFFFFF"/>
+                    </a:solidFill>
+                  </a:tcPr>
+                </a:tc>
+                <a:tc>
+                  <a:txBody>
+                    <a:bodyPr/>
+                    <a:lstStyle/>
+                    <a:p>
+                      <a:r>
+                        <a:rPr lang="es-PE" sz="1050">
+                          <a:latin typeface="Calibri"/>
+                        </a:rPr>
+                        <a:t>HOSPITAL MOYOBAMBA</a:t>
                       </a:r>
                     </a:p>
                   </a:txBody>
@@ -3690,83 +3690,83 @@
                         <a:rPr lang="es-PE" sz="1050">
                           <a:latin typeface="Calibri"/>
                         </a:rPr>
-                        <a:t>24</a:t>
-                      </a:r>
-                    </a:p>
-                  </a:txBody>
-                  <a:tcPr>
-                    <a:solidFill>
-                      <a:srgbClr val="EEF1F6"/>
-                    </a:solidFill>
-                  </a:tcPr>
-                </a:tc>
-                <a:tc>
-                  <a:txBody>
-                    <a:bodyPr/>
-                    <a:lstStyle/>
-                    <a:p>
-                      <a:r>
-                        <a:rPr lang="es-PE" sz="1050">
-                          <a:latin typeface="Calibri"/>
-                        </a:rPr>
-                        <a:t>Arequipa (AQP) -&gt; LIM -&gt; Piura (PIU)</a:t>
-                      </a:r>
-                    </a:p>
-                  </a:txBody>
-                  <a:tcPr>
-                    <a:solidFill>
-                      <a:srgbClr val="EEF1F6"/>
-                    </a:solidFill>
-                  </a:tcPr>
-                </a:tc>
-                <a:tc>
-                  <a:txBody>
-                    <a:bodyPr/>
-                    <a:lstStyle/>
-                    <a:p>
-                      <a:r>
-                        <a:rPr lang="es-PE" sz="1050">
-                          <a:latin typeface="Calibri"/>
-                        </a:rPr>
-                        <a:t>1,616</a:t>
-                      </a:r>
-                    </a:p>
-                  </a:txBody>
-                  <a:tcPr>
-                    <a:solidFill>
-                      <a:srgbClr val="EEF1F6"/>
-                    </a:solidFill>
-                  </a:tcPr>
-                </a:tc>
-                <a:tc>
-                  <a:txBody>
-                    <a:bodyPr/>
-                    <a:lstStyle/>
-                    <a:p>
-                      <a:r>
-                        <a:rPr lang="es-PE" sz="1050">
-                          <a:latin typeface="Calibri"/>
-                        </a:rPr>
-                        <a:t>5 h 43 min</a:t>
-                      </a:r>
-                    </a:p>
-                  </a:txBody>
-                  <a:tcPr>
-                    <a:solidFill>
-                      <a:srgbClr val="EEF1F6"/>
-                    </a:solidFill>
-                  </a:tcPr>
-                </a:tc>
-                <a:tc>
-                  <a:txBody>
-                    <a:bodyPr/>
-                    <a:lstStyle/>
-                    <a:p>
-                      <a:r>
-                        <a:rPr lang="es-PE" sz="1050">
-                          <a:latin typeface="Calibri"/>
-                        </a:rPr>
-                        <a:t>Hospital Militar Divisi…</a:t>
+                        <a:t>274</a:t>
+                      </a:r>
+                    </a:p>
+                  </a:txBody>
+                  <a:tcPr>
+                    <a:solidFill>
+                      <a:srgbClr val="EEF1F6"/>
+                    </a:solidFill>
+                  </a:tcPr>
+                </a:tc>
+                <a:tc>
+                  <a:txBody>
+                    <a:bodyPr/>
+                    <a:lstStyle/>
+                    <a:p>
+                      <a:r>
+                        <a:rPr lang="es-PE" sz="1050">
+                          <a:latin typeface="Calibri"/>
+                        </a:rPr>
+                        <a:t>Tarapoto (TPP) -&gt; LIM -&gt; Rioja (RIJ)</a:t>
+                      </a:r>
+                    </a:p>
+                  </a:txBody>
+                  <a:tcPr>
+                    <a:solidFill>
+                      <a:srgbClr val="EEF1F6"/>
+                    </a:solidFill>
+                  </a:tcPr>
+                </a:tc>
+                <a:tc>
+                  <a:txBody>
+                    <a:bodyPr/>
+                    <a:lstStyle/>
+                    <a:p>
+                      <a:r>
+                        <a:rPr lang="es-PE" sz="1050">
+                          <a:latin typeface="Calibri"/>
+                        </a:rPr>
+                        <a:t>1,280</a:t>
+                      </a:r>
+                    </a:p>
+                  </a:txBody>
+                  <a:tcPr>
+                    <a:solidFill>
+                      <a:srgbClr val="EEF1F6"/>
+                    </a:solidFill>
+                  </a:tcPr>
+                </a:tc>
+                <a:tc>
+                  <a:txBody>
+                    <a:bodyPr/>
+                    <a:lstStyle/>
+                    <a:p>
+                      <a:r>
+                        <a:rPr lang="es-PE" sz="1050">
+                          <a:latin typeface="Calibri"/>
+                        </a:rPr>
+                        <a:t>5 h 33 min</a:t>
+                      </a:r>
+                    </a:p>
+                  </a:txBody>
+                  <a:tcPr>
+                    <a:solidFill>
+                      <a:srgbClr val="EEF1F6"/>
+                    </a:solidFill>
+                  </a:tcPr>
+                </a:tc>
+                <a:tc>
+                  <a:txBody>
+                    <a:bodyPr/>
+                    <a:lstStyle/>
+                    <a:p>
+                      <a:r>
+                        <a:rPr lang="es-PE" sz="1050">
+                          <a:latin typeface="Calibri"/>
+                        </a:rPr>
+                        <a:t>CENTRO MEDICO LUZ DIVINA</a:t>
                       </a:r>
                     </a:p>
                   </a:txBody>
@@ -3792,7 +3792,7 @@
                         <a:rPr lang="es-PE" sz="1050">
                           <a:latin typeface="Calibri"/>
                         </a:rPr>
-                        <a:t>263</a:t>
+                        <a:t>269</a:t>
                       </a:r>
                     </a:p>
                   </a:txBody>
@@ -3849,26 +3849,26 @@
                         <a:rPr lang="es-PE" sz="1050">
                           <a:latin typeface="Calibri"/>
                         </a:rPr>
-                        <a:t>5 h 43 min</a:t>
-                      </a:r>
-                    </a:p>
-                  </a:txBody>
-                  <a:tcPr>
-                    <a:solidFill>
-                      <a:srgbClr val="FFFFFF"/>
-                    </a:solidFill>
-                  </a:tcPr>
-                </a:tc>
-                <a:tc>
-                  <a:txBody>
-                    <a:bodyPr/>
-                    <a:lstStyle/>
-                    <a:p>
-                      <a:r>
-                        <a:rPr lang="es-PE" sz="1050">
-                          <a:latin typeface="Calibri"/>
-                        </a:rPr>
-                        <a:t>HOSPITAL MOYOBAMBA</a:t>
+                        <a:t>5 h 29 min</a:t>
+                      </a:r>
+                    </a:p>
+                  </a:txBody>
+                  <a:tcPr>
+                    <a:solidFill>
+                      <a:srgbClr val="FFFFFF"/>
+                    </a:solidFill>
+                  </a:tcPr>
+                </a:tc>
+                <a:tc>
+                  <a:txBody>
+                    <a:bodyPr/>
+                    <a:lstStyle/>
+                    <a:p>
+                      <a:r>
+                        <a:rPr lang="es-PE" sz="1050">
+                          <a:latin typeface="Calibri"/>
+                        </a:rPr>
+                        <a:t>CLINICA YANTALO -</a:t>
                       </a:r>
                     </a:p>
                   </a:txBody>
@@ -3894,7 +3894,7 @@
                         <a:rPr lang="es-PE" sz="1050">
                           <a:latin typeface="Calibri"/>
                         </a:rPr>
-                        <a:t>269</a:t>
+                        <a:t>260</a:t>
                       </a:r>
                     </a:p>
                   </a:txBody>
@@ -3951,26 +3951,26 @@
                         <a:rPr lang="es-PE" sz="1050">
                           <a:latin typeface="Calibri"/>
                         </a:rPr>
-                        <a:t>5 h 29 min</a:t>
-                      </a:r>
-                    </a:p>
-                  </a:txBody>
-                  <a:tcPr>
-                    <a:solidFill>
-                      <a:srgbClr val="EEF1F6"/>
-                    </a:solidFill>
-                  </a:tcPr>
-                </a:tc>
-                <a:tc>
-                  <a:txBody>
-                    <a:bodyPr/>
-                    <a:lstStyle/>
-                    <a:p>
-                      <a:r>
-                        <a:rPr lang="es-PE" sz="1050">
-                          <a:latin typeface="Calibri"/>
-                        </a:rPr>
-                        <a:t>CLINICA YANTALO -</a:t>
+                        <a:t>5 h 10 min</a:t>
+                      </a:r>
+                    </a:p>
+                  </a:txBody>
+                  <a:tcPr>
+                    <a:solidFill>
+                      <a:srgbClr val="EEF1F6"/>
+                    </a:solidFill>
+                  </a:tcPr>
+                </a:tc>
+                <a:tc>
+                  <a:txBody>
+                    <a:bodyPr/>
+                    <a:lstStyle/>
+                    <a:p>
+                      <a:r>
+                        <a:rPr lang="es-PE" sz="1050">
+                          <a:latin typeface="Calibri"/>
+                        </a:rPr>
+                        <a:t>Nombre comercial: Centr…</a:t>
                       </a:r>
                     </a:p>
                   </a:txBody>
@@ -4088,7 +4088,7 @@
                 </a:solidFill>
                 <a:latin typeface="Calibri"/>
               </a:rPr>
-              <a:t>La via aerea solo se evalua cuando origen y destino usan aeropuertos distintos con servicio comercial; por eso solo 20 de 278 convenios la tienen.</a:t>
+              <a:t>La via aerea solo se evalua cuando origen y destino usan aeropuertos distintos con servicio comercial; por eso solo 18 de 278 convenios la tienen.</a:t>
             </a:r>
             <a:endParaRPr lang="es-PE" sz="1500"/>
           </a:p>
@@ -4104,7 +4104,7 @@
                 </a:solidFill>
                 <a:latin typeface="Calibri"/>
               </a:rPr>
-              <a:t>Rutas largas reales donde el avion es la opcion sensata: Arequipa-Piura (AQP-PIU, 5 h 43), Juliaca-Jaen (JUL-JAE, 9 h 45), Trujillo-Chiclayo via Lima (6 h 57).</a:t>
+              <a:t>Rutas largas reales donde el avion es la opcion sensata (el terrestre de la misma fila es varias veces mas largo): Juliaca-Jaen (JUL-JAE, 9 h 08 vs 2 d 5 h por tierra), Lima-Piura (LIM-PIU, 2 h 44-2 h 48 vs 18 h 20-18 h 21 por tierra), Lima-Arequipa (LIM-AQP, 3 h 06 vs 17 h 36), Lima-Chiclayo (LIM-CIX, 2 h 39 vs 14 h 56), Trujillo-Lima (TRU-LIM, 2 h 38 vs 10 h 24).</a:t>
             </a:r>
             <a:endParaRPr lang="es-PE" sz="1500"/>
           </a:p>
@@ -4120,7 +4120,7 @@
                 </a:solidFill>
                 <a:latin typeface="Calibri"/>
               </a:rPr>
-              <a:t>Casos con numero alto pero poco realistas (mismo eje vial, se resuelven mejor por carretera): Tarapoto-Rioja y Jauja-Ayacucho, forzados a escala en Lima por falta de vuelo directo; Lima-Huaraz (LIM-ATA) sale 9 h 34 por el traslado terrestre al aeropuerto de Anta.</a:t>
+              <a:t>Casos con numero alto pero poco realistas (el terrestre de la misma fila es mas corto: el aeropuerto mas cercano queda lejos o exige escala en Lima): Jauja-Ayacucho (JAU-AYP, 7 h 34-7 h 49 vs 4 h 27-5 h 14 por tierra), Tacna-Ilo (TCQ-ILQ, 7 h 42 vs 3 h 36), Lima-Huaraz/Anta (LIM-ATA, 7 h 10 vs solo 1 h por tierra), Trujillo-Chiclayo via Lima (6 h 31 vs 2 h 35), Tarapoto-Rioja via Lima (5 h 10-5 h 35 vs 2 h 05-2 h 57).</a:t>
             </a:r>
             <a:endParaRPr lang="es-PE" sz="1400"/>
           </a:p>
@@ -4254,7 +4254,7 @@
                 </a:solidFill>
                 <a:latin typeface="Calibri"/>
               </a:rPr>
-              <a:t>En los 246 convenios geolocalizados, para cada par se busco un puerto fluvial navegable a &lt;=150 km de cada extremo y una ruta de rio entre ambos (red curada: Yurimaguas, Iquitos, Pucallpa, Nauta, Contamana, etc.).</a:t>
+              <a:t>En los 248 convenios geolocalizados, para cada par se busco un puerto fluvial navegable a &lt;=150 km de cada extremo y una ruta de rio entre ambos (red curada: Yurimaguas, Iquitos, Pucallpa, Nauta, Contamana, etc.).</a:t>
             </a:r>
             <a:endParaRPr lang="es-PE" sz="1500"/>
           </a:p>
@@ -4270,7 +4270,7 @@
                 </a:solidFill>
                 <a:latin typeface="Calibri"/>
               </a:rPr>
-              <a:t>Resultado: 229 convenios no tienen puerto navegable cerca de al menos un extremo; 17 (San Martin) tienen ambos extremos junto al mismo puerto. En todos hay carretera.</a:t>
+              <a:t>Resultado: 231 convenios no tienen puerto navegable cerca de al menos un extremo; 17 (San Martin) tienen ambos extremos junto al mismo puerto. En todos hay carretera.</a:t>
             </a:r>
             <a:endParaRPr lang="es-PE" sz="1500"/>
           </a:p>
@@ -4389,7 +4389,7 @@
                 </a:solidFill>
                 <a:latin typeface="Calibri"/>
               </a:rPr>
-              <a:t>El convenio con mayor tiempo terrestre es N 253: HOSPITAL CARLOS MONGE MEDRANO -&gt; SANTA MARIA DE NIEVA (2,546 km, 2 d 6 h).</a:t>
+              <a:t>El convenio con mayor tiempo terrestre es N 253: HOSPITAL CARLOS MONGE MEDRANO -&gt; SANTA MARIA DE NIEVA (2,546 km, 2 d 5 h).</a:t>
             </a:r>
             <a:endParaRPr lang="es-PE" sz="1500"/>
           </a:p>
@@ -4421,7 +4421,7 @@
                 </a:solidFill>
                 <a:latin typeface="Calibri"/>
               </a:rPr>
-              <a:t>Para los 20 convenios inter-regionales, la via aerea reduce el tiempo puerta a puerta frente al terrestre; en los demas el traslado es y debe seguir siendo por carretera.</a:t>
+              <a:t>De los 18 convenios con opcion aerea, en 5 el avion realmente reduce el tiempo puerta a puerta frente al terrestre (todos con Lima de por medio); en los demas el terrestre sigue siendo mas rapido pese a la distancia de vuelo. En los que no tienen opcion aerea el traslado es y debe seguir siendo por carretera.</a:t>
             </a:r>
             <a:endParaRPr lang="es-PE" sz="1500"/>
           </a:p>
@@ -4437,7 +4437,7 @@
                 </a:solidFill>
                 <a:latin typeface="Calibri"/>
               </a:rPr>
-              <a:t>Recomendaciones: (1) priorizar la actualizacion de ubicacion RENIPRESS de los 32 receptores sin dato; (2) revisar la pertinencia operativa de convenios con traslado terrestre &gt; 12 h; (3) el detalle fila a fila esta en el Excel adjunto.</a:t>
+              <a:t>Recomendaciones: (1) priorizar la actualizacion de ubicacion RENIPRESS de los 30 receptores sin dato; (2) revisar la pertinencia operativa de convenios con traslado terrestre &gt; 12 h; (3) el detalle fila a fila esta en el Excel adjunto.</a:t>
             </a:r>
             <a:endParaRPr lang="es-PE" sz="1400"/>
           </a:p>

</xml_diff>

<commit_message>
Eliminar convenio erroneo Puno-Amazonas (Hospital Carlos Monge Medrano -> Santa Maria de Nieva)
El codigo RENIPRESS 3299 en la planilla semaforo pertenece en realidad
al Hospital de Apoyo Gustavo Lanatta Lujan, no al hospital de Puno con
el mismo codigo en el registro nacional; ese cruce generaba un
convenio ficticio de 2546 km. Se retira la fila de la fuente, se
regenera la red de convenios del aplicativo (278 -> 277) y se
actualizan el Excel y la presentacion resumen.

Co-Authored-By: Claude Sonnet 5 <noreply@anthropic.com>
</commit_message>
<xml_diff>
--- a/datos/Resumen_tiempos_convenios_BS.pptx
+++ b/datos/Resumen_tiempos_convenios_BS.pptx
@@ -661,7 +661,7 @@
                 </a:solidFill>
                 <a:latin typeface="Calibri"/>
               </a:rPr>
-              <a:t>278 convenios evaluados (banco productor tipo II -&gt; hospital receptor tipo I).</a:t>
+              <a:t>277 convenios evaluados (banco productor tipo II -&gt; hospital receptor tipo I).</a:t>
             </a:r>
             <a:endParaRPr lang="es-PE" sz="1600"/>
           </a:p>
@@ -677,7 +677,7 @@
                 </a:solidFill>
                 <a:latin typeface="Calibri"/>
               </a:rPr>
-              <a:t>248 con ruta terrestre calculada. Ningun convenio resulto sin acceso por carretera.</a:t>
+              <a:t>247 con ruta terrestre calculada. Ningun convenio resulto sin acceso por carretera.</a:t>
             </a:r>
             <a:endParaRPr lang="es-PE" sz="1600"/>
           </a:p>
@@ -693,7 +693,7 @@
                 </a:solidFill>
                 <a:latin typeface="Calibri"/>
               </a:rPr>
-              <a:t>18 con opcion de via aerea util (origen y destino en ciudades con aeropuertos distintos).</a:t>
+              <a:t>17 con opcion de via aerea util (origen y destino en ciudades con aeropuertos distintos).</a:t>
             </a:r>
             <a:endParaRPr lang="es-PE" sz="1600"/>
           </a:p>
@@ -843,7 +843,7 @@
                 </a:solidFill>
                 <a:latin typeface="Calibri"/>
               </a:rPr>
-              <a:t>Distribucion de los 248 convenios por tiempo de traslado terrestre (auto particular):</a:t>
+              <a:t>Distribucion de los 247 convenios por tiempo de traslado terrestre (auto particular):</a:t>
             </a:r>
             <a:endParaRPr lang="es-PE" sz="1400"/>
           </a:p>
@@ -939,7 +939,7 @@
                 </a:solidFill>
                 <a:latin typeface="Calibri"/>
               </a:rPr>
-              <a:t>Mas de 24 h ......... 1</a:t>
+              <a:t>Mas de 24 h ......... 0</a:t>
             </a:r>
             <a:endParaRPr lang="es-PE" sz="1400"/>
           </a:p>
@@ -954,7 +954,7 @@
                 </a:solidFill>
                 <a:latin typeface="Calibri"/>
               </a:rPr>
-              <a:t>Conjunto completo (248 convenios): mediana 0 h 26 min, media 1 h 27 min.</a:t>
+              <a:t>Conjunto completo (247 convenios): mediana 0 h 26 min, media 1 h 15 min.</a:t>
             </a:r>
             <a:endParaRPr lang="es-PE" sz="1300"/>
           </a:p>
@@ -969,7 +969,7 @@
                 </a:solidFill>
                 <a:latin typeface="Calibri"/>
               </a:rPr>
-              <a:t>IPRESS con traslado terrestre mayor a 1 h: 59 convenios (24 % del total).</a:t>
+              <a:t>IPRESS con traslado terrestre mayor a 1 h: 58 convenios (23 % del total).</a:t>
             </a:r>
             <a:endParaRPr lang="es-PE" sz="1500"/>
           </a:p>
@@ -985,7 +985,7 @@
                 </a:solidFill>
                 <a:latin typeface="Calibri"/>
               </a:rPr>
-              <a:t>En ese grupo la mediana del tiempo de ruta es 2 h 30 min y la media es 4 h 52 min.</a:t>
+              <a:t>En ese grupo la mediana del tiempo de ruta es 2 h 29 min y la media es 4 h 02 min.</a:t>
             </a:r>
             <a:endParaRPr lang="es-PE" sz="1500"/>
           </a:p>
@@ -1000,7 +1000,7 @@
                 </a:solidFill>
                 <a:latin typeface="Calibri"/>
               </a:rPr>
-              <a:t>La media es mayor que la mediana porque unos pocos convenios inter-regionales de sierra y selva (12 h a 2 dias) elevan el promedio; para la mitad del grupo el traslado sigue por debajo de 2 h 30 min.</a:t>
+              <a:t>La media es mayor que la mediana porque unos pocos convenios inter-regionales de sierra y selva (12 h a 2 dias) elevan el promedio; para la mitad del grupo el traslado sigue por debajo de 2 h 29 min.</a:t>
             </a:r>
             <a:endParaRPr lang="es-PE" sz="1200"/>
           </a:p>
@@ -1283,102 +1283,102 @@
                         <a:rPr lang="es-PE" sz="1050">
                           <a:latin typeface="Calibri"/>
                         </a:rPr>
-                        <a:t>253</a:t>
-                      </a:r>
-                    </a:p>
-                  </a:txBody>
-                  <a:tcPr>
-                    <a:solidFill>
-                      <a:srgbClr val="FFFFFF"/>
-                    </a:solidFill>
-                  </a:tcPr>
-                </a:tc>
-                <a:tc>
-                  <a:txBody>
-                    <a:bodyPr/>
-                    <a:lstStyle/>
-                    <a:p>
-                      <a:r>
-                        <a:rPr lang="es-PE" sz="1050">
-                          <a:latin typeface="Calibri"/>
-                        </a:rPr>
-                        <a:t>HOSPITAL CARLOS MONGE MED…</a:t>
-                      </a:r>
-                    </a:p>
-                  </a:txBody>
-                  <a:tcPr>
-                    <a:solidFill>
-                      <a:srgbClr val="FFFFFF"/>
-                    </a:solidFill>
-                  </a:tcPr>
-                </a:tc>
-                <a:tc>
-                  <a:txBody>
-                    <a:bodyPr/>
-                    <a:lstStyle/>
-                    <a:p>
-                      <a:r>
-                        <a:rPr lang="es-PE" sz="1050">
-                          <a:latin typeface="Calibri"/>
-                        </a:rPr>
-                        <a:t>SANTA MARIA DE NIEVA</a:t>
-                      </a:r>
-                    </a:p>
-                  </a:txBody>
-                  <a:tcPr>
-                    <a:solidFill>
-                      <a:srgbClr val="FFFFFF"/>
-                    </a:solidFill>
-                  </a:tcPr>
-                </a:tc>
-                <a:tc>
-                  <a:txBody>
-                    <a:bodyPr/>
-                    <a:lstStyle/>
-                    <a:p>
-                      <a:r>
-                        <a:rPr lang="es-PE" sz="1050">
-                          <a:latin typeface="Calibri"/>
-                        </a:rPr>
-                        <a:t>2,546</a:t>
-                      </a:r>
-                    </a:p>
-                  </a:txBody>
-                  <a:tcPr>
-                    <a:solidFill>
-                      <a:srgbClr val="FFFFFF"/>
-                    </a:solidFill>
-                  </a:tcPr>
-                </a:tc>
-                <a:tc>
-                  <a:txBody>
-                    <a:bodyPr/>
-                    <a:lstStyle/>
-                    <a:p>
-                      <a:r>
-                        <a:rPr lang="es-PE" sz="1050">
-                          <a:latin typeface="Calibri"/>
-                        </a:rPr>
-                        <a:t>2 d 5 h</a:t>
-                      </a:r>
-                    </a:p>
-                  </a:txBody>
-                  <a:tcPr>
-                    <a:solidFill>
-                      <a:srgbClr val="FFFFFF"/>
-                    </a:solidFill>
-                  </a:tcPr>
-                </a:tc>
-                <a:tc>
-                  <a:txBody>
-                    <a:bodyPr/>
-                    <a:lstStyle/>
-                    <a:p>
-                      <a:r>
-                        <a:rPr lang="es-PE" sz="1050">
-                          <a:latin typeface="Calibri"/>
-                        </a:rPr>
-                        <a:t>paso de altura</a:t>
+                        <a:t>211</a:t>
+                      </a:r>
+                    </a:p>
+                  </a:txBody>
+                  <a:tcPr>
+                    <a:solidFill>
+                      <a:srgbClr val="FFFFFF"/>
+                    </a:solidFill>
+                  </a:tcPr>
+                </a:tc>
+                <a:tc>
+                  <a:txBody>
+                    <a:bodyPr/>
+                    <a:lstStyle/>
+                    <a:p>
+                      <a:r>
+                        <a:rPr lang="es-PE" sz="1050">
+                          <a:latin typeface="Calibri"/>
+                        </a:rPr>
+                        <a:t>MEDIC SER SAC -AUNA CLINI…</a:t>
+                      </a:r>
+                    </a:p>
+                  </a:txBody>
+                  <a:tcPr>
+                    <a:solidFill>
+                      <a:srgbClr val="FFFFFF"/>
+                    </a:solidFill>
+                  </a:tcPr>
+                </a:tc>
+                <a:tc>
+                  <a:txBody>
+                    <a:bodyPr/>
+                    <a:lstStyle/>
+                    <a:p>
+                      <a:r>
+                        <a:rPr lang="es-PE" sz="1050">
+                          <a:latin typeface="Calibri"/>
+                        </a:rPr>
+                        <a:t>CLÍNICAS AUNA SEDE PIURA -</a:t>
+                      </a:r>
+                    </a:p>
+                  </a:txBody>
+                  <a:tcPr>
+                    <a:solidFill>
+                      <a:srgbClr val="FFFFFF"/>
+                    </a:solidFill>
+                  </a:tcPr>
+                </a:tc>
+                <a:tc>
+                  <a:txBody>
+                    <a:bodyPr/>
+                    <a:lstStyle/>
+                    <a:p>
+                      <a:r>
+                        <a:rPr lang="es-PE" sz="1050">
+                          <a:latin typeface="Calibri"/>
+                        </a:rPr>
+                        <a:t>977</a:t>
+                      </a:r>
+                    </a:p>
+                  </a:txBody>
+                  <a:tcPr>
+                    <a:solidFill>
+                      <a:srgbClr val="FFFFFF"/>
+                    </a:solidFill>
+                  </a:tcPr>
+                </a:tc>
+                <a:tc>
+                  <a:txBody>
+                    <a:bodyPr/>
+                    <a:lstStyle/>
+                    <a:p>
+                      <a:r>
+                        <a:rPr lang="es-PE" sz="1050">
+                          <a:latin typeface="Calibri"/>
+                        </a:rPr>
+                        <a:t>18 h 21 min</a:t>
+                      </a:r>
+                    </a:p>
+                  </a:txBody>
+                  <a:tcPr>
+                    <a:solidFill>
+                      <a:srgbClr val="FFFFFF"/>
+                    </a:solidFill>
+                  </a:tcPr>
+                </a:tc>
+                <a:tc>
+                  <a:txBody>
+                    <a:bodyPr/>
+                    <a:lstStyle/>
+                    <a:p>
+                      <a:r>
+                        <a:rPr lang="es-PE" sz="1050">
+                          <a:latin typeface="Calibri"/>
+                        </a:rPr>
+                        <a:t>costa / llano</a:t>
                       </a:r>
                     </a:p>
                   </a:txBody>
@@ -1404,83 +1404,83 @@
                         <a:rPr lang="es-PE" sz="1050">
                           <a:latin typeface="Calibri"/>
                         </a:rPr>
-                        <a:t>211</a:t>
-                      </a:r>
-                    </a:p>
-                  </a:txBody>
-                  <a:tcPr>
-                    <a:solidFill>
-                      <a:srgbClr val="EEF1F6"/>
-                    </a:solidFill>
-                  </a:tcPr>
-                </a:tc>
-                <a:tc>
-                  <a:txBody>
-                    <a:bodyPr/>
-                    <a:lstStyle/>
-                    <a:p>
-                      <a:r>
-                        <a:rPr lang="es-PE" sz="1050">
-                          <a:latin typeface="Calibri"/>
-                        </a:rPr>
-                        <a:t>MEDIC SER SAC -AUNA CLINI…</a:t>
-                      </a:r>
-                    </a:p>
-                  </a:txBody>
-                  <a:tcPr>
-                    <a:solidFill>
-                      <a:srgbClr val="EEF1F6"/>
-                    </a:solidFill>
-                  </a:tcPr>
-                </a:tc>
-                <a:tc>
-                  <a:txBody>
-                    <a:bodyPr/>
-                    <a:lstStyle/>
-                    <a:p>
-                      <a:r>
-                        <a:rPr lang="es-PE" sz="1050">
-                          <a:latin typeface="Calibri"/>
-                        </a:rPr>
-                        <a:t>CLÍNICAS AUNA SEDE PIURA -</a:t>
-                      </a:r>
-                    </a:p>
-                  </a:txBody>
-                  <a:tcPr>
-                    <a:solidFill>
-                      <a:srgbClr val="EEF1F6"/>
-                    </a:solidFill>
-                  </a:tcPr>
-                </a:tc>
-                <a:tc>
-                  <a:txBody>
-                    <a:bodyPr/>
-                    <a:lstStyle/>
-                    <a:p>
-                      <a:r>
-                        <a:rPr lang="es-PE" sz="1050">
-                          <a:latin typeface="Calibri"/>
-                        </a:rPr>
-                        <a:t>977</a:t>
-                      </a:r>
-                    </a:p>
-                  </a:txBody>
-                  <a:tcPr>
-                    <a:solidFill>
-                      <a:srgbClr val="EEF1F6"/>
-                    </a:solidFill>
-                  </a:tcPr>
-                </a:tc>
-                <a:tc>
-                  <a:txBody>
-                    <a:bodyPr/>
-                    <a:lstStyle/>
-                    <a:p>
-                      <a:r>
-                        <a:rPr lang="es-PE" sz="1050">
-                          <a:latin typeface="Calibri"/>
-                        </a:rPr>
-                        <a:t>18 h 21 min</a:t>
+                        <a:t>226</a:t>
+                      </a:r>
+                    </a:p>
+                  </a:txBody>
+                  <a:tcPr>
+                    <a:solidFill>
+                      <a:srgbClr val="EEF1F6"/>
+                    </a:solidFill>
+                  </a:tcPr>
+                </a:tc>
+                <a:tc>
+                  <a:txBody>
+                    <a:bodyPr/>
+                    <a:lstStyle/>
+                    <a:p>
+                      <a:r>
+                        <a:rPr lang="es-PE" sz="1050">
+                          <a:latin typeface="Calibri"/>
+                        </a:rPr>
+                        <a:t>CLINICA SAN BORJA</a:t>
+                      </a:r>
+                    </a:p>
+                  </a:txBody>
+                  <a:tcPr>
+                    <a:solidFill>
+                      <a:srgbClr val="EEF1F6"/>
+                    </a:solidFill>
+                  </a:tcPr>
+                </a:tc>
+                <a:tc>
+                  <a:txBody>
+                    <a:bodyPr/>
+                    <a:lstStyle/>
+                    <a:p>
+                      <a:r>
+                        <a:rPr lang="es-PE" sz="1050">
+                          <a:latin typeface="Calibri"/>
+                        </a:rPr>
+                        <a:t>SANNA - CLINICA BELEN</a:t>
+                      </a:r>
+                    </a:p>
+                  </a:txBody>
+                  <a:tcPr>
+                    <a:solidFill>
+                      <a:srgbClr val="EEF1F6"/>
+                    </a:solidFill>
+                  </a:tcPr>
+                </a:tc>
+                <a:tc>
+                  <a:txBody>
+                    <a:bodyPr/>
+                    <a:lstStyle/>
+                    <a:p>
+                      <a:r>
+                        <a:rPr lang="es-PE" sz="1050">
+                          <a:latin typeface="Calibri"/>
+                        </a:rPr>
+                        <a:t>978</a:t>
+                      </a:r>
+                    </a:p>
+                  </a:txBody>
+                  <a:tcPr>
+                    <a:solidFill>
+                      <a:srgbClr val="EEF1F6"/>
+                    </a:solidFill>
+                  </a:tcPr>
+                </a:tc>
+                <a:tc>
+                  <a:txBody>
+                    <a:bodyPr/>
+                    <a:lstStyle/>
+                    <a:p>
+                      <a:r>
+                        <a:rPr lang="es-PE" sz="1050">
+                          <a:latin typeface="Calibri"/>
+                        </a:rPr>
+                        <a:t>18 h 20 min</a:t>
                       </a:r>
                     </a:p>
                   </a:txBody>
@@ -1525,102 +1525,102 @@
                         <a:rPr lang="es-PE" sz="1050">
                           <a:latin typeface="Calibri"/>
                         </a:rPr>
-                        <a:t>226</a:t>
-                      </a:r>
-                    </a:p>
-                  </a:txBody>
-                  <a:tcPr>
-                    <a:solidFill>
-                      <a:srgbClr val="FFFFFF"/>
-                    </a:solidFill>
-                  </a:tcPr>
-                </a:tc>
-                <a:tc>
-                  <a:txBody>
-                    <a:bodyPr/>
-                    <a:lstStyle/>
-                    <a:p>
-                      <a:r>
-                        <a:rPr lang="es-PE" sz="1050">
-                          <a:latin typeface="Calibri"/>
-                        </a:rPr>
-                        <a:t>CLINICA SAN BORJA</a:t>
-                      </a:r>
-                    </a:p>
-                  </a:txBody>
-                  <a:tcPr>
-                    <a:solidFill>
-                      <a:srgbClr val="FFFFFF"/>
-                    </a:solidFill>
-                  </a:tcPr>
-                </a:tc>
-                <a:tc>
-                  <a:txBody>
-                    <a:bodyPr/>
-                    <a:lstStyle/>
-                    <a:p>
-                      <a:r>
-                        <a:rPr lang="es-PE" sz="1050">
-                          <a:latin typeface="Calibri"/>
-                        </a:rPr>
-                        <a:t>SANNA - CLINICA BELEN</a:t>
-                      </a:r>
-                    </a:p>
-                  </a:txBody>
-                  <a:tcPr>
-                    <a:solidFill>
-                      <a:srgbClr val="FFFFFF"/>
-                    </a:solidFill>
-                  </a:tcPr>
-                </a:tc>
-                <a:tc>
-                  <a:txBody>
-                    <a:bodyPr/>
-                    <a:lstStyle/>
-                    <a:p>
-                      <a:r>
-                        <a:rPr lang="es-PE" sz="1050">
-                          <a:latin typeface="Calibri"/>
-                        </a:rPr>
-                        <a:t>978</a:t>
-                      </a:r>
-                    </a:p>
-                  </a:txBody>
-                  <a:tcPr>
-                    <a:solidFill>
-                      <a:srgbClr val="FFFFFF"/>
-                    </a:solidFill>
-                  </a:tcPr>
-                </a:tc>
-                <a:tc>
-                  <a:txBody>
-                    <a:bodyPr/>
-                    <a:lstStyle/>
-                    <a:p>
-                      <a:r>
-                        <a:rPr lang="es-PE" sz="1050">
-                          <a:latin typeface="Calibri"/>
-                        </a:rPr>
-                        <a:t>18 h 20 min</a:t>
-                      </a:r>
-                    </a:p>
-                  </a:txBody>
-                  <a:tcPr>
-                    <a:solidFill>
-                      <a:srgbClr val="FFFFFF"/>
-                    </a:solidFill>
-                  </a:tcPr>
-                </a:tc>
-                <a:tc>
-                  <a:txBody>
-                    <a:bodyPr/>
-                    <a:lstStyle/>
-                    <a:p>
-                      <a:r>
-                        <a:rPr lang="es-PE" sz="1050">
-                          <a:latin typeface="Calibri"/>
-                        </a:rPr>
-                        <a:t>costa / llano</a:t>
+                        <a:t>209</a:t>
+                      </a:r>
+                    </a:p>
+                  </a:txBody>
+                  <a:tcPr>
+                    <a:solidFill>
+                      <a:srgbClr val="FFFFFF"/>
+                    </a:solidFill>
+                  </a:tcPr>
+                </a:tc>
+                <a:tc>
+                  <a:txBody>
+                    <a:bodyPr/>
+                    <a:lstStyle/>
+                    <a:p>
+                      <a:r>
+                        <a:rPr lang="es-PE" sz="1050">
+                          <a:latin typeface="Calibri"/>
+                        </a:rPr>
+                        <a:t>MEDIC SER SAC -AUNA CLINI…</a:t>
+                      </a:r>
+                    </a:p>
+                  </a:txBody>
+                  <a:tcPr>
+                    <a:solidFill>
+                      <a:srgbClr val="FFFFFF"/>
+                    </a:solidFill>
+                  </a:tcPr>
+                </a:tc>
+                <a:tc>
+                  <a:txBody>
+                    <a:bodyPr/>
+                    <a:lstStyle/>
+                    <a:p>
+                      <a:r>
+                        <a:rPr lang="es-PE" sz="1050">
+                          <a:latin typeface="Calibri"/>
+                        </a:rPr>
+                        <a:t>CLINICAS AUNA SEDE VALLE…</a:t>
+                      </a:r>
+                    </a:p>
+                  </a:txBody>
+                  <a:tcPr>
+                    <a:solidFill>
+                      <a:srgbClr val="FFFFFF"/>
+                    </a:solidFill>
+                  </a:tcPr>
+                </a:tc>
+                <a:tc>
+                  <a:txBody>
+                    <a:bodyPr/>
+                    <a:lstStyle/>
+                    <a:p>
+                      <a:r>
+                        <a:rPr lang="es-PE" sz="1050">
+                          <a:latin typeface="Calibri"/>
+                        </a:rPr>
+                        <a:t>993</a:t>
+                      </a:r>
+                    </a:p>
+                  </a:txBody>
+                  <a:tcPr>
+                    <a:solidFill>
+                      <a:srgbClr val="FFFFFF"/>
+                    </a:solidFill>
+                  </a:tcPr>
+                </a:tc>
+                <a:tc>
+                  <a:txBody>
+                    <a:bodyPr/>
+                    <a:lstStyle/>
+                    <a:p>
+                      <a:r>
+                        <a:rPr lang="es-PE" sz="1050">
+                          <a:latin typeface="Calibri"/>
+                        </a:rPr>
+                        <a:t>17 h 36 min</a:t>
+                      </a:r>
+                    </a:p>
+                  </a:txBody>
+                  <a:tcPr>
+                    <a:solidFill>
+                      <a:srgbClr val="FFFFFF"/>
+                    </a:solidFill>
+                  </a:tcPr>
+                </a:tc>
+                <a:tc>
+                  <a:txBody>
+                    <a:bodyPr/>
+                    <a:lstStyle/>
+                    <a:p>
+                      <a:r>
+                        <a:rPr lang="es-PE" sz="1050">
+                          <a:latin typeface="Calibri"/>
+                        </a:rPr>
+                        <a:t>tramos de altura</a:t>
                       </a:r>
                     </a:p>
                   </a:txBody>
@@ -1646,7 +1646,7 @@
                         <a:rPr lang="es-PE" sz="1050">
                           <a:latin typeface="Calibri"/>
                         </a:rPr>
-                        <a:t>209</a:t>
+                        <a:t>212</a:t>
                       </a:r>
                     </a:p>
                   </a:txBody>
@@ -1684,64 +1684,64 @@
                         <a:rPr lang="es-PE" sz="1050">
                           <a:latin typeface="Calibri"/>
                         </a:rPr>
-                        <a:t>CLINICAS AUNA SEDE VALLE…</a:t>
-                      </a:r>
-                    </a:p>
-                  </a:txBody>
-                  <a:tcPr>
-                    <a:solidFill>
-                      <a:srgbClr val="EEF1F6"/>
-                    </a:solidFill>
-                  </a:tcPr>
-                </a:tc>
-                <a:tc>
-                  <a:txBody>
-                    <a:bodyPr/>
-                    <a:lstStyle/>
-                    <a:p>
-                      <a:r>
-                        <a:rPr lang="es-PE" sz="1050">
-                          <a:latin typeface="Calibri"/>
-                        </a:rPr>
-                        <a:t>993</a:t>
-                      </a:r>
-                    </a:p>
-                  </a:txBody>
-                  <a:tcPr>
-                    <a:solidFill>
-                      <a:srgbClr val="EEF1F6"/>
-                    </a:solidFill>
-                  </a:tcPr>
-                </a:tc>
-                <a:tc>
-                  <a:txBody>
-                    <a:bodyPr/>
-                    <a:lstStyle/>
-                    <a:p>
-                      <a:r>
-                        <a:rPr lang="es-PE" sz="1050">
-                          <a:latin typeface="Calibri"/>
-                        </a:rPr>
-                        <a:t>17 h 36 min</a:t>
-                      </a:r>
-                    </a:p>
-                  </a:txBody>
-                  <a:tcPr>
-                    <a:solidFill>
-                      <a:srgbClr val="EEF1F6"/>
-                    </a:solidFill>
-                  </a:tcPr>
-                </a:tc>
-                <a:tc>
-                  <a:txBody>
-                    <a:bodyPr/>
-                    <a:lstStyle/>
-                    <a:p>
-                      <a:r>
-                        <a:rPr lang="es-PE" sz="1050">
-                          <a:latin typeface="Calibri"/>
-                        </a:rPr>
-                        <a:t>tramos de altura</a:t>
+                        <a:t>GSP TRUJILLO</a:t>
+                      </a:r>
+                    </a:p>
+                  </a:txBody>
+                  <a:tcPr>
+                    <a:solidFill>
+                      <a:srgbClr val="EEF1F6"/>
+                    </a:solidFill>
+                  </a:tcPr>
+                </a:tc>
+                <a:tc>
+                  <a:txBody>
+                    <a:bodyPr/>
+                    <a:lstStyle/>
+                    <a:p>
+                      <a:r>
+                        <a:rPr lang="es-PE" sz="1050">
+                          <a:latin typeface="Calibri"/>
+                        </a:rPr>
+                        <a:t>764</a:t>
+                      </a:r>
+                    </a:p>
+                  </a:txBody>
+                  <a:tcPr>
+                    <a:solidFill>
+                      <a:srgbClr val="EEF1F6"/>
+                    </a:solidFill>
+                  </a:tcPr>
+                </a:tc>
+                <a:tc>
+                  <a:txBody>
+                    <a:bodyPr/>
+                    <a:lstStyle/>
+                    <a:p>
+                      <a:r>
+                        <a:rPr lang="es-PE" sz="1050">
+                          <a:latin typeface="Calibri"/>
+                        </a:rPr>
+                        <a:t>14 h 56 min</a:t>
+                      </a:r>
+                    </a:p>
+                  </a:txBody>
+                  <a:tcPr>
+                    <a:solidFill>
+                      <a:srgbClr val="EEF1F6"/>
+                    </a:solidFill>
+                  </a:tcPr>
+                </a:tc>
+                <a:tc>
+                  <a:txBody>
+                    <a:bodyPr/>
+                    <a:lstStyle/>
+                    <a:p>
+                      <a:r>
+                        <a:rPr lang="es-PE" sz="1050">
+                          <a:latin typeface="Calibri"/>
+                        </a:rPr>
+                        <a:t>costa / llano</a:t>
                       </a:r>
                     </a:p>
                   </a:txBody>
@@ -1767,83 +1767,83 @@
                         <a:rPr lang="es-PE" sz="1050">
                           <a:latin typeface="Calibri"/>
                         </a:rPr>
-                        <a:t>212</a:t>
-                      </a:r>
-                    </a:p>
-                  </a:txBody>
-                  <a:tcPr>
-                    <a:solidFill>
-                      <a:srgbClr val="FFFFFF"/>
-                    </a:solidFill>
-                  </a:tcPr>
-                </a:tc>
-                <a:tc>
-                  <a:txBody>
-                    <a:bodyPr/>
-                    <a:lstStyle/>
-                    <a:p>
-                      <a:r>
-                        <a:rPr lang="es-PE" sz="1050">
-                          <a:latin typeface="Calibri"/>
-                        </a:rPr>
-                        <a:t>MEDIC SER SAC -AUNA CLINI…</a:t>
-                      </a:r>
-                    </a:p>
-                  </a:txBody>
-                  <a:tcPr>
-                    <a:solidFill>
-                      <a:srgbClr val="FFFFFF"/>
-                    </a:solidFill>
-                  </a:tcPr>
-                </a:tc>
-                <a:tc>
-                  <a:txBody>
-                    <a:bodyPr/>
-                    <a:lstStyle/>
-                    <a:p>
-                      <a:r>
-                        <a:rPr lang="es-PE" sz="1050">
-                          <a:latin typeface="Calibri"/>
-                        </a:rPr>
-                        <a:t>GSP TRUJILLO</a:t>
-                      </a:r>
-                    </a:p>
-                  </a:txBody>
-                  <a:tcPr>
-                    <a:solidFill>
-                      <a:srgbClr val="FFFFFF"/>
-                    </a:solidFill>
-                  </a:tcPr>
-                </a:tc>
-                <a:tc>
-                  <a:txBody>
-                    <a:bodyPr/>
-                    <a:lstStyle/>
-                    <a:p>
-                      <a:r>
-                        <a:rPr lang="es-PE" sz="1050">
-                          <a:latin typeface="Calibri"/>
-                        </a:rPr>
-                        <a:t>764</a:t>
-                      </a:r>
-                    </a:p>
-                  </a:txBody>
-                  <a:tcPr>
-                    <a:solidFill>
-                      <a:srgbClr val="FFFFFF"/>
-                    </a:solidFill>
-                  </a:tcPr>
-                </a:tc>
-                <a:tc>
-                  <a:txBody>
-                    <a:bodyPr/>
-                    <a:lstStyle/>
-                    <a:p>
-                      <a:r>
-                        <a:rPr lang="es-PE" sz="1050">
-                          <a:latin typeface="Calibri"/>
-                        </a:rPr>
-                        <a:t>14 h 56 min</a:t>
+                        <a:t>100</a:t>
+                      </a:r>
+                    </a:p>
+                  </a:txBody>
+                  <a:tcPr>
+                    <a:solidFill>
+                      <a:srgbClr val="FFFFFF"/>
+                    </a:solidFill>
+                  </a:tcPr>
+                </a:tc>
+                <a:tc>
+                  <a:txBody>
+                    <a:bodyPr/>
+                    <a:lstStyle/>
+                    <a:p>
+                      <a:r>
+                        <a:rPr lang="es-PE" sz="1050">
+                          <a:latin typeface="Calibri"/>
+                        </a:rPr>
+                        <a:t>HOSPITAL REGIONAL DOCENTE…</a:t>
+                      </a:r>
+                    </a:p>
+                  </a:txBody>
+                  <a:tcPr>
+                    <a:solidFill>
+                      <a:srgbClr val="FFFFFF"/>
+                    </a:solidFill>
+                  </a:tcPr>
+                </a:tc>
+                <a:tc>
+                  <a:txBody>
+                    <a:bodyPr/>
+                    <a:lstStyle/>
+                    <a:p>
+                      <a:r>
+                        <a:rPr lang="es-PE" sz="1050">
+                          <a:latin typeface="Calibri"/>
+                        </a:rPr>
+                        <a:t>CLINICA CAMINO REAL</a:t>
+                      </a:r>
+                    </a:p>
+                  </a:txBody>
+                  <a:tcPr>
+                    <a:solidFill>
+                      <a:srgbClr val="FFFFFF"/>
+                    </a:solidFill>
+                  </a:tcPr>
+                </a:tc>
+                <a:tc>
+                  <a:txBody>
+                    <a:bodyPr/>
+                    <a:lstStyle/>
+                    <a:p>
+                      <a:r>
+                        <a:rPr lang="es-PE" sz="1050">
+                          <a:latin typeface="Calibri"/>
+                        </a:rPr>
+                        <a:t>559</a:t>
+                      </a:r>
+                    </a:p>
+                  </a:txBody>
+                  <a:tcPr>
+                    <a:solidFill>
+                      <a:srgbClr val="FFFFFF"/>
+                    </a:solidFill>
+                  </a:tcPr>
+                </a:tc>
+                <a:tc>
+                  <a:txBody>
+                    <a:bodyPr/>
+                    <a:lstStyle/>
+                    <a:p>
+                      <a:r>
+                        <a:rPr lang="es-PE" sz="1050">
+                          <a:latin typeface="Calibri"/>
+                        </a:rPr>
+                        <a:t>10 h 24 min</a:t>
                       </a:r>
                     </a:p>
                   </a:txBody>
@@ -1888,102 +1888,102 @@
                         <a:rPr lang="es-PE" sz="1050">
                           <a:latin typeface="Calibri"/>
                         </a:rPr>
-                        <a:t>100</a:t>
-                      </a:r>
-                    </a:p>
-                  </a:txBody>
-                  <a:tcPr>
-                    <a:solidFill>
-                      <a:srgbClr val="EEF1F6"/>
-                    </a:solidFill>
-                  </a:tcPr>
-                </a:tc>
-                <a:tc>
-                  <a:txBody>
-                    <a:bodyPr/>
-                    <a:lstStyle/>
-                    <a:p>
-                      <a:r>
-                        <a:rPr lang="es-PE" sz="1050">
-                          <a:latin typeface="Calibri"/>
-                        </a:rPr>
-                        <a:t>HOSPITAL REGIONAL DOCENTE…</a:t>
-                      </a:r>
-                    </a:p>
-                  </a:txBody>
-                  <a:tcPr>
-                    <a:solidFill>
-                      <a:srgbClr val="EEF1F6"/>
-                    </a:solidFill>
-                  </a:tcPr>
-                </a:tc>
-                <a:tc>
-                  <a:txBody>
-                    <a:bodyPr/>
-                    <a:lstStyle/>
-                    <a:p>
-                      <a:r>
-                        <a:rPr lang="es-PE" sz="1050">
-                          <a:latin typeface="Calibri"/>
-                        </a:rPr>
-                        <a:t>CLINICA CAMINO REAL</a:t>
-                      </a:r>
-                    </a:p>
-                  </a:txBody>
-                  <a:tcPr>
-                    <a:solidFill>
-                      <a:srgbClr val="EEF1F6"/>
-                    </a:solidFill>
-                  </a:tcPr>
-                </a:tc>
-                <a:tc>
-                  <a:txBody>
-                    <a:bodyPr/>
-                    <a:lstStyle/>
-                    <a:p>
-                      <a:r>
-                        <a:rPr lang="es-PE" sz="1050">
-                          <a:latin typeface="Calibri"/>
-                        </a:rPr>
-                        <a:t>559</a:t>
-                      </a:r>
-                    </a:p>
-                  </a:txBody>
-                  <a:tcPr>
-                    <a:solidFill>
-                      <a:srgbClr val="EEF1F6"/>
-                    </a:solidFill>
-                  </a:tcPr>
-                </a:tc>
-                <a:tc>
-                  <a:txBody>
-                    <a:bodyPr/>
-                    <a:lstStyle/>
-                    <a:p>
-                      <a:r>
-                        <a:rPr lang="es-PE" sz="1050">
-                          <a:latin typeface="Calibri"/>
-                        </a:rPr>
-                        <a:t>10 h 24 min</a:t>
-                      </a:r>
-                    </a:p>
-                  </a:txBody>
-                  <a:tcPr>
-                    <a:solidFill>
-                      <a:srgbClr val="EEF1F6"/>
-                    </a:solidFill>
-                  </a:tcPr>
-                </a:tc>
-                <a:tc>
-                  <a:txBody>
-                    <a:bodyPr/>
-                    <a:lstStyle/>
-                    <a:p>
-                      <a:r>
-                        <a:rPr lang="es-PE" sz="1050">
-                          <a:latin typeface="Calibri"/>
-                        </a:rPr>
-                        <a:t>costa / llano</a:t>
+                        <a:t>57</a:t>
+                      </a:r>
+                    </a:p>
+                  </a:txBody>
+                  <a:tcPr>
+                    <a:solidFill>
+                      <a:srgbClr val="EEF1F6"/>
+                    </a:solidFill>
+                  </a:tcPr>
+                </a:tc>
+                <a:tc>
+                  <a:txBody>
+                    <a:bodyPr/>
+                    <a:lstStyle/>
+                    <a:p>
+                      <a:r>
+                        <a:rPr lang="es-PE" sz="1050">
+                          <a:latin typeface="Calibri"/>
+                        </a:rPr>
+                        <a:t>Hospital Antonio Lorena d…</a:t>
+                      </a:r>
+                    </a:p>
+                  </a:txBody>
+                  <a:tcPr>
+                    <a:solidFill>
+                      <a:srgbClr val="EEF1F6"/>
+                    </a:solidFill>
+                  </a:tcPr>
+                </a:tc>
+                <a:tc>
+                  <a:txBody>
+                    <a:bodyPr/>
+                    <a:lstStyle/>
+                    <a:p>
+                      <a:r>
+                        <a:rPr lang="es-PE" sz="1050">
+                          <a:latin typeface="Calibri"/>
+                        </a:rPr>
+                        <a:t>SR DE TORRECHAYOC</a:t>
+                      </a:r>
+                    </a:p>
+                  </a:txBody>
+                  <a:tcPr>
+                    <a:solidFill>
+                      <a:srgbClr val="EEF1F6"/>
+                    </a:solidFill>
+                  </a:tcPr>
+                </a:tc>
+                <a:tc>
+                  <a:txBody>
+                    <a:bodyPr/>
+                    <a:lstStyle/>
+                    <a:p>
+                      <a:r>
+                        <a:rPr lang="es-PE" sz="1050">
+                          <a:latin typeface="Calibri"/>
+                        </a:rPr>
+                        <a:t>202</a:t>
+                      </a:r>
+                    </a:p>
+                  </a:txBody>
+                  <a:tcPr>
+                    <a:solidFill>
+                      <a:srgbClr val="EEF1F6"/>
+                    </a:solidFill>
+                  </a:tcPr>
+                </a:tc>
+                <a:tc>
+                  <a:txBody>
+                    <a:bodyPr/>
+                    <a:lstStyle/>
+                    <a:p>
+                      <a:r>
+                        <a:rPr lang="es-PE" sz="1050">
+                          <a:latin typeface="Calibri"/>
+                        </a:rPr>
+                        <a:t>6 h 57 min</a:t>
+                      </a:r>
+                    </a:p>
+                  </a:txBody>
+                  <a:tcPr>
+                    <a:solidFill>
+                      <a:srgbClr val="EEF1F6"/>
+                    </a:solidFill>
+                  </a:tcPr>
+                </a:tc>
+                <a:tc>
+                  <a:txBody>
+                    <a:bodyPr/>
+                    <a:lstStyle/>
+                    <a:p>
+                      <a:r>
+                        <a:rPr lang="es-PE" sz="1050">
+                          <a:latin typeface="Calibri"/>
+                        </a:rPr>
+                        <a:t>sierra alta sostenida</a:t>
                       </a:r>
                     </a:p>
                   </a:txBody>
@@ -2130,7 +2130,7 @@
                         <a:rPr lang="es-PE" sz="1050">
                           <a:latin typeface="Calibri"/>
                         </a:rPr>
-                        <a:t>57</a:t>
+                        <a:t>49</a:t>
                       </a:r>
                     </a:p>
                   </a:txBody>
@@ -2168,45 +2168,45 @@
                         <a:rPr lang="es-PE" sz="1050">
                           <a:latin typeface="Calibri"/>
                         </a:rPr>
-                        <a:t>SR DE TORRECHAYOC</a:t>
-                      </a:r>
-                    </a:p>
-                  </a:txBody>
-                  <a:tcPr>
-                    <a:solidFill>
-                      <a:srgbClr val="EEF1F6"/>
-                    </a:solidFill>
-                  </a:tcPr>
-                </a:tc>
-                <a:tc>
-                  <a:txBody>
-                    <a:bodyPr/>
-                    <a:lstStyle/>
-                    <a:p>
-                      <a:r>
-                        <a:rPr lang="es-PE" sz="1050">
-                          <a:latin typeface="Calibri"/>
-                        </a:rPr>
-                        <a:t>202</a:t>
-                      </a:r>
-                    </a:p>
-                  </a:txBody>
-                  <a:tcPr>
-                    <a:solidFill>
-                      <a:srgbClr val="EEF1F6"/>
-                    </a:solidFill>
-                  </a:tcPr>
-                </a:tc>
-                <a:tc>
-                  <a:txBody>
-                    <a:bodyPr/>
-                    <a:lstStyle/>
-                    <a:p>
-                      <a:r>
-                        <a:rPr lang="es-PE" sz="1050">
-                          <a:latin typeface="Calibri"/>
-                        </a:rPr>
-                        <a:t>6 h 57 min</a:t>
+                        <a:t>HOSPITAL DE ESPINAR</a:t>
+                      </a:r>
+                    </a:p>
+                  </a:txBody>
+                  <a:tcPr>
+                    <a:solidFill>
+                      <a:srgbClr val="EEF1F6"/>
+                    </a:solidFill>
+                  </a:tcPr>
+                </a:tc>
+                <a:tc>
+                  <a:txBody>
+                    <a:bodyPr/>
+                    <a:lstStyle/>
+                    <a:p>
+                      <a:r>
+                        <a:rPr lang="es-PE" sz="1050">
+                          <a:latin typeface="Calibri"/>
+                        </a:rPr>
+                        <a:t>221</a:t>
+                      </a:r>
+                    </a:p>
+                  </a:txBody>
+                  <a:tcPr>
+                    <a:solidFill>
+                      <a:srgbClr val="EEF1F6"/>
+                    </a:solidFill>
+                  </a:tcPr>
+                </a:tc>
+                <a:tc>
+                  <a:txBody>
+                    <a:bodyPr/>
+                    <a:lstStyle/>
+                    <a:p>
+                      <a:r>
+                        <a:rPr lang="es-PE" sz="1050">
+                          <a:latin typeface="Calibri"/>
+                        </a:rPr>
+                        <a:t>6 h 09 min</a:t>
                       </a:r>
                     </a:p>
                   </a:txBody>
@@ -2251,83 +2251,83 @@
                         <a:rPr lang="es-PE" sz="1050">
                           <a:latin typeface="Calibri"/>
                         </a:rPr>
-                        <a:t>49</a:t>
-                      </a:r>
-                    </a:p>
-                  </a:txBody>
-                  <a:tcPr>
-                    <a:solidFill>
-                      <a:srgbClr val="FFFFFF"/>
-                    </a:solidFill>
-                  </a:tcPr>
-                </a:tc>
-                <a:tc>
-                  <a:txBody>
-                    <a:bodyPr/>
-                    <a:lstStyle/>
-                    <a:p>
-                      <a:r>
-                        <a:rPr lang="es-PE" sz="1050">
-                          <a:latin typeface="Calibri"/>
-                        </a:rPr>
-                        <a:t>Hospital Antonio Lorena d…</a:t>
-                      </a:r>
-                    </a:p>
-                  </a:txBody>
-                  <a:tcPr>
-                    <a:solidFill>
-                      <a:srgbClr val="FFFFFF"/>
-                    </a:solidFill>
-                  </a:tcPr>
-                </a:tc>
-                <a:tc>
-                  <a:txBody>
-                    <a:bodyPr/>
-                    <a:lstStyle/>
-                    <a:p>
-                      <a:r>
-                        <a:rPr lang="es-PE" sz="1050">
-                          <a:latin typeface="Calibri"/>
-                        </a:rPr>
-                        <a:t>HOSPITAL DE ESPINAR</a:t>
-                      </a:r>
-                    </a:p>
-                  </a:txBody>
-                  <a:tcPr>
-                    <a:solidFill>
-                      <a:srgbClr val="FFFFFF"/>
-                    </a:solidFill>
-                  </a:tcPr>
-                </a:tc>
-                <a:tc>
-                  <a:txBody>
-                    <a:bodyPr/>
-                    <a:lstStyle/>
-                    <a:p>
-                      <a:r>
-                        <a:rPr lang="es-PE" sz="1050">
-                          <a:latin typeface="Calibri"/>
-                        </a:rPr>
-                        <a:t>221</a:t>
-                      </a:r>
-                    </a:p>
-                  </a:txBody>
-                  <a:tcPr>
-                    <a:solidFill>
-                      <a:srgbClr val="FFFFFF"/>
-                    </a:solidFill>
-                  </a:tcPr>
-                </a:tc>
-                <a:tc>
-                  <a:txBody>
-                    <a:bodyPr/>
-                    <a:lstStyle/>
-                    <a:p>
-                      <a:r>
-                        <a:rPr lang="es-PE" sz="1050">
-                          <a:latin typeface="Calibri"/>
-                        </a:rPr>
-                        <a:t>6 h 09 min</a:t>
+                        <a:t>40</a:t>
+                      </a:r>
+                    </a:p>
+                  </a:txBody>
+                  <a:tcPr>
+                    <a:solidFill>
+                      <a:srgbClr val="FFFFFF"/>
+                    </a:solidFill>
+                  </a:tcPr>
+                </a:tc>
+                <a:tc>
+                  <a:txBody>
+                    <a:bodyPr/>
+                    <a:lstStyle/>
+                    <a:p>
+                      <a:r>
+                        <a:rPr lang="es-PE" sz="1050">
+                          <a:latin typeface="Calibri"/>
+                        </a:rPr>
+                        <a:t>Hospital Regional de Ayac…</a:t>
+                      </a:r>
+                    </a:p>
+                  </a:txBody>
+                  <a:tcPr>
+                    <a:solidFill>
+                      <a:srgbClr val="FFFFFF"/>
+                    </a:solidFill>
+                  </a:tcPr>
+                </a:tc>
+                <a:tc>
+                  <a:txBody>
+                    <a:bodyPr/>
+                    <a:lstStyle/>
+                    <a:p>
+                      <a:r>
+                        <a:rPr lang="es-PE" sz="1050">
+                          <a:latin typeface="Calibri"/>
+                        </a:rPr>
+                        <a:t>SAN JUAN DE KIMBIRI-VRAEM</a:t>
+                      </a:r>
+                    </a:p>
+                  </a:txBody>
+                  <a:tcPr>
+                    <a:solidFill>
+                      <a:srgbClr val="FFFFFF"/>
+                    </a:solidFill>
+                  </a:tcPr>
+                </a:tc>
+                <a:tc>
+                  <a:txBody>
+                    <a:bodyPr/>
+                    <a:lstStyle/>
+                    <a:p>
+                      <a:r>
+                        <a:rPr lang="es-PE" sz="1050">
+                          <a:latin typeface="Calibri"/>
+                        </a:rPr>
+                        <a:t>186</a:t>
+                      </a:r>
+                    </a:p>
+                  </a:txBody>
+                  <a:tcPr>
+                    <a:solidFill>
+                      <a:srgbClr val="FFFFFF"/>
+                    </a:solidFill>
+                  </a:tcPr>
+                </a:tc>
+                <a:tc>
+                  <a:txBody>
+                    <a:bodyPr/>
+                    <a:lstStyle/>
+                    <a:p>
+                      <a:r>
+                        <a:rPr lang="es-PE" sz="1050">
+                          <a:latin typeface="Calibri"/>
+                        </a:rPr>
+                        <a:t>6 h 04 min</a:t>
                       </a:r>
                     </a:p>
                   </a:txBody>
@@ -2372,83 +2372,83 @@
                         <a:rPr lang="es-PE" sz="1050">
                           <a:latin typeface="Calibri"/>
                         </a:rPr>
-                        <a:t>40</a:t>
-                      </a:r>
-                    </a:p>
-                  </a:txBody>
-                  <a:tcPr>
-                    <a:solidFill>
-                      <a:srgbClr val="EEF1F6"/>
-                    </a:solidFill>
-                  </a:tcPr>
-                </a:tc>
-                <a:tc>
-                  <a:txBody>
-                    <a:bodyPr/>
-                    <a:lstStyle/>
-                    <a:p>
-                      <a:r>
-                        <a:rPr lang="es-PE" sz="1050">
-                          <a:latin typeface="Calibri"/>
-                        </a:rPr>
-                        <a:t>Hospital Regional de Ayac…</a:t>
-                      </a:r>
-                    </a:p>
-                  </a:txBody>
-                  <a:tcPr>
-                    <a:solidFill>
-                      <a:srgbClr val="EEF1F6"/>
-                    </a:solidFill>
-                  </a:tcPr>
-                </a:tc>
-                <a:tc>
-                  <a:txBody>
-                    <a:bodyPr/>
-                    <a:lstStyle/>
-                    <a:p>
-                      <a:r>
-                        <a:rPr lang="es-PE" sz="1050">
-                          <a:latin typeface="Calibri"/>
-                        </a:rPr>
-                        <a:t>SAN JUAN DE KIMBIRI-VRAEM</a:t>
-                      </a:r>
-                    </a:p>
-                  </a:txBody>
-                  <a:tcPr>
-                    <a:solidFill>
-                      <a:srgbClr val="EEF1F6"/>
-                    </a:solidFill>
-                  </a:tcPr>
-                </a:tc>
-                <a:tc>
-                  <a:txBody>
-                    <a:bodyPr/>
-                    <a:lstStyle/>
-                    <a:p>
-                      <a:r>
-                        <a:rPr lang="es-PE" sz="1050">
-                          <a:latin typeface="Calibri"/>
-                        </a:rPr>
-                        <a:t>186</a:t>
-                      </a:r>
-                    </a:p>
-                  </a:txBody>
-                  <a:tcPr>
-                    <a:solidFill>
-                      <a:srgbClr val="EEF1F6"/>
-                    </a:solidFill>
-                  </a:tcPr>
-                </a:tc>
-                <a:tc>
-                  <a:txBody>
-                    <a:bodyPr/>
-                    <a:lstStyle/>
-                    <a:p>
-                      <a:r>
-                        <a:rPr lang="es-PE" sz="1050">
-                          <a:latin typeface="Calibri"/>
-                        </a:rPr>
-                        <a:t>6 h 04 min</a:t>
+                        <a:t>241</a:t>
+                      </a:r>
+                    </a:p>
+                  </a:txBody>
+                  <a:tcPr>
+                    <a:solidFill>
+                      <a:srgbClr val="EEF1F6"/>
+                    </a:solidFill>
+                  </a:tcPr>
+                </a:tc>
+                <a:tc>
+                  <a:txBody>
+                    <a:bodyPr/>
+                    <a:lstStyle/>
+                    <a:p>
+                      <a:r>
+                        <a:rPr lang="es-PE" sz="1050">
+                          <a:latin typeface="Calibri"/>
+                        </a:rPr>
+                        <a:t>HOSPITAL II PASCO</a:t>
+                      </a:r>
+                    </a:p>
+                  </a:txBody>
+                  <a:tcPr>
+                    <a:solidFill>
+                      <a:srgbClr val="EEF1F6"/>
+                    </a:solidFill>
+                  </a:tcPr>
+                </a:tc>
+                <a:tc>
+                  <a:txBody>
+                    <a:bodyPr/>
+                    <a:lstStyle/>
+                    <a:p>
+                      <a:r>
+                        <a:rPr lang="es-PE" sz="1050">
+                          <a:latin typeface="Calibri"/>
+                        </a:rPr>
+                        <a:t>HOSPITAL I OXAPAMPA</a:t>
+                      </a:r>
+                    </a:p>
+                  </a:txBody>
+                  <a:tcPr>
+                    <a:solidFill>
+                      <a:srgbClr val="EEF1F6"/>
+                    </a:solidFill>
+                  </a:tcPr>
+                </a:tc>
+                <a:tc>
+                  <a:txBody>
+                    <a:bodyPr/>
+                    <a:lstStyle/>
+                    <a:p>
+                      <a:r>
+                        <a:rPr lang="es-PE" sz="1050">
+                          <a:latin typeface="Calibri"/>
+                        </a:rPr>
+                        <a:t>175</a:t>
+                      </a:r>
+                    </a:p>
+                  </a:txBody>
+                  <a:tcPr>
+                    <a:solidFill>
+                      <a:srgbClr val="EEF1F6"/>
+                    </a:solidFill>
+                  </a:tcPr>
+                </a:tc>
+                <a:tc>
+                  <a:txBody>
+                    <a:bodyPr/>
+                    <a:lstStyle/>
+                    <a:p>
+                      <a:r>
+                        <a:rPr lang="es-PE" sz="1050">
+                          <a:latin typeface="Calibri"/>
+                        </a:rPr>
+                        <a:t>6 h 02 min</a:t>
                       </a:r>
                     </a:p>
                   </a:txBody>
@@ -2493,45 +2493,45 @@
                         <a:rPr lang="es-PE" sz="1050">
                           <a:latin typeface="Calibri"/>
                         </a:rPr>
-                        <a:t>241</a:t>
-                      </a:r>
-                    </a:p>
-                  </a:txBody>
-                  <a:tcPr>
-                    <a:solidFill>
-                      <a:srgbClr val="FFFFFF"/>
-                    </a:solidFill>
-                  </a:tcPr>
-                </a:tc>
-                <a:tc>
-                  <a:txBody>
-                    <a:bodyPr/>
-                    <a:lstStyle/>
-                    <a:p>
-                      <a:r>
-                        <a:rPr lang="es-PE" sz="1050">
-                          <a:latin typeface="Calibri"/>
-                        </a:rPr>
-                        <a:t>HOSPITAL II PASCO</a:t>
-                      </a:r>
-                    </a:p>
-                  </a:txBody>
-                  <a:tcPr>
-                    <a:solidFill>
-                      <a:srgbClr val="FFFFFF"/>
-                    </a:solidFill>
-                  </a:tcPr>
-                </a:tc>
-                <a:tc>
-                  <a:txBody>
-                    <a:bodyPr/>
-                    <a:lstStyle/>
-                    <a:p>
-                      <a:r>
-                        <a:rPr lang="es-PE" sz="1050">
-                          <a:latin typeface="Calibri"/>
-                        </a:rPr>
-                        <a:t>HOSPITAL I OXAPAMPA</a:t>
+                        <a:t>41</a:t>
+                      </a:r>
+                    </a:p>
+                  </a:txBody>
+                  <a:tcPr>
+                    <a:solidFill>
+                      <a:srgbClr val="FFFFFF"/>
+                    </a:solidFill>
+                  </a:tcPr>
+                </a:tc>
+                <a:tc>
+                  <a:txBody>
+                    <a:bodyPr/>
+                    <a:lstStyle/>
+                    <a:p>
+                      <a:r>
+                        <a:rPr lang="es-PE" sz="1050">
+                          <a:latin typeface="Calibri"/>
+                        </a:rPr>
+                        <a:t>Hospital Regional de Ayac…</a:t>
+                      </a:r>
+                    </a:p>
+                  </a:txBody>
+                  <a:tcPr>
+                    <a:solidFill>
+                      <a:srgbClr val="FFFFFF"/>
+                    </a:solidFill>
+                  </a:tcPr>
+                </a:tc>
+                <a:tc>
+                  <a:txBody>
+                    <a:bodyPr/>
+                    <a:lstStyle/>
+                    <a:p>
+                      <a:r>
+                        <a:rPr lang="es-PE" sz="1050">
+                          <a:latin typeface="Calibri"/>
+                        </a:rPr>
+                        <a:t>HOSPITAL DE APOYO SAN FRA…</a:t>
                       </a:r>
                     </a:p>
                   </a:txBody>
@@ -2569,7 +2569,7 @@
                         <a:rPr lang="es-PE" sz="1050">
                           <a:latin typeface="Calibri"/>
                         </a:rPr>
-                        <a:t>6 h 02 min</a:t>
+                        <a:t>5 h 25 min</a:t>
                       </a:r>
                     </a:p>
                   </a:txBody>
@@ -2614,83 +2614,83 @@
                         <a:rPr lang="es-PE" sz="1050">
                           <a:latin typeface="Calibri"/>
                         </a:rPr>
-                        <a:t>41</a:t>
-                      </a:r>
-                    </a:p>
-                  </a:txBody>
-                  <a:tcPr>
-                    <a:solidFill>
-                      <a:srgbClr val="EEF1F6"/>
-                    </a:solidFill>
-                  </a:tcPr>
-                </a:tc>
-                <a:tc>
-                  <a:txBody>
-                    <a:bodyPr/>
-                    <a:lstStyle/>
-                    <a:p>
-                      <a:r>
-                        <a:rPr lang="es-PE" sz="1050">
-                          <a:latin typeface="Calibri"/>
-                        </a:rPr>
-                        <a:t>Hospital Regional de Ayac…</a:t>
-                      </a:r>
-                    </a:p>
-                  </a:txBody>
-                  <a:tcPr>
-                    <a:solidFill>
-                      <a:srgbClr val="EEF1F6"/>
-                    </a:solidFill>
-                  </a:tcPr>
-                </a:tc>
-                <a:tc>
-                  <a:txBody>
-                    <a:bodyPr/>
-                    <a:lstStyle/>
-                    <a:p>
-                      <a:r>
-                        <a:rPr lang="es-PE" sz="1050">
-                          <a:latin typeface="Calibri"/>
-                        </a:rPr>
-                        <a:t>HOSPITAL DE APOYO SAN FRA…</a:t>
-                      </a:r>
-                    </a:p>
-                  </a:txBody>
-                  <a:tcPr>
-                    <a:solidFill>
-                      <a:srgbClr val="EEF1F6"/>
-                    </a:solidFill>
-                  </a:tcPr>
-                </a:tc>
-                <a:tc>
-                  <a:txBody>
-                    <a:bodyPr/>
-                    <a:lstStyle/>
-                    <a:p>
-                      <a:r>
-                        <a:rPr lang="es-PE" sz="1050">
-                          <a:latin typeface="Calibri"/>
-                        </a:rPr>
-                        <a:t>175</a:t>
-                      </a:r>
-                    </a:p>
-                  </a:txBody>
-                  <a:tcPr>
-                    <a:solidFill>
-                      <a:srgbClr val="EEF1F6"/>
-                    </a:solidFill>
-                  </a:tcPr>
-                </a:tc>
-                <a:tc>
-                  <a:txBody>
-                    <a:bodyPr/>
-                    <a:lstStyle/>
-                    <a:p>
-                      <a:r>
-                        <a:rPr lang="es-PE" sz="1050">
-                          <a:latin typeface="Calibri"/>
-                        </a:rPr>
-                        <a:t>5 h 25 min</a:t>
+                        <a:t>51</a:t>
+                      </a:r>
+                    </a:p>
+                  </a:txBody>
+                  <a:tcPr>
+                    <a:solidFill>
+                      <a:srgbClr val="EEF1F6"/>
+                    </a:solidFill>
+                  </a:tcPr>
+                </a:tc>
+                <a:tc>
+                  <a:txBody>
+                    <a:bodyPr/>
+                    <a:lstStyle/>
+                    <a:p>
+                      <a:r>
+                        <a:rPr lang="es-PE" sz="1050">
+                          <a:latin typeface="Calibri"/>
+                        </a:rPr>
+                        <a:t>Hospital Antonio Lorena d…</a:t>
+                      </a:r>
+                    </a:p>
+                  </a:txBody>
+                  <a:tcPr>
+                    <a:solidFill>
+                      <a:srgbClr val="EEF1F6"/>
+                    </a:solidFill>
+                  </a:tcPr>
+                </a:tc>
+                <a:tc>
+                  <a:txBody>
+                    <a:bodyPr/>
+                    <a:lstStyle/>
+                    <a:p>
+                      <a:r>
+                        <a:rPr lang="es-PE" sz="1050">
+                          <a:latin typeface="Calibri"/>
+                        </a:rPr>
+                        <a:t>HOSPITAL DE SANTO TOMAS</a:t>
+                      </a:r>
+                    </a:p>
+                  </a:txBody>
+                  <a:tcPr>
+                    <a:solidFill>
+                      <a:srgbClr val="EEF1F6"/>
+                    </a:solidFill>
+                  </a:tcPr>
+                </a:tc>
+                <a:tc>
+                  <a:txBody>
+                    <a:bodyPr/>
+                    <a:lstStyle/>
+                    <a:p>
+                      <a:r>
+                        <a:rPr lang="es-PE" sz="1050">
+                          <a:latin typeface="Calibri"/>
+                        </a:rPr>
+                        <a:t>219</a:t>
+                      </a:r>
+                    </a:p>
+                  </a:txBody>
+                  <a:tcPr>
+                    <a:solidFill>
+                      <a:srgbClr val="EEF1F6"/>
+                    </a:solidFill>
+                  </a:tcPr>
+                </a:tc>
+                <a:tc>
+                  <a:txBody>
+                    <a:bodyPr/>
+                    <a:lstStyle/>
+                    <a:p>
+                      <a:r>
+                        <a:rPr lang="es-PE" sz="1050">
+                          <a:latin typeface="Calibri"/>
+                        </a:rPr>
+                        <a:t>5 h 21 min</a:t>
                       </a:r>
                     </a:p>
                   </a:txBody>
@@ -2787,7 +2787,7 @@
                 </a:solidFill>
                 <a:latin typeface="Calibri"/>
               </a:rPr>
-              <a:t>Via aerea - 18 convenios con opcion aerea (por tiempo)</a:t>
+              <a:t>Via aerea - 17 convenios con opcion aerea (por tiempo)</a:t>
             </a:r>
             <a:endParaRPr lang="es-PE" sz="2600"/>
           </a:p>
@@ -2976,83 +2976,83 @@
                         <a:rPr lang="es-PE" sz="1050">
                           <a:latin typeface="Calibri"/>
                         </a:rPr>
-                        <a:t>253</a:t>
-                      </a:r>
-                    </a:p>
-                  </a:txBody>
-                  <a:tcPr>
-                    <a:solidFill>
-                      <a:srgbClr val="FFFFFF"/>
-                    </a:solidFill>
-                  </a:tcPr>
-                </a:tc>
-                <a:tc>
-                  <a:txBody>
-                    <a:bodyPr/>
-                    <a:lstStyle/>
-                    <a:p>
-                      <a:r>
-                        <a:rPr lang="es-PE" sz="1050">
-                          <a:latin typeface="Calibri"/>
-                        </a:rPr>
-                        <a:t>Juliaca (JUL) -&gt; LIM -&gt; Jaén (JAE)</a:t>
-                      </a:r>
-                    </a:p>
-                  </a:txBody>
-                  <a:tcPr>
-                    <a:solidFill>
-                      <a:srgbClr val="FFFFFF"/>
-                    </a:solidFill>
-                  </a:tcPr>
-                </a:tc>
-                <a:tc>
-                  <a:txBody>
-                    <a:bodyPr/>
-                    <a:lstStyle/>
-                    <a:p>
-                      <a:r>
-                        <a:rPr lang="es-PE" sz="1050">
-                          <a:latin typeface="Calibri"/>
-                        </a:rPr>
-                        <a:t>1,581</a:t>
-                      </a:r>
-                    </a:p>
-                  </a:txBody>
-                  <a:tcPr>
-                    <a:solidFill>
-                      <a:srgbClr val="FFFFFF"/>
-                    </a:solidFill>
-                  </a:tcPr>
-                </a:tc>
-                <a:tc>
-                  <a:txBody>
-                    <a:bodyPr/>
-                    <a:lstStyle/>
-                    <a:p>
-                      <a:r>
-                        <a:rPr lang="es-PE" sz="1050">
-                          <a:latin typeface="Calibri"/>
-                        </a:rPr>
-                        <a:t>9 h 08 min</a:t>
-                      </a:r>
-                    </a:p>
-                  </a:txBody>
-                  <a:tcPr>
-                    <a:solidFill>
-                      <a:srgbClr val="FFFFFF"/>
-                    </a:solidFill>
-                  </a:tcPr>
-                </a:tc>
-                <a:tc>
-                  <a:txBody>
-                    <a:bodyPr/>
-                    <a:lstStyle/>
-                    <a:p>
-                      <a:r>
-                        <a:rPr lang="es-PE" sz="1050">
-                          <a:latin typeface="Calibri"/>
-                        </a:rPr>
-                        <a:t>SANTA MARIA DE NIEVA</a:t>
+                        <a:t>69</a:t>
+                      </a:r>
+                    </a:p>
+                  </a:txBody>
+                  <a:tcPr>
+                    <a:solidFill>
+                      <a:srgbClr val="FFFFFF"/>
+                    </a:solidFill>
+                  </a:tcPr>
+                </a:tc>
+                <a:tc>
+                  <a:txBody>
+                    <a:bodyPr/>
+                    <a:lstStyle/>
+                    <a:p>
+                      <a:r>
+                        <a:rPr lang="es-PE" sz="1050">
+                          <a:latin typeface="Calibri"/>
+                        </a:rPr>
+                        <a:t>Jauja (JAU) -&gt; LIM -&gt; Ayacucho (AYP)</a:t>
+                      </a:r>
+                    </a:p>
+                  </a:txBody>
+                  <a:tcPr>
+                    <a:solidFill>
+                      <a:srgbClr val="FFFFFF"/>
+                    </a:solidFill>
+                  </a:tcPr>
+                </a:tc>
+                <a:tc>
+                  <a:txBody>
+                    <a:bodyPr/>
+                    <a:lstStyle/>
+                    <a:p>
+                      <a:r>
+                        <a:rPr lang="es-PE" sz="1050">
+                          <a:latin typeface="Calibri"/>
+                        </a:rPr>
+                        <a:t>520</a:t>
+                      </a:r>
+                    </a:p>
+                  </a:txBody>
+                  <a:tcPr>
+                    <a:solidFill>
+                      <a:srgbClr val="FFFFFF"/>
+                    </a:solidFill>
+                  </a:tcPr>
+                </a:tc>
+                <a:tc>
+                  <a:txBody>
+                    <a:bodyPr/>
+                    <a:lstStyle/>
+                    <a:p>
+                      <a:r>
+                        <a:rPr lang="es-PE" sz="1050">
+                          <a:latin typeface="Calibri"/>
+                        </a:rPr>
+                        <a:t>7 h 49 min</a:t>
+                      </a:r>
+                    </a:p>
+                  </a:txBody>
+                  <a:tcPr>
+                    <a:solidFill>
+                      <a:srgbClr val="FFFFFF"/>
+                    </a:solidFill>
+                  </a:tcPr>
+                </a:tc>
+                <a:tc>
+                  <a:txBody>
+                    <a:bodyPr/>
+                    <a:lstStyle/>
+                    <a:p>
+                      <a:r>
+                        <a:rPr lang="es-PE" sz="1050">
+                          <a:latin typeface="Calibri"/>
+                        </a:rPr>
+                        <a:t>HOSPITAL DE LIRCAY</a:t>
                       </a:r>
                     </a:p>
                   </a:txBody>
@@ -3078,83 +3078,83 @@
                         <a:rPr lang="es-PE" sz="1050">
                           <a:latin typeface="Calibri"/>
                         </a:rPr>
-                        <a:t>69</a:t>
-                      </a:r>
-                    </a:p>
-                  </a:txBody>
-                  <a:tcPr>
-                    <a:solidFill>
-                      <a:srgbClr val="EEF1F6"/>
-                    </a:solidFill>
-                  </a:tcPr>
-                </a:tc>
-                <a:tc>
-                  <a:txBody>
-                    <a:bodyPr/>
-                    <a:lstStyle/>
-                    <a:p>
-                      <a:r>
-                        <a:rPr lang="es-PE" sz="1050">
-                          <a:latin typeface="Calibri"/>
-                        </a:rPr>
-                        <a:t>Jauja (JAU) -&gt; LIM -&gt; Ayacucho (AYP)</a:t>
-                      </a:r>
-                    </a:p>
-                  </a:txBody>
-                  <a:tcPr>
-                    <a:solidFill>
-                      <a:srgbClr val="EEF1F6"/>
-                    </a:solidFill>
-                  </a:tcPr>
-                </a:tc>
-                <a:tc>
-                  <a:txBody>
-                    <a:bodyPr/>
-                    <a:lstStyle/>
-                    <a:p>
-                      <a:r>
-                        <a:rPr lang="es-PE" sz="1050">
-                          <a:latin typeface="Calibri"/>
-                        </a:rPr>
-                        <a:t>520</a:t>
-                      </a:r>
-                    </a:p>
-                  </a:txBody>
-                  <a:tcPr>
-                    <a:solidFill>
-                      <a:srgbClr val="EEF1F6"/>
-                    </a:solidFill>
-                  </a:tcPr>
-                </a:tc>
-                <a:tc>
-                  <a:txBody>
-                    <a:bodyPr/>
-                    <a:lstStyle/>
-                    <a:p>
-                      <a:r>
-                        <a:rPr lang="es-PE" sz="1050">
-                          <a:latin typeface="Calibri"/>
-                        </a:rPr>
-                        <a:t>7 h 49 min</a:t>
-                      </a:r>
-                    </a:p>
-                  </a:txBody>
-                  <a:tcPr>
-                    <a:solidFill>
-                      <a:srgbClr val="EEF1F6"/>
-                    </a:solidFill>
-                  </a:tcPr>
-                </a:tc>
-                <a:tc>
-                  <a:txBody>
-                    <a:bodyPr/>
-                    <a:lstStyle/>
-                    <a:p>
-                      <a:r>
-                        <a:rPr lang="es-PE" sz="1050">
-                          <a:latin typeface="Calibri"/>
-                        </a:rPr>
-                        <a:t>HOSPITAL DE LIRCAY</a:t>
+                        <a:t>278</a:t>
+                      </a:r>
+                    </a:p>
+                  </a:txBody>
+                  <a:tcPr>
+                    <a:solidFill>
+                      <a:srgbClr val="EEF1F6"/>
+                    </a:solidFill>
+                  </a:tcPr>
+                </a:tc>
+                <a:tc>
+                  <a:txBody>
+                    <a:bodyPr/>
+                    <a:lstStyle/>
+                    <a:p>
+                      <a:r>
+                        <a:rPr lang="es-PE" sz="1050">
+                          <a:latin typeface="Calibri"/>
+                        </a:rPr>
+                        <a:t>Tacna (TCQ) -&gt; LIM -&gt; Ilo (ILQ)</a:t>
+                      </a:r>
+                    </a:p>
+                  </a:txBody>
+                  <a:tcPr>
+                    <a:solidFill>
+                      <a:srgbClr val="EEF1F6"/>
+                    </a:solidFill>
+                  </a:tcPr>
+                </a:tc>
+                <a:tc>
+                  <a:txBody>
+                    <a:bodyPr/>
+                    <a:lstStyle/>
+                    <a:p>
+                      <a:r>
+                        <a:rPr lang="es-PE" sz="1050">
+                          <a:latin typeface="Calibri"/>
+                        </a:rPr>
+                        <a:t>1,879</a:t>
+                      </a:r>
+                    </a:p>
+                  </a:txBody>
+                  <a:tcPr>
+                    <a:solidFill>
+                      <a:srgbClr val="EEF1F6"/>
+                    </a:solidFill>
+                  </a:tcPr>
+                </a:tc>
+                <a:tc>
+                  <a:txBody>
+                    <a:bodyPr/>
+                    <a:lstStyle/>
+                    <a:p>
+                      <a:r>
+                        <a:rPr lang="es-PE" sz="1050">
+                          <a:latin typeface="Calibri"/>
+                        </a:rPr>
+                        <a:t>7 h 42 min</a:t>
+                      </a:r>
+                    </a:p>
+                  </a:txBody>
+                  <a:tcPr>
+                    <a:solidFill>
+                      <a:srgbClr val="EEF1F6"/>
+                    </a:solidFill>
+                  </a:tcPr>
+                </a:tc>
+                <a:tc>
+                  <a:txBody>
+                    <a:bodyPr/>
+                    <a:lstStyle/>
+                    <a:p>
+                      <a:r>
+                        <a:rPr lang="es-PE" sz="1050">
+                          <a:latin typeface="Calibri"/>
+                        </a:rPr>
+                        <a:t>Hospital II Moquegua -…</a:t>
                       </a:r>
                     </a:p>
                   </a:txBody>
@@ -3180,83 +3180,83 @@
                         <a:rPr lang="es-PE" sz="1050">
                           <a:latin typeface="Calibri"/>
                         </a:rPr>
-                        <a:t>278</a:t>
-                      </a:r>
-                    </a:p>
-                  </a:txBody>
-                  <a:tcPr>
-                    <a:solidFill>
-                      <a:srgbClr val="FFFFFF"/>
-                    </a:solidFill>
-                  </a:tcPr>
-                </a:tc>
-                <a:tc>
-                  <a:txBody>
-                    <a:bodyPr/>
-                    <a:lstStyle/>
-                    <a:p>
-                      <a:r>
-                        <a:rPr lang="es-PE" sz="1050">
-                          <a:latin typeface="Calibri"/>
-                        </a:rPr>
-                        <a:t>Tacna (TCQ) -&gt; LIM -&gt; Ilo (ILQ)</a:t>
-                      </a:r>
-                    </a:p>
-                  </a:txBody>
-                  <a:tcPr>
-                    <a:solidFill>
-                      <a:srgbClr val="FFFFFF"/>
-                    </a:solidFill>
-                  </a:tcPr>
-                </a:tc>
-                <a:tc>
-                  <a:txBody>
-                    <a:bodyPr/>
-                    <a:lstStyle/>
-                    <a:p>
-                      <a:r>
-                        <a:rPr lang="es-PE" sz="1050">
-                          <a:latin typeface="Calibri"/>
-                        </a:rPr>
-                        <a:t>1,879</a:t>
-                      </a:r>
-                    </a:p>
-                  </a:txBody>
-                  <a:tcPr>
-                    <a:solidFill>
-                      <a:srgbClr val="FFFFFF"/>
-                    </a:solidFill>
-                  </a:tcPr>
-                </a:tc>
-                <a:tc>
-                  <a:txBody>
-                    <a:bodyPr/>
-                    <a:lstStyle/>
-                    <a:p>
-                      <a:r>
-                        <a:rPr lang="es-PE" sz="1050">
-                          <a:latin typeface="Calibri"/>
-                        </a:rPr>
-                        <a:t>7 h 42 min</a:t>
-                      </a:r>
-                    </a:p>
-                  </a:txBody>
-                  <a:tcPr>
-                    <a:solidFill>
-                      <a:srgbClr val="FFFFFF"/>
-                    </a:solidFill>
-                  </a:tcPr>
-                </a:tc>
-                <a:tc>
-                  <a:txBody>
-                    <a:bodyPr/>
-                    <a:lstStyle/>
-                    <a:p>
-                      <a:r>
-                        <a:rPr lang="es-PE" sz="1050">
-                          <a:latin typeface="Calibri"/>
-                        </a:rPr>
-                        <a:t>Hospital II Moquegua -…</a:t>
+                        <a:t>68</a:t>
+                      </a:r>
+                    </a:p>
+                  </a:txBody>
+                  <a:tcPr>
+                    <a:solidFill>
+                      <a:srgbClr val="FFFFFF"/>
+                    </a:solidFill>
+                  </a:tcPr>
+                </a:tc>
+                <a:tc>
+                  <a:txBody>
+                    <a:bodyPr/>
+                    <a:lstStyle/>
+                    <a:p>
+                      <a:r>
+                        <a:rPr lang="es-PE" sz="1050">
+                          <a:latin typeface="Calibri"/>
+                        </a:rPr>
+                        <a:t>Jauja (JAU) -&gt; LIM -&gt; Ayacucho (AYP)</a:t>
+                      </a:r>
+                    </a:p>
+                  </a:txBody>
+                  <a:tcPr>
+                    <a:solidFill>
+                      <a:srgbClr val="FFFFFF"/>
+                    </a:solidFill>
+                  </a:tcPr>
+                </a:tc>
+                <a:tc>
+                  <a:txBody>
+                    <a:bodyPr/>
+                    <a:lstStyle/>
+                    <a:p>
+                      <a:r>
+                        <a:rPr lang="es-PE" sz="1050">
+                          <a:latin typeface="Calibri"/>
+                        </a:rPr>
+                        <a:t>520</a:t>
+                      </a:r>
+                    </a:p>
+                  </a:txBody>
+                  <a:tcPr>
+                    <a:solidFill>
+                      <a:srgbClr val="FFFFFF"/>
+                    </a:solidFill>
+                  </a:tcPr>
+                </a:tc>
+                <a:tc>
+                  <a:txBody>
+                    <a:bodyPr/>
+                    <a:lstStyle/>
+                    <a:p>
+                      <a:r>
+                        <a:rPr lang="es-PE" sz="1050">
+                          <a:latin typeface="Calibri"/>
+                        </a:rPr>
+                        <a:t>7 h 34 min</a:t>
+                      </a:r>
+                    </a:p>
+                  </a:txBody>
+                  <a:tcPr>
+                    <a:solidFill>
+                      <a:srgbClr val="FFFFFF"/>
+                    </a:solidFill>
+                  </a:tcPr>
+                </a:tc>
+                <a:tc>
+                  <a:txBody>
+                    <a:bodyPr/>
+                    <a:lstStyle/>
+                    <a:p>
+                      <a:r>
+                        <a:rPr lang="es-PE" sz="1050">
+                          <a:latin typeface="Calibri"/>
+                        </a:rPr>
+                        <a:t>HOSPITAL PROVINCIAL DE…</a:t>
                       </a:r>
                     </a:p>
                   </a:txBody>
@@ -3282,83 +3282,83 @@
                         <a:rPr lang="es-PE" sz="1050">
                           <a:latin typeface="Calibri"/>
                         </a:rPr>
-                        <a:t>68</a:t>
-                      </a:r>
-                    </a:p>
-                  </a:txBody>
-                  <a:tcPr>
-                    <a:solidFill>
-                      <a:srgbClr val="EEF1F6"/>
-                    </a:solidFill>
-                  </a:tcPr>
-                </a:tc>
-                <a:tc>
-                  <a:txBody>
-                    <a:bodyPr/>
-                    <a:lstStyle/>
-                    <a:p>
-                      <a:r>
-                        <a:rPr lang="es-PE" sz="1050">
-                          <a:latin typeface="Calibri"/>
-                        </a:rPr>
-                        <a:t>Jauja (JAU) -&gt; LIM -&gt; Ayacucho (AYP)</a:t>
-                      </a:r>
-                    </a:p>
-                  </a:txBody>
-                  <a:tcPr>
-                    <a:solidFill>
-                      <a:srgbClr val="EEF1F6"/>
-                    </a:solidFill>
-                  </a:tcPr>
-                </a:tc>
-                <a:tc>
-                  <a:txBody>
-                    <a:bodyPr/>
-                    <a:lstStyle/>
-                    <a:p>
-                      <a:r>
-                        <a:rPr lang="es-PE" sz="1050">
-                          <a:latin typeface="Calibri"/>
-                        </a:rPr>
-                        <a:t>520</a:t>
-                      </a:r>
-                    </a:p>
-                  </a:txBody>
-                  <a:tcPr>
-                    <a:solidFill>
-                      <a:srgbClr val="EEF1F6"/>
-                    </a:solidFill>
-                  </a:tcPr>
-                </a:tc>
-                <a:tc>
-                  <a:txBody>
-                    <a:bodyPr/>
-                    <a:lstStyle/>
-                    <a:p>
-                      <a:r>
-                        <a:rPr lang="es-PE" sz="1050">
-                          <a:latin typeface="Calibri"/>
-                        </a:rPr>
-                        <a:t>7 h 34 min</a:t>
-                      </a:r>
-                    </a:p>
-                  </a:txBody>
-                  <a:tcPr>
-                    <a:solidFill>
-                      <a:srgbClr val="EEF1F6"/>
-                    </a:solidFill>
-                  </a:tcPr>
-                </a:tc>
-                <a:tc>
-                  <a:txBody>
-                    <a:bodyPr/>
-                    <a:lstStyle/>
-                    <a:p>
-                      <a:r>
-                        <a:rPr lang="es-PE" sz="1050">
-                          <a:latin typeface="Calibri"/>
-                        </a:rPr>
-                        <a:t>HOSPITAL PROVINCIAL DE…</a:t>
+                        <a:t>177</a:t>
+                      </a:r>
+                    </a:p>
+                  </a:txBody>
+                  <a:tcPr>
+                    <a:solidFill>
+                      <a:srgbClr val="EEF1F6"/>
+                    </a:solidFill>
+                  </a:tcPr>
+                </a:tc>
+                <a:tc>
+                  <a:txBody>
+                    <a:bodyPr/>
+                    <a:lstStyle/>
+                    <a:p>
+                      <a:r>
+                        <a:rPr lang="es-PE" sz="1050">
+                          <a:latin typeface="Calibri"/>
+                        </a:rPr>
+                        <a:t>Lima (LIM) -&gt; Huaraz (Anta) (ATA)</a:t>
+                      </a:r>
+                    </a:p>
+                  </a:txBody>
+                  <a:tcPr>
+                    <a:solidFill>
+                      <a:srgbClr val="EEF1F6"/>
+                    </a:solidFill>
+                  </a:tcPr>
+                </a:tc>
+                <a:tc>
+                  <a:txBody>
+                    <a:bodyPr/>
+                    <a:lstStyle/>
+                    <a:p>
+                      <a:r>
+                        <a:rPr lang="es-PE" sz="1050">
+                          <a:latin typeface="Calibri"/>
+                        </a:rPr>
+                        <a:t>302</a:t>
+                      </a:r>
+                    </a:p>
+                  </a:txBody>
+                  <a:tcPr>
+                    <a:solidFill>
+                      <a:srgbClr val="EEF1F6"/>
+                    </a:solidFill>
+                  </a:tcPr>
+                </a:tc>
+                <a:tc>
+                  <a:txBody>
+                    <a:bodyPr/>
+                    <a:lstStyle/>
+                    <a:p>
+                      <a:r>
+                        <a:rPr lang="es-PE" sz="1050">
+                          <a:latin typeface="Calibri"/>
+                        </a:rPr>
+                        <a:t>7 h 10 min</a:t>
+                      </a:r>
+                    </a:p>
+                  </a:txBody>
+                  <a:tcPr>
+                    <a:solidFill>
+                      <a:srgbClr val="EEF1F6"/>
+                    </a:solidFill>
+                  </a:tcPr>
+                </a:tc>
+                <a:tc>
+                  <a:txBody>
+                    <a:bodyPr/>
+                    <a:lstStyle/>
+                    <a:p>
+                      <a:r>
+                        <a:rPr lang="es-PE" sz="1050">
+                          <a:latin typeface="Calibri"/>
+                        </a:rPr>
+                        <a:t>HOSPITAL BARRANCA CAJAT…</a:t>
                       </a:r>
                     </a:p>
                   </a:txBody>
@@ -3384,83 +3384,83 @@
                         <a:rPr lang="es-PE" sz="1050">
                           <a:latin typeface="Calibri"/>
                         </a:rPr>
-                        <a:t>177</a:t>
-                      </a:r>
-                    </a:p>
-                  </a:txBody>
-                  <a:tcPr>
-                    <a:solidFill>
-                      <a:srgbClr val="FFFFFF"/>
-                    </a:solidFill>
-                  </a:tcPr>
-                </a:tc>
-                <a:tc>
-                  <a:txBody>
-                    <a:bodyPr/>
-                    <a:lstStyle/>
-                    <a:p>
-                      <a:r>
-                        <a:rPr lang="es-PE" sz="1050">
-                          <a:latin typeface="Calibri"/>
-                        </a:rPr>
-                        <a:t>Lima (LIM) -&gt; Huaraz (Anta) (ATA)</a:t>
-                      </a:r>
-                    </a:p>
-                  </a:txBody>
-                  <a:tcPr>
-                    <a:solidFill>
-                      <a:srgbClr val="FFFFFF"/>
-                    </a:solidFill>
-                  </a:tcPr>
-                </a:tc>
-                <a:tc>
-                  <a:txBody>
-                    <a:bodyPr/>
-                    <a:lstStyle/>
-                    <a:p>
-                      <a:r>
-                        <a:rPr lang="es-PE" sz="1050">
-                          <a:latin typeface="Calibri"/>
-                        </a:rPr>
-                        <a:t>302</a:t>
-                      </a:r>
-                    </a:p>
-                  </a:txBody>
-                  <a:tcPr>
-                    <a:solidFill>
-                      <a:srgbClr val="FFFFFF"/>
-                    </a:solidFill>
-                  </a:tcPr>
-                </a:tc>
-                <a:tc>
-                  <a:txBody>
-                    <a:bodyPr/>
-                    <a:lstStyle/>
-                    <a:p>
-                      <a:r>
-                        <a:rPr lang="es-PE" sz="1050">
-                          <a:latin typeface="Calibri"/>
-                        </a:rPr>
-                        <a:t>7 h 10 min</a:t>
-                      </a:r>
-                    </a:p>
-                  </a:txBody>
-                  <a:tcPr>
-                    <a:solidFill>
-                      <a:srgbClr val="FFFFFF"/>
-                    </a:solidFill>
-                  </a:tcPr>
-                </a:tc>
-                <a:tc>
-                  <a:txBody>
-                    <a:bodyPr/>
-                    <a:lstStyle/>
-                    <a:p>
-                      <a:r>
-                        <a:rPr lang="es-PE" sz="1050">
-                          <a:latin typeface="Calibri"/>
-                        </a:rPr>
-                        <a:t>HOSPITAL BARRANCA CAJAT…</a:t>
+                        <a:t>102</a:t>
+                      </a:r>
+                    </a:p>
+                  </a:txBody>
+                  <a:tcPr>
+                    <a:solidFill>
+                      <a:srgbClr val="FFFFFF"/>
+                    </a:solidFill>
+                  </a:tcPr>
+                </a:tc>
+                <a:tc>
+                  <a:txBody>
+                    <a:bodyPr/>
+                    <a:lstStyle/>
+                    <a:p>
+                      <a:r>
+                        <a:rPr lang="es-PE" sz="1050">
+                          <a:latin typeface="Calibri"/>
+                        </a:rPr>
+                        <a:t>Trujillo (TRU) -&gt; LIM -&gt; Chiclayo (CIX)</a:t>
+                      </a:r>
+                    </a:p>
+                  </a:txBody>
+                  <a:tcPr>
+                    <a:solidFill>
+                      <a:srgbClr val="FFFFFF"/>
+                    </a:solidFill>
+                  </a:tcPr>
+                </a:tc>
+                <a:tc>
+                  <a:txBody>
+                    <a:bodyPr/>
+                    <a:lstStyle/>
+                    <a:p>
+                      <a:r>
+                        <a:rPr lang="es-PE" sz="1050">
+                          <a:latin typeface="Calibri"/>
+                        </a:rPr>
+                        <a:t>1,143</a:t>
+                      </a:r>
+                    </a:p>
+                  </a:txBody>
+                  <a:tcPr>
+                    <a:solidFill>
+                      <a:srgbClr val="FFFFFF"/>
+                    </a:solidFill>
+                  </a:tcPr>
+                </a:tc>
+                <a:tc>
+                  <a:txBody>
+                    <a:bodyPr/>
+                    <a:lstStyle/>
+                    <a:p>
+                      <a:r>
+                        <a:rPr lang="es-PE" sz="1050">
+                          <a:latin typeface="Calibri"/>
+                        </a:rPr>
+                        <a:t>6 h 31 min</a:t>
+                      </a:r>
+                    </a:p>
+                  </a:txBody>
+                  <a:tcPr>
+                    <a:solidFill>
+                      <a:srgbClr val="FFFFFF"/>
+                    </a:solidFill>
+                  </a:tcPr>
+                </a:tc>
+                <a:tc>
+                  <a:txBody>
+                    <a:bodyPr/>
+                    <a:lstStyle/>
+                    <a:p>
+                      <a:r>
+                        <a:rPr lang="es-PE" sz="1050">
+                          <a:latin typeface="Calibri"/>
+                        </a:rPr>
+                        <a:t>HOSPITAL TOMAS LA FORA</a:t>
                       </a:r>
                     </a:p>
                   </a:txBody>
@@ -3486,83 +3486,83 @@
                         <a:rPr lang="es-PE" sz="1050">
                           <a:latin typeface="Calibri"/>
                         </a:rPr>
-                        <a:t>102</a:t>
-                      </a:r>
-                    </a:p>
-                  </a:txBody>
-                  <a:tcPr>
-                    <a:solidFill>
-                      <a:srgbClr val="EEF1F6"/>
-                    </a:solidFill>
-                  </a:tcPr>
-                </a:tc>
-                <a:tc>
-                  <a:txBody>
-                    <a:bodyPr/>
-                    <a:lstStyle/>
-                    <a:p>
-                      <a:r>
-                        <a:rPr lang="es-PE" sz="1050">
-                          <a:latin typeface="Calibri"/>
-                        </a:rPr>
-                        <a:t>Trujillo (TRU) -&gt; LIM -&gt; Chiclayo (CIX)</a:t>
-                      </a:r>
-                    </a:p>
-                  </a:txBody>
-                  <a:tcPr>
-                    <a:solidFill>
-                      <a:srgbClr val="EEF1F6"/>
-                    </a:solidFill>
-                  </a:tcPr>
-                </a:tc>
-                <a:tc>
-                  <a:txBody>
-                    <a:bodyPr/>
-                    <a:lstStyle/>
-                    <a:p>
-                      <a:r>
-                        <a:rPr lang="es-PE" sz="1050">
-                          <a:latin typeface="Calibri"/>
-                        </a:rPr>
-                        <a:t>1,143</a:t>
-                      </a:r>
-                    </a:p>
-                  </a:txBody>
-                  <a:tcPr>
-                    <a:solidFill>
-                      <a:srgbClr val="EEF1F6"/>
-                    </a:solidFill>
-                  </a:tcPr>
-                </a:tc>
-                <a:tc>
-                  <a:txBody>
-                    <a:bodyPr/>
-                    <a:lstStyle/>
-                    <a:p>
-                      <a:r>
-                        <a:rPr lang="es-PE" sz="1050">
-                          <a:latin typeface="Calibri"/>
-                        </a:rPr>
-                        <a:t>6 h 31 min</a:t>
-                      </a:r>
-                    </a:p>
-                  </a:txBody>
-                  <a:tcPr>
-                    <a:solidFill>
-                      <a:srgbClr val="EEF1F6"/>
-                    </a:solidFill>
-                  </a:tcPr>
-                </a:tc>
-                <a:tc>
-                  <a:txBody>
-                    <a:bodyPr/>
-                    <a:lstStyle/>
-                    <a:p>
-                      <a:r>
-                        <a:rPr lang="es-PE" sz="1050">
-                          <a:latin typeface="Calibri"/>
-                        </a:rPr>
-                        <a:t>HOSPITAL TOMAS LA FORA</a:t>
+                        <a:t>263</a:t>
+                      </a:r>
+                    </a:p>
+                  </a:txBody>
+                  <a:tcPr>
+                    <a:solidFill>
+                      <a:srgbClr val="EEF1F6"/>
+                    </a:solidFill>
+                  </a:tcPr>
+                </a:tc>
+                <a:tc>
+                  <a:txBody>
+                    <a:bodyPr/>
+                    <a:lstStyle/>
+                    <a:p>
+                      <a:r>
+                        <a:rPr lang="es-PE" sz="1050">
+                          <a:latin typeface="Calibri"/>
+                        </a:rPr>
+                        <a:t>Tarapoto (TPP) -&gt; LIM -&gt; Rioja (RIJ)</a:t>
+                      </a:r>
+                    </a:p>
+                  </a:txBody>
+                  <a:tcPr>
+                    <a:solidFill>
+                      <a:srgbClr val="EEF1F6"/>
+                    </a:solidFill>
+                  </a:tcPr>
+                </a:tc>
+                <a:tc>
+                  <a:txBody>
+                    <a:bodyPr/>
+                    <a:lstStyle/>
+                    <a:p>
+                      <a:r>
+                        <a:rPr lang="es-PE" sz="1050">
+                          <a:latin typeface="Calibri"/>
+                        </a:rPr>
+                        <a:t>1,280</a:t>
+                      </a:r>
+                    </a:p>
+                  </a:txBody>
+                  <a:tcPr>
+                    <a:solidFill>
+                      <a:srgbClr val="EEF1F6"/>
+                    </a:solidFill>
+                  </a:tcPr>
+                </a:tc>
+                <a:tc>
+                  <a:txBody>
+                    <a:bodyPr/>
+                    <a:lstStyle/>
+                    <a:p>
+                      <a:r>
+                        <a:rPr lang="es-PE" sz="1050">
+                          <a:latin typeface="Calibri"/>
+                        </a:rPr>
+                        <a:t>5 h 35 min</a:t>
+                      </a:r>
+                    </a:p>
+                  </a:txBody>
+                  <a:tcPr>
+                    <a:solidFill>
+                      <a:srgbClr val="EEF1F6"/>
+                    </a:solidFill>
+                  </a:tcPr>
+                </a:tc>
+                <a:tc>
+                  <a:txBody>
+                    <a:bodyPr/>
+                    <a:lstStyle/>
+                    <a:p>
+                      <a:r>
+                        <a:rPr lang="es-PE" sz="1050">
+                          <a:latin typeface="Calibri"/>
+                        </a:rPr>
+                        <a:t>HOSPITAL MOYOBAMBA</a:t>
                       </a:r>
                     </a:p>
                   </a:txBody>
@@ -3588,7 +3588,7 @@
                         <a:rPr lang="es-PE" sz="1050">
                           <a:latin typeface="Calibri"/>
                         </a:rPr>
-                        <a:t>263</a:t>
+                        <a:t>274</a:t>
                       </a:r>
                     </a:p>
                   </a:txBody>
@@ -3645,26 +3645,26 @@
                         <a:rPr lang="es-PE" sz="1050">
                           <a:latin typeface="Calibri"/>
                         </a:rPr>
-                        <a:t>5 h 35 min</a:t>
-                      </a:r>
-                    </a:p>
-                  </a:txBody>
-                  <a:tcPr>
-                    <a:solidFill>
-                      <a:srgbClr val="FFFFFF"/>
-                    </a:solidFill>
-                  </a:tcPr>
-                </a:tc>
-                <a:tc>
-                  <a:txBody>
-                    <a:bodyPr/>
-                    <a:lstStyle/>
-                    <a:p>
-                      <a:r>
-                        <a:rPr lang="es-PE" sz="1050">
-                          <a:latin typeface="Calibri"/>
-                        </a:rPr>
-                        <a:t>HOSPITAL MOYOBAMBA</a:t>
+                        <a:t>5 h 33 min</a:t>
+                      </a:r>
+                    </a:p>
+                  </a:txBody>
+                  <a:tcPr>
+                    <a:solidFill>
+                      <a:srgbClr val="FFFFFF"/>
+                    </a:solidFill>
+                  </a:tcPr>
+                </a:tc>
+                <a:tc>
+                  <a:txBody>
+                    <a:bodyPr/>
+                    <a:lstStyle/>
+                    <a:p>
+                      <a:r>
+                        <a:rPr lang="es-PE" sz="1050">
+                          <a:latin typeface="Calibri"/>
+                        </a:rPr>
+                        <a:t>CENTRO MEDICO LUZ DIVINA</a:t>
                       </a:r>
                     </a:p>
                   </a:txBody>
@@ -3690,7 +3690,7 @@
                         <a:rPr lang="es-PE" sz="1050">
                           <a:latin typeface="Calibri"/>
                         </a:rPr>
-                        <a:t>274</a:t>
+                        <a:t>269</a:t>
                       </a:r>
                     </a:p>
                   </a:txBody>
@@ -3747,26 +3747,26 @@
                         <a:rPr lang="es-PE" sz="1050">
                           <a:latin typeface="Calibri"/>
                         </a:rPr>
-                        <a:t>5 h 33 min</a:t>
-                      </a:r>
-                    </a:p>
-                  </a:txBody>
-                  <a:tcPr>
-                    <a:solidFill>
-                      <a:srgbClr val="EEF1F6"/>
-                    </a:solidFill>
-                  </a:tcPr>
-                </a:tc>
-                <a:tc>
-                  <a:txBody>
-                    <a:bodyPr/>
-                    <a:lstStyle/>
-                    <a:p>
-                      <a:r>
-                        <a:rPr lang="es-PE" sz="1050">
-                          <a:latin typeface="Calibri"/>
-                        </a:rPr>
-                        <a:t>CENTRO MEDICO LUZ DIVINA</a:t>
+                        <a:t>5 h 29 min</a:t>
+                      </a:r>
+                    </a:p>
+                  </a:txBody>
+                  <a:tcPr>
+                    <a:solidFill>
+                      <a:srgbClr val="EEF1F6"/>
+                    </a:solidFill>
+                  </a:tcPr>
+                </a:tc>
+                <a:tc>
+                  <a:txBody>
+                    <a:bodyPr/>
+                    <a:lstStyle/>
+                    <a:p>
+                      <a:r>
+                        <a:rPr lang="es-PE" sz="1050">
+                          <a:latin typeface="Calibri"/>
+                        </a:rPr>
+                        <a:t>CLINICA YANTALO -</a:t>
                       </a:r>
                     </a:p>
                   </a:txBody>
@@ -3792,7 +3792,7 @@
                         <a:rPr lang="es-PE" sz="1050">
                           <a:latin typeface="Calibri"/>
                         </a:rPr>
-                        <a:t>269</a:t>
+                        <a:t>260</a:t>
                       </a:r>
                     </a:p>
                   </a:txBody>
@@ -3849,26 +3849,26 @@
                         <a:rPr lang="es-PE" sz="1050">
                           <a:latin typeface="Calibri"/>
                         </a:rPr>
-                        <a:t>5 h 29 min</a:t>
-                      </a:r>
-                    </a:p>
-                  </a:txBody>
-                  <a:tcPr>
-                    <a:solidFill>
-                      <a:srgbClr val="FFFFFF"/>
-                    </a:solidFill>
-                  </a:tcPr>
-                </a:tc>
-                <a:tc>
-                  <a:txBody>
-                    <a:bodyPr/>
-                    <a:lstStyle/>
-                    <a:p>
-                      <a:r>
-                        <a:rPr lang="es-PE" sz="1050">
-                          <a:latin typeface="Calibri"/>
-                        </a:rPr>
-                        <a:t>CLINICA YANTALO -</a:t>
+                        <a:t>5 h 10 min</a:t>
+                      </a:r>
+                    </a:p>
+                  </a:txBody>
+                  <a:tcPr>
+                    <a:solidFill>
+                      <a:srgbClr val="FFFFFF"/>
+                    </a:solidFill>
+                  </a:tcPr>
+                </a:tc>
+                <a:tc>
+                  <a:txBody>
+                    <a:bodyPr/>
+                    <a:lstStyle/>
+                    <a:p>
+                      <a:r>
+                        <a:rPr lang="es-PE" sz="1050">
+                          <a:latin typeface="Calibri"/>
+                        </a:rPr>
+                        <a:t>Nombre comercial: Centr…</a:t>
                       </a:r>
                     </a:p>
                   </a:txBody>
@@ -3894,7 +3894,7 @@
                         <a:rPr lang="es-PE" sz="1050">
                           <a:latin typeface="Calibri"/>
                         </a:rPr>
-                        <a:t>260</a:t>
+                        <a:t>264</a:t>
                       </a:r>
                     </a:p>
                   </a:txBody>
@@ -3970,7 +3970,7 @@
                         <a:rPr lang="es-PE" sz="1050">
                           <a:latin typeface="Calibri"/>
                         </a:rPr>
-                        <a:t>Nombre comercial: Centr…</a:t>
+                        <a:t>HOSPITAL DE RIOJA</a:t>
                       </a:r>
                     </a:p>
                   </a:txBody>
@@ -4088,7 +4088,7 @@
                 </a:solidFill>
                 <a:latin typeface="Calibri"/>
               </a:rPr>
-              <a:t>La via aerea solo se evalua cuando origen y destino usan aeropuertos distintos con servicio comercial; por eso solo 18 de 278 convenios la tienen.</a:t>
+              <a:t>La via aerea solo se evalua cuando origen y destino usan aeropuertos distintos con servicio comercial; por eso solo 17 de 277 convenios la tienen.</a:t>
             </a:r>
             <a:endParaRPr lang="es-PE" sz="1500"/>
           </a:p>
@@ -4104,7 +4104,7 @@
                 </a:solidFill>
                 <a:latin typeface="Calibri"/>
               </a:rPr>
-              <a:t>Rutas largas reales donde el avion es la opcion sensata (el terrestre de la misma fila es varias veces mas largo): Juliaca-Jaen (JUL-JAE, 9 h 08 vs 2 d 5 h por tierra), Lima-Piura (LIM-PIU, 2 h 44-2 h 48 vs 18 h 20-18 h 21 por tierra), Lima-Arequipa (LIM-AQP, 3 h 06 vs 17 h 36), Lima-Chiclayo (LIM-CIX, 2 h 39 vs 14 h 56), Trujillo-Lima (TRU-LIM, 2 h 38 vs 10 h 24).</a:t>
+              <a:t>Rutas largas reales donde el avion es la opcion sensata (el terrestre de la misma fila es varias veces mas largo): Lima-Piura (LIM-PIU, 2 h 44-2 h 48 vs 18 h 20-18 h 21 por tierra), Lima-Arequipa (LIM-AQP, 3 h 06 vs 17 h 36), Lima-Chiclayo (LIM-CIX, 2 h 39 vs 14 h 56), Trujillo-Lima (TRU-LIM, 2 h 38 vs 10 h 24).</a:t>
             </a:r>
             <a:endParaRPr lang="es-PE" sz="1500"/>
           </a:p>
@@ -4254,7 +4254,7 @@
                 </a:solidFill>
                 <a:latin typeface="Calibri"/>
               </a:rPr>
-              <a:t>En los 248 convenios geolocalizados, para cada par se busco un puerto fluvial navegable a &lt;=150 km de cada extremo y una ruta de rio entre ambos (red curada: Yurimaguas, Iquitos, Pucallpa, Nauta, Contamana, etc.).</a:t>
+              <a:t>En los 247 convenios geolocalizados, para cada par se busco un puerto fluvial navegable a &lt;=150 km de cada extremo y una ruta de rio entre ambos (red curada: Yurimaguas, Iquitos, Pucallpa, Nauta, Contamana, etc.).</a:t>
             </a:r>
             <a:endParaRPr lang="es-PE" sz="1500"/>
           </a:p>
@@ -4270,7 +4270,7 @@
                 </a:solidFill>
                 <a:latin typeface="Calibri"/>
               </a:rPr>
-              <a:t>Resultado: 231 convenios no tienen puerto navegable cerca de al menos un extremo; 17 (San Martin) tienen ambos extremos junto al mismo puerto. En todos hay carretera.</a:t>
+              <a:t>Resultado: 230 convenios no tienen puerto navegable cerca de al menos un extremo; 17 (San Martin) tienen ambos extremos junto al mismo puerto. En todos hay carretera.</a:t>
             </a:r>
             <a:endParaRPr lang="es-PE" sz="1500"/>
           </a:p>
@@ -4389,7 +4389,7 @@
                 </a:solidFill>
                 <a:latin typeface="Calibri"/>
               </a:rPr>
-              <a:t>El convenio con mayor tiempo terrestre es N 253: HOSPITAL CARLOS MONGE MEDRANO -&gt; SANTA MARIA DE NIEVA (2,546 km, 2 d 5 h).</a:t>
+              <a:t>El convenio con mayor tiempo terrestre es N 211: MEDIC SER SAC -AUNA CLINICA DELGA… -&gt; CLÍNICAS AUNA SEDE PIURA - (977 km, 18 h 21 min).</a:t>
             </a:r>
             <a:endParaRPr lang="es-PE" sz="1500"/>
           </a:p>
@@ -4421,7 +4421,7 @@
                 </a:solidFill>
                 <a:latin typeface="Calibri"/>
               </a:rPr>
-              <a:t>De los 18 convenios con opcion aerea, en 5 el avion realmente reduce el tiempo puerta a puerta frente al terrestre (todos con Lima de por medio); en los demas el terrestre sigue siendo mas rapido pese a la distancia de vuelo. En los que no tienen opcion aerea el traslado es y debe seguir siendo por carretera.</a:t>
+              <a:t>De los 17 convenios con opcion aerea, en 5 el avion realmente reduce el tiempo puerta a puerta frente al terrestre (todos con Lima de por medio); en los demas el terrestre sigue siendo mas rapido pese a la distancia de vuelo. En los que no tienen opcion aerea el traslado es y debe seguir siendo por carretera.</a:t>
             </a:r>
             <a:endParaRPr lang="es-PE" sz="1500"/>
           </a:p>

</xml_diff>

<commit_message>
Corregir codigo RENIPRESS del convenio Hospital Docente de Trujillo -> Clinica Camino Real
El receptor usaba RENIPRESS 34335 (Clinica Camino Real de San Isidro,
Lima), generando un convenio ficticio Trujillo-Lima de 559 km / 10 h
24. El codigo correcto es 16830 (RS: GPS Trujillo SAC y NC: Clinica
Camino Real, Trujillo, La Libertad): es un convenio intra-Trujillo.
Se regenera la red de convenios, el Excel de tiempos y la
presentacion resumen.

Co-Authored-By: Claude Sonnet 5 <noreply@anthropic.com>
</commit_message>
<xml_diff>
--- a/datos/Resumen_tiempos_convenios_BS.pptx
+++ b/datos/Resumen_tiempos_convenios_BS.pptx
@@ -693,7 +693,7 @@
                 </a:solidFill>
                 <a:latin typeface="Calibri"/>
               </a:rPr>
-              <a:t>17 con opcion de via aerea util (origen y destino en ciudades con aeropuertos distintos).</a:t>
+              <a:t>16 con opcion de via aerea util (origen y destino en ciudades con aeropuertos distintos).</a:t>
             </a:r>
             <a:endParaRPr lang="es-PE" sz="1600"/>
           </a:p>
@@ -859,7 +859,7 @@
                 </a:solidFill>
                 <a:latin typeface="Calibri"/>
               </a:rPr>
-              <a:t>Hasta 1 h ............ 189</a:t>
+              <a:t>Hasta 1 h ............ 190</a:t>
             </a:r>
             <a:endParaRPr lang="es-PE" sz="1400"/>
           </a:p>
@@ -907,7 +907,7 @@
                 </a:solidFill>
                 <a:latin typeface="Calibri"/>
               </a:rPr>
-              <a:t>6 a 12 h ............. 6</a:t>
+              <a:t>6 a 12 h ............. 5</a:t>
             </a:r>
             <a:endParaRPr lang="es-PE" sz="1400"/>
           </a:p>
@@ -954,7 +954,7 @@
                 </a:solidFill>
                 <a:latin typeface="Calibri"/>
               </a:rPr>
-              <a:t>Conjunto completo (247 convenios): mediana 0 h 26 min, media 1 h 15 min.</a:t>
+              <a:t>Conjunto completo (247 convenios): mediana 0 h 26 min, media 1 h 12 min.</a:t>
             </a:r>
             <a:endParaRPr lang="es-PE" sz="1300"/>
           </a:p>
@@ -969,7 +969,7 @@
                 </a:solidFill>
                 <a:latin typeface="Calibri"/>
               </a:rPr>
-              <a:t>IPRESS con traslado terrestre mayor a 1 h: 58 convenios (23 % del total).</a:t>
+              <a:t>IPRESS con traslado terrestre mayor a 1 h: 57 convenios (23 % del total).</a:t>
             </a:r>
             <a:endParaRPr lang="es-PE" sz="1500"/>
           </a:p>
@@ -985,7 +985,7 @@
                 </a:solidFill>
                 <a:latin typeface="Calibri"/>
               </a:rPr>
-              <a:t>En ese grupo la mediana del tiempo de ruta es 2 h 29 min y la media es 4 h 02 min.</a:t>
+              <a:t>En ese grupo la mediana del tiempo de ruta es 2 h 28 min y la media es 3 h 55 min.</a:t>
             </a:r>
             <a:endParaRPr lang="es-PE" sz="1500"/>
           </a:p>
@@ -1000,7 +1000,7 @@
                 </a:solidFill>
                 <a:latin typeface="Calibri"/>
               </a:rPr>
-              <a:t>La media es mayor que la mediana porque unos pocos convenios inter-regionales de sierra y selva (12 h a 2 dias) elevan el promedio; para la mitad del grupo el traslado sigue por debajo de 2 h 29 min.</a:t>
+              <a:t>La media es mayor que la mediana porque unos pocos convenios inter-regionales de sierra y selva (12 h a 2 dias) elevan el promedio; para la mitad del grupo el traslado sigue por debajo de 2 h 28 min.</a:t>
             </a:r>
             <a:endParaRPr lang="es-PE" sz="1200"/>
           </a:p>
@@ -1767,102 +1767,102 @@
                         <a:rPr lang="es-PE" sz="1050">
                           <a:latin typeface="Calibri"/>
                         </a:rPr>
-                        <a:t>100</a:t>
-                      </a:r>
-                    </a:p>
-                  </a:txBody>
-                  <a:tcPr>
-                    <a:solidFill>
-                      <a:srgbClr val="FFFFFF"/>
-                    </a:solidFill>
-                  </a:tcPr>
-                </a:tc>
-                <a:tc>
-                  <a:txBody>
-                    <a:bodyPr/>
-                    <a:lstStyle/>
-                    <a:p>
-                      <a:r>
-                        <a:rPr lang="es-PE" sz="1050">
-                          <a:latin typeface="Calibri"/>
-                        </a:rPr>
-                        <a:t>HOSPITAL REGIONAL DOCENTE…</a:t>
-                      </a:r>
-                    </a:p>
-                  </a:txBody>
-                  <a:tcPr>
-                    <a:solidFill>
-                      <a:srgbClr val="FFFFFF"/>
-                    </a:solidFill>
-                  </a:tcPr>
-                </a:tc>
-                <a:tc>
-                  <a:txBody>
-                    <a:bodyPr/>
-                    <a:lstStyle/>
-                    <a:p>
-                      <a:r>
-                        <a:rPr lang="es-PE" sz="1050">
-                          <a:latin typeface="Calibri"/>
-                        </a:rPr>
-                        <a:t>CLINICA CAMINO REAL</a:t>
-                      </a:r>
-                    </a:p>
-                  </a:txBody>
-                  <a:tcPr>
-                    <a:solidFill>
-                      <a:srgbClr val="FFFFFF"/>
-                    </a:solidFill>
-                  </a:tcPr>
-                </a:tc>
-                <a:tc>
-                  <a:txBody>
-                    <a:bodyPr/>
-                    <a:lstStyle/>
-                    <a:p>
-                      <a:r>
-                        <a:rPr lang="es-PE" sz="1050">
-                          <a:latin typeface="Calibri"/>
-                        </a:rPr>
-                        <a:t>559</a:t>
-                      </a:r>
-                    </a:p>
-                  </a:txBody>
-                  <a:tcPr>
-                    <a:solidFill>
-                      <a:srgbClr val="FFFFFF"/>
-                    </a:solidFill>
-                  </a:tcPr>
-                </a:tc>
-                <a:tc>
-                  <a:txBody>
-                    <a:bodyPr/>
-                    <a:lstStyle/>
-                    <a:p>
-                      <a:r>
-                        <a:rPr lang="es-PE" sz="1050">
-                          <a:latin typeface="Calibri"/>
-                        </a:rPr>
-                        <a:t>10 h 24 min</a:t>
-                      </a:r>
-                    </a:p>
-                  </a:txBody>
-                  <a:tcPr>
-                    <a:solidFill>
-                      <a:srgbClr val="FFFFFF"/>
-                    </a:solidFill>
-                  </a:tcPr>
-                </a:tc>
-                <a:tc>
-                  <a:txBody>
-                    <a:bodyPr/>
-                    <a:lstStyle/>
-                    <a:p>
-                      <a:r>
-                        <a:rPr lang="es-PE" sz="1050">
-                          <a:latin typeface="Calibri"/>
-                        </a:rPr>
-                        <a:t>costa / llano</a:t>
+                        <a:t>57</a:t>
+                      </a:r>
+                    </a:p>
+                  </a:txBody>
+                  <a:tcPr>
+                    <a:solidFill>
+                      <a:srgbClr val="FFFFFF"/>
+                    </a:solidFill>
+                  </a:tcPr>
+                </a:tc>
+                <a:tc>
+                  <a:txBody>
+                    <a:bodyPr/>
+                    <a:lstStyle/>
+                    <a:p>
+                      <a:r>
+                        <a:rPr lang="es-PE" sz="1050">
+                          <a:latin typeface="Calibri"/>
+                        </a:rPr>
+                        <a:t>Hospital Antonio Lorena d…</a:t>
+                      </a:r>
+                    </a:p>
+                  </a:txBody>
+                  <a:tcPr>
+                    <a:solidFill>
+                      <a:srgbClr val="FFFFFF"/>
+                    </a:solidFill>
+                  </a:tcPr>
+                </a:tc>
+                <a:tc>
+                  <a:txBody>
+                    <a:bodyPr/>
+                    <a:lstStyle/>
+                    <a:p>
+                      <a:r>
+                        <a:rPr lang="es-PE" sz="1050">
+                          <a:latin typeface="Calibri"/>
+                        </a:rPr>
+                        <a:t>SR DE TORRECHAYOC</a:t>
+                      </a:r>
+                    </a:p>
+                  </a:txBody>
+                  <a:tcPr>
+                    <a:solidFill>
+                      <a:srgbClr val="FFFFFF"/>
+                    </a:solidFill>
+                  </a:tcPr>
+                </a:tc>
+                <a:tc>
+                  <a:txBody>
+                    <a:bodyPr/>
+                    <a:lstStyle/>
+                    <a:p>
+                      <a:r>
+                        <a:rPr lang="es-PE" sz="1050">
+                          <a:latin typeface="Calibri"/>
+                        </a:rPr>
+                        <a:t>202</a:t>
+                      </a:r>
+                    </a:p>
+                  </a:txBody>
+                  <a:tcPr>
+                    <a:solidFill>
+                      <a:srgbClr val="FFFFFF"/>
+                    </a:solidFill>
+                  </a:tcPr>
+                </a:tc>
+                <a:tc>
+                  <a:txBody>
+                    <a:bodyPr/>
+                    <a:lstStyle/>
+                    <a:p>
+                      <a:r>
+                        <a:rPr lang="es-PE" sz="1050">
+                          <a:latin typeface="Calibri"/>
+                        </a:rPr>
+                        <a:t>6 h 57 min</a:t>
+                      </a:r>
+                    </a:p>
+                  </a:txBody>
+                  <a:tcPr>
+                    <a:solidFill>
+                      <a:srgbClr val="FFFFFF"/>
+                    </a:solidFill>
+                  </a:tcPr>
+                </a:tc>
+                <a:tc>
+                  <a:txBody>
+                    <a:bodyPr/>
+                    <a:lstStyle/>
+                    <a:p>
+                      <a:r>
+                        <a:rPr lang="es-PE" sz="1050">
+                          <a:latin typeface="Calibri"/>
+                        </a:rPr>
+                        <a:t>sierra alta sostenida</a:t>
                       </a:r>
                     </a:p>
                   </a:txBody>
@@ -1888,7 +1888,7 @@
                         <a:rPr lang="es-PE" sz="1050">
                           <a:latin typeface="Calibri"/>
                         </a:rPr>
-                        <a:t>57</a:t>
+                        <a:t>48</a:t>
                       </a:r>
                     </a:p>
                   </a:txBody>
@@ -1926,7 +1926,7 @@
                         <a:rPr lang="es-PE" sz="1050">
                           <a:latin typeface="Calibri"/>
                         </a:rPr>
-                        <a:t>SR DE TORRECHAYOC</a:t>
+                        <a:t>QUILLABAMBA-ESSALUD</a:t>
                       </a:r>
                     </a:p>
                   </a:txBody>
@@ -2009,7 +2009,7 @@
                         <a:rPr lang="es-PE" sz="1050">
                           <a:latin typeface="Calibri"/>
                         </a:rPr>
-                        <a:t>48</a:t>
+                        <a:t>49</a:t>
                       </a:r>
                     </a:p>
                   </a:txBody>
@@ -2047,45 +2047,45 @@
                         <a:rPr lang="es-PE" sz="1050">
                           <a:latin typeface="Calibri"/>
                         </a:rPr>
-                        <a:t>QUILLABAMBA-ESSALUD</a:t>
-                      </a:r>
-                    </a:p>
-                  </a:txBody>
-                  <a:tcPr>
-                    <a:solidFill>
-                      <a:srgbClr val="FFFFFF"/>
-                    </a:solidFill>
-                  </a:tcPr>
-                </a:tc>
-                <a:tc>
-                  <a:txBody>
-                    <a:bodyPr/>
-                    <a:lstStyle/>
-                    <a:p>
-                      <a:r>
-                        <a:rPr lang="es-PE" sz="1050">
-                          <a:latin typeface="Calibri"/>
-                        </a:rPr>
-                        <a:t>202</a:t>
-                      </a:r>
-                    </a:p>
-                  </a:txBody>
-                  <a:tcPr>
-                    <a:solidFill>
-                      <a:srgbClr val="FFFFFF"/>
-                    </a:solidFill>
-                  </a:tcPr>
-                </a:tc>
-                <a:tc>
-                  <a:txBody>
-                    <a:bodyPr/>
-                    <a:lstStyle/>
-                    <a:p>
-                      <a:r>
-                        <a:rPr lang="es-PE" sz="1050">
-                          <a:latin typeface="Calibri"/>
-                        </a:rPr>
-                        <a:t>6 h 57 min</a:t>
+                        <a:t>HOSPITAL DE ESPINAR</a:t>
+                      </a:r>
+                    </a:p>
+                  </a:txBody>
+                  <a:tcPr>
+                    <a:solidFill>
+                      <a:srgbClr val="FFFFFF"/>
+                    </a:solidFill>
+                  </a:tcPr>
+                </a:tc>
+                <a:tc>
+                  <a:txBody>
+                    <a:bodyPr/>
+                    <a:lstStyle/>
+                    <a:p>
+                      <a:r>
+                        <a:rPr lang="es-PE" sz="1050">
+                          <a:latin typeface="Calibri"/>
+                        </a:rPr>
+                        <a:t>221</a:t>
+                      </a:r>
+                    </a:p>
+                  </a:txBody>
+                  <a:tcPr>
+                    <a:solidFill>
+                      <a:srgbClr val="FFFFFF"/>
+                    </a:solidFill>
+                  </a:tcPr>
+                </a:tc>
+                <a:tc>
+                  <a:txBody>
+                    <a:bodyPr/>
+                    <a:lstStyle/>
+                    <a:p>
+                      <a:r>
+                        <a:rPr lang="es-PE" sz="1050">
+                          <a:latin typeface="Calibri"/>
+                        </a:rPr>
+                        <a:t>6 h 09 min</a:t>
                       </a:r>
                     </a:p>
                   </a:txBody>
@@ -2130,83 +2130,83 @@
                         <a:rPr lang="es-PE" sz="1050">
                           <a:latin typeface="Calibri"/>
                         </a:rPr>
-                        <a:t>49</a:t>
-                      </a:r>
-                    </a:p>
-                  </a:txBody>
-                  <a:tcPr>
-                    <a:solidFill>
-                      <a:srgbClr val="EEF1F6"/>
-                    </a:solidFill>
-                  </a:tcPr>
-                </a:tc>
-                <a:tc>
-                  <a:txBody>
-                    <a:bodyPr/>
-                    <a:lstStyle/>
-                    <a:p>
-                      <a:r>
-                        <a:rPr lang="es-PE" sz="1050">
-                          <a:latin typeface="Calibri"/>
-                        </a:rPr>
-                        <a:t>Hospital Antonio Lorena d…</a:t>
-                      </a:r>
-                    </a:p>
-                  </a:txBody>
-                  <a:tcPr>
-                    <a:solidFill>
-                      <a:srgbClr val="EEF1F6"/>
-                    </a:solidFill>
-                  </a:tcPr>
-                </a:tc>
-                <a:tc>
-                  <a:txBody>
-                    <a:bodyPr/>
-                    <a:lstStyle/>
-                    <a:p>
-                      <a:r>
-                        <a:rPr lang="es-PE" sz="1050">
-                          <a:latin typeface="Calibri"/>
-                        </a:rPr>
-                        <a:t>HOSPITAL DE ESPINAR</a:t>
-                      </a:r>
-                    </a:p>
-                  </a:txBody>
-                  <a:tcPr>
-                    <a:solidFill>
-                      <a:srgbClr val="EEF1F6"/>
-                    </a:solidFill>
-                  </a:tcPr>
-                </a:tc>
-                <a:tc>
-                  <a:txBody>
-                    <a:bodyPr/>
-                    <a:lstStyle/>
-                    <a:p>
-                      <a:r>
-                        <a:rPr lang="es-PE" sz="1050">
-                          <a:latin typeface="Calibri"/>
-                        </a:rPr>
-                        <a:t>221</a:t>
-                      </a:r>
-                    </a:p>
-                  </a:txBody>
-                  <a:tcPr>
-                    <a:solidFill>
-                      <a:srgbClr val="EEF1F6"/>
-                    </a:solidFill>
-                  </a:tcPr>
-                </a:tc>
-                <a:tc>
-                  <a:txBody>
-                    <a:bodyPr/>
-                    <a:lstStyle/>
-                    <a:p>
-                      <a:r>
-                        <a:rPr lang="es-PE" sz="1050">
-                          <a:latin typeface="Calibri"/>
-                        </a:rPr>
-                        <a:t>6 h 09 min</a:t>
+                        <a:t>40</a:t>
+                      </a:r>
+                    </a:p>
+                  </a:txBody>
+                  <a:tcPr>
+                    <a:solidFill>
+                      <a:srgbClr val="EEF1F6"/>
+                    </a:solidFill>
+                  </a:tcPr>
+                </a:tc>
+                <a:tc>
+                  <a:txBody>
+                    <a:bodyPr/>
+                    <a:lstStyle/>
+                    <a:p>
+                      <a:r>
+                        <a:rPr lang="es-PE" sz="1050">
+                          <a:latin typeface="Calibri"/>
+                        </a:rPr>
+                        <a:t>Hospital Regional de Ayac…</a:t>
+                      </a:r>
+                    </a:p>
+                  </a:txBody>
+                  <a:tcPr>
+                    <a:solidFill>
+                      <a:srgbClr val="EEF1F6"/>
+                    </a:solidFill>
+                  </a:tcPr>
+                </a:tc>
+                <a:tc>
+                  <a:txBody>
+                    <a:bodyPr/>
+                    <a:lstStyle/>
+                    <a:p>
+                      <a:r>
+                        <a:rPr lang="es-PE" sz="1050">
+                          <a:latin typeface="Calibri"/>
+                        </a:rPr>
+                        <a:t>SAN JUAN DE KIMBIRI-VRAEM</a:t>
+                      </a:r>
+                    </a:p>
+                  </a:txBody>
+                  <a:tcPr>
+                    <a:solidFill>
+                      <a:srgbClr val="EEF1F6"/>
+                    </a:solidFill>
+                  </a:tcPr>
+                </a:tc>
+                <a:tc>
+                  <a:txBody>
+                    <a:bodyPr/>
+                    <a:lstStyle/>
+                    <a:p>
+                      <a:r>
+                        <a:rPr lang="es-PE" sz="1050">
+                          <a:latin typeface="Calibri"/>
+                        </a:rPr>
+                        <a:t>186</a:t>
+                      </a:r>
+                    </a:p>
+                  </a:txBody>
+                  <a:tcPr>
+                    <a:solidFill>
+                      <a:srgbClr val="EEF1F6"/>
+                    </a:solidFill>
+                  </a:tcPr>
+                </a:tc>
+                <a:tc>
+                  <a:txBody>
+                    <a:bodyPr/>
+                    <a:lstStyle/>
+                    <a:p>
+                      <a:r>
+                        <a:rPr lang="es-PE" sz="1050">
+                          <a:latin typeface="Calibri"/>
+                        </a:rPr>
+                        <a:t>6 h 04 min</a:t>
                       </a:r>
                     </a:p>
                   </a:txBody>
@@ -2251,83 +2251,83 @@
                         <a:rPr lang="es-PE" sz="1050">
                           <a:latin typeface="Calibri"/>
                         </a:rPr>
-                        <a:t>40</a:t>
-                      </a:r>
-                    </a:p>
-                  </a:txBody>
-                  <a:tcPr>
-                    <a:solidFill>
-                      <a:srgbClr val="FFFFFF"/>
-                    </a:solidFill>
-                  </a:tcPr>
-                </a:tc>
-                <a:tc>
-                  <a:txBody>
-                    <a:bodyPr/>
-                    <a:lstStyle/>
-                    <a:p>
-                      <a:r>
-                        <a:rPr lang="es-PE" sz="1050">
-                          <a:latin typeface="Calibri"/>
-                        </a:rPr>
-                        <a:t>Hospital Regional de Ayac…</a:t>
-                      </a:r>
-                    </a:p>
-                  </a:txBody>
-                  <a:tcPr>
-                    <a:solidFill>
-                      <a:srgbClr val="FFFFFF"/>
-                    </a:solidFill>
-                  </a:tcPr>
-                </a:tc>
-                <a:tc>
-                  <a:txBody>
-                    <a:bodyPr/>
-                    <a:lstStyle/>
-                    <a:p>
-                      <a:r>
-                        <a:rPr lang="es-PE" sz="1050">
-                          <a:latin typeface="Calibri"/>
-                        </a:rPr>
-                        <a:t>SAN JUAN DE KIMBIRI-VRAEM</a:t>
-                      </a:r>
-                    </a:p>
-                  </a:txBody>
-                  <a:tcPr>
-                    <a:solidFill>
-                      <a:srgbClr val="FFFFFF"/>
-                    </a:solidFill>
-                  </a:tcPr>
-                </a:tc>
-                <a:tc>
-                  <a:txBody>
-                    <a:bodyPr/>
-                    <a:lstStyle/>
-                    <a:p>
-                      <a:r>
-                        <a:rPr lang="es-PE" sz="1050">
-                          <a:latin typeface="Calibri"/>
-                        </a:rPr>
-                        <a:t>186</a:t>
-                      </a:r>
-                    </a:p>
-                  </a:txBody>
-                  <a:tcPr>
-                    <a:solidFill>
-                      <a:srgbClr val="FFFFFF"/>
-                    </a:solidFill>
-                  </a:tcPr>
-                </a:tc>
-                <a:tc>
-                  <a:txBody>
-                    <a:bodyPr/>
-                    <a:lstStyle/>
-                    <a:p>
-                      <a:r>
-                        <a:rPr lang="es-PE" sz="1050">
-                          <a:latin typeface="Calibri"/>
-                        </a:rPr>
-                        <a:t>6 h 04 min</a:t>
+                        <a:t>241</a:t>
+                      </a:r>
+                    </a:p>
+                  </a:txBody>
+                  <a:tcPr>
+                    <a:solidFill>
+                      <a:srgbClr val="FFFFFF"/>
+                    </a:solidFill>
+                  </a:tcPr>
+                </a:tc>
+                <a:tc>
+                  <a:txBody>
+                    <a:bodyPr/>
+                    <a:lstStyle/>
+                    <a:p>
+                      <a:r>
+                        <a:rPr lang="es-PE" sz="1050">
+                          <a:latin typeface="Calibri"/>
+                        </a:rPr>
+                        <a:t>HOSPITAL II PASCO</a:t>
+                      </a:r>
+                    </a:p>
+                  </a:txBody>
+                  <a:tcPr>
+                    <a:solidFill>
+                      <a:srgbClr val="FFFFFF"/>
+                    </a:solidFill>
+                  </a:tcPr>
+                </a:tc>
+                <a:tc>
+                  <a:txBody>
+                    <a:bodyPr/>
+                    <a:lstStyle/>
+                    <a:p>
+                      <a:r>
+                        <a:rPr lang="es-PE" sz="1050">
+                          <a:latin typeface="Calibri"/>
+                        </a:rPr>
+                        <a:t>HOSPITAL I OXAPAMPA</a:t>
+                      </a:r>
+                    </a:p>
+                  </a:txBody>
+                  <a:tcPr>
+                    <a:solidFill>
+                      <a:srgbClr val="FFFFFF"/>
+                    </a:solidFill>
+                  </a:tcPr>
+                </a:tc>
+                <a:tc>
+                  <a:txBody>
+                    <a:bodyPr/>
+                    <a:lstStyle/>
+                    <a:p>
+                      <a:r>
+                        <a:rPr lang="es-PE" sz="1050">
+                          <a:latin typeface="Calibri"/>
+                        </a:rPr>
+                        <a:t>175</a:t>
+                      </a:r>
+                    </a:p>
+                  </a:txBody>
+                  <a:tcPr>
+                    <a:solidFill>
+                      <a:srgbClr val="FFFFFF"/>
+                    </a:solidFill>
+                  </a:tcPr>
+                </a:tc>
+                <a:tc>
+                  <a:txBody>
+                    <a:bodyPr/>
+                    <a:lstStyle/>
+                    <a:p>
+                      <a:r>
+                        <a:rPr lang="es-PE" sz="1050">
+                          <a:latin typeface="Calibri"/>
+                        </a:rPr>
+                        <a:t>6 h 02 min</a:t>
                       </a:r>
                     </a:p>
                   </a:txBody>
@@ -2372,45 +2372,45 @@
                         <a:rPr lang="es-PE" sz="1050">
                           <a:latin typeface="Calibri"/>
                         </a:rPr>
-                        <a:t>241</a:t>
-                      </a:r>
-                    </a:p>
-                  </a:txBody>
-                  <a:tcPr>
-                    <a:solidFill>
-                      <a:srgbClr val="EEF1F6"/>
-                    </a:solidFill>
-                  </a:tcPr>
-                </a:tc>
-                <a:tc>
-                  <a:txBody>
-                    <a:bodyPr/>
-                    <a:lstStyle/>
-                    <a:p>
-                      <a:r>
-                        <a:rPr lang="es-PE" sz="1050">
-                          <a:latin typeface="Calibri"/>
-                        </a:rPr>
-                        <a:t>HOSPITAL II PASCO</a:t>
-                      </a:r>
-                    </a:p>
-                  </a:txBody>
-                  <a:tcPr>
-                    <a:solidFill>
-                      <a:srgbClr val="EEF1F6"/>
-                    </a:solidFill>
-                  </a:tcPr>
-                </a:tc>
-                <a:tc>
-                  <a:txBody>
-                    <a:bodyPr/>
-                    <a:lstStyle/>
-                    <a:p>
-                      <a:r>
-                        <a:rPr lang="es-PE" sz="1050">
-                          <a:latin typeface="Calibri"/>
-                        </a:rPr>
-                        <a:t>HOSPITAL I OXAPAMPA</a:t>
+                        <a:t>41</a:t>
+                      </a:r>
+                    </a:p>
+                  </a:txBody>
+                  <a:tcPr>
+                    <a:solidFill>
+                      <a:srgbClr val="EEF1F6"/>
+                    </a:solidFill>
+                  </a:tcPr>
+                </a:tc>
+                <a:tc>
+                  <a:txBody>
+                    <a:bodyPr/>
+                    <a:lstStyle/>
+                    <a:p>
+                      <a:r>
+                        <a:rPr lang="es-PE" sz="1050">
+                          <a:latin typeface="Calibri"/>
+                        </a:rPr>
+                        <a:t>Hospital Regional de Ayac…</a:t>
+                      </a:r>
+                    </a:p>
+                  </a:txBody>
+                  <a:tcPr>
+                    <a:solidFill>
+                      <a:srgbClr val="EEF1F6"/>
+                    </a:solidFill>
+                  </a:tcPr>
+                </a:tc>
+                <a:tc>
+                  <a:txBody>
+                    <a:bodyPr/>
+                    <a:lstStyle/>
+                    <a:p>
+                      <a:r>
+                        <a:rPr lang="es-PE" sz="1050">
+                          <a:latin typeface="Calibri"/>
+                        </a:rPr>
+                        <a:t>HOSPITAL DE APOYO SAN FRA…</a:t>
                       </a:r>
                     </a:p>
                   </a:txBody>
@@ -2448,7 +2448,7 @@
                         <a:rPr lang="es-PE" sz="1050">
                           <a:latin typeface="Calibri"/>
                         </a:rPr>
-                        <a:t>6 h 02 min</a:t>
+                        <a:t>5 h 25 min</a:t>
                       </a:r>
                     </a:p>
                   </a:txBody>
@@ -2493,83 +2493,83 @@
                         <a:rPr lang="es-PE" sz="1050">
                           <a:latin typeface="Calibri"/>
                         </a:rPr>
-                        <a:t>41</a:t>
-                      </a:r>
-                    </a:p>
-                  </a:txBody>
-                  <a:tcPr>
-                    <a:solidFill>
-                      <a:srgbClr val="FFFFFF"/>
-                    </a:solidFill>
-                  </a:tcPr>
-                </a:tc>
-                <a:tc>
-                  <a:txBody>
-                    <a:bodyPr/>
-                    <a:lstStyle/>
-                    <a:p>
-                      <a:r>
-                        <a:rPr lang="es-PE" sz="1050">
-                          <a:latin typeface="Calibri"/>
-                        </a:rPr>
-                        <a:t>Hospital Regional de Ayac…</a:t>
-                      </a:r>
-                    </a:p>
-                  </a:txBody>
-                  <a:tcPr>
-                    <a:solidFill>
-                      <a:srgbClr val="FFFFFF"/>
-                    </a:solidFill>
-                  </a:tcPr>
-                </a:tc>
-                <a:tc>
-                  <a:txBody>
-                    <a:bodyPr/>
-                    <a:lstStyle/>
-                    <a:p>
-                      <a:r>
-                        <a:rPr lang="es-PE" sz="1050">
-                          <a:latin typeface="Calibri"/>
-                        </a:rPr>
-                        <a:t>HOSPITAL DE APOYO SAN FRA…</a:t>
-                      </a:r>
-                    </a:p>
-                  </a:txBody>
-                  <a:tcPr>
-                    <a:solidFill>
-                      <a:srgbClr val="FFFFFF"/>
-                    </a:solidFill>
-                  </a:tcPr>
-                </a:tc>
-                <a:tc>
-                  <a:txBody>
-                    <a:bodyPr/>
-                    <a:lstStyle/>
-                    <a:p>
-                      <a:r>
-                        <a:rPr lang="es-PE" sz="1050">
-                          <a:latin typeface="Calibri"/>
-                        </a:rPr>
-                        <a:t>175</a:t>
-                      </a:r>
-                    </a:p>
-                  </a:txBody>
-                  <a:tcPr>
-                    <a:solidFill>
-                      <a:srgbClr val="FFFFFF"/>
-                    </a:solidFill>
-                  </a:tcPr>
-                </a:tc>
-                <a:tc>
-                  <a:txBody>
-                    <a:bodyPr/>
-                    <a:lstStyle/>
-                    <a:p>
-                      <a:r>
-                        <a:rPr lang="es-PE" sz="1050">
-                          <a:latin typeface="Calibri"/>
-                        </a:rPr>
-                        <a:t>5 h 25 min</a:t>
+                        <a:t>51</a:t>
+                      </a:r>
+                    </a:p>
+                  </a:txBody>
+                  <a:tcPr>
+                    <a:solidFill>
+                      <a:srgbClr val="FFFFFF"/>
+                    </a:solidFill>
+                  </a:tcPr>
+                </a:tc>
+                <a:tc>
+                  <a:txBody>
+                    <a:bodyPr/>
+                    <a:lstStyle/>
+                    <a:p>
+                      <a:r>
+                        <a:rPr lang="es-PE" sz="1050">
+                          <a:latin typeface="Calibri"/>
+                        </a:rPr>
+                        <a:t>Hospital Antonio Lorena d…</a:t>
+                      </a:r>
+                    </a:p>
+                  </a:txBody>
+                  <a:tcPr>
+                    <a:solidFill>
+                      <a:srgbClr val="FFFFFF"/>
+                    </a:solidFill>
+                  </a:tcPr>
+                </a:tc>
+                <a:tc>
+                  <a:txBody>
+                    <a:bodyPr/>
+                    <a:lstStyle/>
+                    <a:p>
+                      <a:r>
+                        <a:rPr lang="es-PE" sz="1050">
+                          <a:latin typeface="Calibri"/>
+                        </a:rPr>
+                        <a:t>HOSPITAL DE SANTO TOMAS</a:t>
+                      </a:r>
+                    </a:p>
+                  </a:txBody>
+                  <a:tcPr>
+                    <a:solidFill>
+                      <a:srgbClr val="FFFFFF"/>
+                    </a:solidFill>
+                  </a:tcPr>
+                </a:tc>
+                <a:tc>
+                  <a:txBody>
+                    <a:bodyPr/>
+                    <a:lstStyle/>
+                    <a:p>
+                      <a:r>
+                        <a:rPr lang="es-PE" sz="1050">
+                          <a:latin typeface="Calibri"/>
+                        </a:rPr>
+                        <a:t>219</a:t>
+                      </a:r>
+                    </a:p>
+                  </a:txBody>
+                  <a:tcPr>
+                    <a:solidFill>
+                      <a:srgbClr val="FFFFFF"/>
+                    </a:solidFill>
+                  </a:tcPr>
+                </a:tc>
+                <a:tc>
+                  <a:txBody>
+                    <a:bodyPr/>
+                    <a:lstStyle/>
+                    <a:p>
+                      <a:r>
+                        <a:rPr lang="es-PE" sz="1050">
+                          <a:latin typeface="Calibri"/>
+                        </a:rPr>
+                        <a:t>5 h 21 min</a:t>
                       </a:r>
                     </a:p>
                   </a:txBody>
@@ -2614,83 +2614,83 @@
                         <a:rPr lang="es-PE" sz="1050">
                           <a:latin typeface="Calibri"/>
                         </a:rPr>
-                        <a:t>51</a:t>
-                      </a:r>
-                    </a:p>
-                  </a:txBody>
-                  <a:tcPr>
-                    <a:solidFill>
-                      <a:srgbClr val="EEF1F6"/>
-                    </a:solidFill>
-                  </a:tcPr>
-                </a:tc>
-                <a:tc>
-                  <a:txBody>
-                    <a:bodyPr/>
-                    <a:lstStyle/>
-                    <a:p>
-                      <a:r>
-                        <a:rPr lang="es-PE" sz="1050">
-                          <a:latin typeface="Calibri"/>
-                        </a:rPr>
-                        <a:t>Hospital Antonio Lorena d…</a:t>
-                      </a:r>
-                    </a:p>
-                  </a:txBody>
-                  <a:tcPr>
-                    <a:solidFill>
-                      <a:srgbClr val="EEF1F6"/>
-                    </a:solidFill>
-                  </a:tcPr>
-                </a:tc>
-                <a:tc>
-                  <a:txBody>
-                    <a:bodyPr/>
-                    <a:lstStyle/>
-                    <a:p>
-                      <a:r>
-                        <a:rPr lang="es-PE" sz="1050">
-                          <a:latin typeface="Calibri"/>
-                        </a:rPr>
-                        <a:t>HOSPITAL DE SANTO TOMAS</a:t>
-                      </a:r>
-                    </a:p>
-                  </a:txBody>
-                  <a:tcPr>
-                    <a:solidFill>
-                      <a:srgbClr val="EEF1F6"/>
-                    </a:solidFill>
-                  </a:tcPr>
-                </a:tc>
-                <a:tc>
-                  <a:txBody>
-                    <a:bodyPr/>
-                    <a:lstStyle/>
-                    <a:p>
-                      <a:r>
-                        <a:rPr lang="es-PE" sz="1050">
-                          <a:latin typeface="Calibri"/>
-                        </a:rPr>
-                        <a:t>219</a:t>
-                      </a:r>
-                    </a:p>
-                  </a:txBody>
-                  <a:tcPr>
-                    <a:solidFill>
-                      <a:srgbClr val="EEF1F6"/>
-                    </a:solidFill>
-                  </a:tcPr>
-                </a:tc>
-                <a:tc>
-                  <a:txBody>
-                    <a:bodyPr/>
-                    <a:lstStyle/>
-                    <a:p>
-                      <a:r>
-                        <a:rPr lang="es-PE" sz="1050">
-                          <a:latin typeface="Calibri"/>
-                        </a:rPr>
-                        <a:t>5 h 21 min</a:t>
+                        <a:t>69</a:t>
+                      </a:r>
+                    </a:p>
+                  </a:txBody>
+                  <a:tcPr>
+                    <a:solidFill>
+                      <a:srgbClr val="EEF1F6"/>
+                    </a:solidFill>
+                  </a:tcPr>
+                </a:tc>
+                <a:tc>
+                  <a:txBody>
+                    <a:bodyPr/>
+                    <a:lstStyle/>
+                    <a:p>
+                      <a:r>
+                        <a:rPr lang="es-PE" sz="1050">
+                          <a:latin typeface="Calibri"/>
+                        </a:rPr>
+                        <a:t>Hospital Regional Docente…</a:t>
+                      </a:r>
+                    </a:p>
+                  </a:txBody>
+                  <a:tcPr>
+                    <a:solidFill>
+                      <a:srgbClr val="EEF1F6"/>
+                    </a:solidFill>
+                  </a:tcPr>
+                </a:tc>
+                <a:tc>
+                  <a:txBody>
+                    <a:bodyPr/>
+                    <a:lstStyle/>
+                    <a:p>
+                      <a:r>
+                        <a:rPr lang="es-PE" sz="1050">
+                          <a:latin typeface="Calibri"/>
+                        </a:rPr>
+                        <a:t>HOSPITAL DE LIRCAY</a:t>
+                      </a:r>
+                    </a:p>
+                  </a:txBody>
+                  <a:tcPr>
+                    <a:solidFill>
+                      <a:srgbClr val="EEF1F6"/>
+                    </a:solidFill>
+                  </a:tcPr>
+                </a:tc>
+                <a:tc>
+                  <a:txBody>
+                    <a:bodyPr/>
+                    <a:lstStyle/>
+                    <a:p>
+                      <a:r>
+                        <a:rPr lang="es-PE" sz="1050">
+                          <a:latin typeface="Calibri"/>
+                        </a:rPr>
+                        <a:t>210</a:t>
+                      </a:r>
+                    </a:p>
+                  </a:txBody>
+                  <a:tcPr>
+                    <a:solidFill>
+                      <a:srgbClr val="EEF1F6"/>
+                    </a:solidFill>
+                  </a:tcPr>
+                </a:tc>
+                <a:tc>
+                  <a:txBody>
+                    <a:bodyPr/>
+                    <a:lstStyle/>
+                    <a:p>
+                      <a:r>
+                        <a:rPr lang="es-PE" sz="1050">
+                          <a:latin typeface="Calibri"/>
+                        </a:rPr>
+                        <a:t>5 h 14 min</a:t>
                       </a:r>
                     </a:p>
                   </a:txBody>
@@ -2787,7 +2787,7 @@
                 </a:solidFill>
                 <a:latin typeface="Calibri"/>
               </a:rPr>
-              <a:t>Via aerea - 17 convenios con opcion aerea (por tiempo)</a:t>
+              <a:t>Via aerea - 16 convenios con opcion aerea (por tiempo)</a:t>
             </a:r>
             <a:endParaRPr lang="es-PE" sz="2600"/>
           </a:p>
@@ -3792,7 +3792,7 @@
                         <a:rPr lang="es-PE" sz="1050">
                           <a:latin typeface="Calibri"/>
                         </a:rPr>
-                        <a:t>260</a:t>
+                        <a:t>264</a:t>
                       </a:r>
                     </a:p>
                   </a:txBody>
@@ -3868,7 +3868,7 @@
                         <a:rPr lang="es-PE" sz="1050">
                           <a:latin typeface="Calibri"/>
                         </a:rPr>
-                        <a:t>Nombre comercial: Centr…</a:t>
+                        <a:t>HOSPITAL DE RIOJA</a:t>
                       </a:r>
                     </a:p>
                   </a:txBody>
@@ -3894,7 +3894,7 @@
                         <a:rPr lang="es-PE" sz="1050">
                           <a:latin typeface="Calibri"/>
                         </a:rPr>
-                        <a:t>264</a:t>
+                        <a:t>270</a:t>
                       </a:r>
                     </a:p>
                   </a:txBody>
@@ -3970,7 +3970,7 @@
                         <a:rPr lang="es-PE" sz="1050">
                           <a:latin typeface="Calibri"/>
                         </a:rPr>
-                        <a:t>HOSPITAL DE RIOJA</a:t>
+                        <a:t>CLINICA SINAI</a:t>
                       </a:r>
                     </a:p>
                   </a:txBody>
@@ -4088,7 +4088,7 @@
                 </a:solidFill>
                 <a:latin typeface="Calibri"/>
               </a:rPr>
-              <a:t>La via aerea solo se evalua cuando origen y destino usan aeropuertos distintos con servicio comercial; por eso solo 17 de 277 convenios la tienen.</a:t>
+              <a:t>La via aerea solo se evalua cuando origen y destino usan aeropuertos distintos con servicio comercial; por eso solo 16 de 277 convenios la tienen.</a:t>
             </a:r>
             <a:endParaRPr lang="es-PE" sz="1500"/>
           </a:p>
@@ -4104,7 +4104,7 @@
                 </a:solidFill>
                 <a:latin typeface="Calibri"/>
               </a:rPr>
-              <a:t>Rutas largas reales donde el avion es la opcion sensata (el terrestre de la misma fila es varias veces mas largo): Lima-Piura (LIM-PIU, 2 h 44-2 h 48 vs 18 h 20-18 h 21 por tierra), Lima-Arequipa (LIM-AQP, 3 h 06 vs 17 h 36), Lima-Chiclayo (LIM-CIX, 2 h 39 vs 14 h 56), Trujillo-Lima (TRU-LIM, 2 h 38 vs 10 h 24).</a:t>
+              <a:t>Rutas largas reales donde el avion es la opcion sensata (el terrestre de la misma fila es varias veces mas largo): Lima-Piura (LIM-PIU, 2 h 44-2 h 48 vs 18 h 20-18 h 21 por tierra), Lima-Arequipa (LIM-AQP, 3 h 06 vs 17 h 36), Lima-Chiclayo (LIM-CIX, 2 h 39 vs 14 h 56).</a:t>
             </a:r>
             <a:endParaRPr lang="es-PE" sz="1500"/>
           </a:p>
@@ -4421,7 +4421,7 @@
                 </a:solidFill>
                 <a:latin typeface="Calibri"/>
               </a:rPr>
-              <a:t>De los 17 convenios con opcion aerea, en 5 el avion realmente reduce el tiempo puerta a puerta frente al terrestre (todos con Lima de por medio); en los demas el terrestre sigue siendo mas rapido pese a la distancia de vuelo. En los que no tienen opcion aerea el traslado es y debe seguir siendo por carretera.</a:t>
+              <a:t>De los 16 convenios con opcion aerea, en 5 el avion realmente reduce el tiempo puerta a puerta frente al terrestre (todos con Lima de por medio); en los demas el terrestre sigue siendo mas rapido pese a la distancia de vuelo. En los que no tienen opcion aerea el traslado es y debe seguir siendo por carretera.</a:t>
             </a:r>
             <a:endParaRPr lang="es-PE" sz="1500"/>
           </a:p>

</xml_diff>

<commit_message>
Excluir convenios con opcion aerea de la media/mediana/desv. estandar terrestre; agregar anexo grafico
Para los convenios donde ya existe una alternativa aerea util, el
traslado real conviene por aire, no por tierra: se excluyen del
calculo de media, mediana y desviacion estandar del tiempo terrestre
(231 de 247 convenios). Se agrega una diapositiva de anexo con un
grafico de dispersion (puntos ordenados) mostrando las bandas de
1 y 2 desviaciones estandar y los valores atipicos.

Co-Authored-By: Claude Sonnet 5 <noreply@anthropic.com>
</commit_message>
<xml_diff>
--- a/datos/Resumen_tiempos_convenios_BS.pptx
+++ b/datos/Resumen_tiempos_convenios_BS.pptx
@@ -13,6 +13,7 @@
     <p:sldId id="261" r:id="rId7"/>
     <p:sldId id="262" r:id="rId8"/>
     <p:sldId id="263" r:id="rId9"/>
+    <p:sldId id="264" r:id="rId10"/>
   </p:sldIdLst>
   <p:sldSz cx="12192000" cy="6858000"/>
   <p:notesSz cx="6858000" cy="9144000"/>
@@ -804,7 +805,7 @@
                 </a:solidFill>
                 <a:latin typeface="Calibri"/>
               </a:rPr>
-              <a:t>Via terrestre - distribucion de tiempos</a:t>
+              <a:t>Via terrestre - distribucion de tiempos (sin via aerea)</a:t>
             </a:r>
             <a:endParaRPr lang="es-PE" sz="2600"/>
           </a:p>
@@ -837,13 +838,29 @@
               <a:buNone/>
             </a:pPr>
             <a:r>
+              <a:rPr lang="es-PE" sz="1300" dirty="0">
+                <a:solidFill>
+                  <a:srgbClr val="022300"/>
+                </a:solidFill>
+                <a:latin typeface="Calibri"/>
+              </a:rPr>
+              <a:t>Distribucion de los 231 convenios por tiempo de traslado terrestre, EXCLUYENDO los 16 convenios con opcion aerea util (en esos casos el traslado real conviene por aire, no por tierra):</a:t>
+            </a:r>
+            <a:endParaRPr lang="es-PE" sz="1300"/>
+          </a:p>
+          <a:p>
+            <a:pPr marL="0" lvl="0">
+              <a:buFont typeface="Arial"/>
+              <a:buChar char="•"/>
+            </a:pPr>
+            <a:r>
               <a:rPr lang="es-PE" sz="1400" dirty="0">
                 <a:solidFill>
                   <a:srgbClr val="022300"/>
                 </a:solidFill>
                 <a:latin typeface="Calibri"/>
               </a:rPr>
-              <a:t>Distribucion de los 247 convenios por tiempo de traslado terrestre (auto particular):</a:t>
+              <a:t>Hasta 1 h ............ 189</a:t>
             </a:r>
             <a:endParaRPr lang="es-PE" sz="1400"/>
           </a:p>
@@ -859,7 +876,7 @@
                 </a:solidFill>
                 <a:latin typeface="Calibri"/>
               </a:rPr>
-              <a:t>Hasta 1 h ............ 190</a:t>
+              <a:t>1 a 3 h .............. 30</a:t>
             </a:r>
             <a:endParaRPr lang="es-PE" sz="1400"/>
           </a:p>
@@ -875,23 +892,7 @@
                 </a:solidFill>
                 <a:latin typeface="Calibri"/>
               </a:rPr>
-              <a:t>1 a 3 h .............. 37</a:t>
-            </a:r>
-            <a:endParaRPr lang="es-PE" sz="1400"/>
-          </a:p>
-          <a:p>
-            <a:pPr marL="0" lvl="0">
-              <a:buFont typeface="Arial"/>
-              <a:buChar char="•"/>
-            </a:pPr>
-            <a:r>
-              <a:rPr lang="es-PE" sz="1400" dirty="0">
-                <a:solidFill>
-                  <a:srgbClr val="022300"/>
-                </a:solidFill>
-                <a:latin typeface="Calibri"/>
-              </a:rPr>
-              <a:t>3 a 6 h .............. 11</a:t>
+              <a:t>3 a 6 h .............. 7</a:t>
             </a:r>
             <a:endParaRPr lang="es-PE" sz="1400"/>
           </a:p>
@@ -923,7 +924,7 @@
                 </a:solidFill>
                 <a:latin typeface="Calibri"/>
               </a:rPr>
-              <a:t>12 a 24 h ............ 4</a:t>
+              <a:t>12 a 24 h ............ 0</a:t>
             </a:r>
             <a:endParaRPr lang="es-PE" sz="1400"/>
           </a:p>
@@ -948,13 +949,13 @@
               <a:buNone/>
             </a:pPr>
             <a:r>
-              <a:rPr lang="es-PE" sz="1300" dirty="0">
+              <a:rPr lang="es-PE" sz="1300" b="1" dirty="0">
                 <a:solidFill>
                   <a:srgbClr val="7A8699"/>
                 </a:solidFill>
                 <a:latin typeface="Calibri"/>
               </a:rPr>
-              <a:t>Conjunto completo (247 convenios): mediana 0 h 26 min, media 1 h 12 min.</a:t>
+              <a:t>Sin via aerea (231 convenios): mediana 0 h 24 min, media 0 h 50 min, desviacion estandar 1 h 12 min.</a:t>
             </a:r>
             <a:endParaRPr lang="es-PE" sz="1300"/>
           </a:p>
@@ -969,7 +970,7 @@
                 </a:solidFill>
                 <a:latin typeface="Calibri"/>
               </a:rPr>
-              <a:t>IPRESS con traslado terrestre mayor a 1 h: 57 convenios (23 % del total).</a:t>
+              <a:t>IPRESS con traslado terrestre mayor a 1 h: 42 convenios (18 % del subconjunto sin via aerea).</a:t>
             </a:r>
             <a:endParaRPr lang="es-PE" sz="1500"/>
           </a:p>
@@ -985,7 +986,7 @@
                 </a:solidFill>
                 <a:latin typeface="Calibri"/>
               </a:rPr>
-              <a:t>En ese grupo la mediana del tiempo de ruta es 2 h 28 min y la media es 3 h 55 min.</a:t>
+              <a:t>En ese grupo la mediana del tiempo de ruta es 2 h 16 min y la media es 2 h 51 min.</a:t>
             </a:r>
             <a:endParaRPr lang="es-PE" sz="1500"/>
           </a:p>
@@ -1000,7 +1001,7 @@
                 </a:solidFill>
                 <a:latin typeface="Calibri"/>
               </a:rPr>
-              <a:t>La media es mayor que la mediana porque unos pocos convenios inter-regionales de sierra y selva (12 h a 2 dias) elevan el promedio; para la mitad del grupo el traslado sigue por debajo de 2 h 28 min.</a:t>
+              <a:t>La media es mayor que la mediana porque unos pocos convenios de sierra (Cusco, Ayacucho) elevan el promedio; para la mitad del grupo el traslado sigue por debajo de 2 h 16 min. Ver el detalle punto a punto y las bandas de desviacion estandar en el anexo (ultima diapositiva).</a:t>
             </a:r>
             <a:endParaRPr lang="es-PE" sz="1200"/>
           </a:p>
@@ -4451,6 +4452,94 @@
 </p:sld>
 </file>
 
+<file path=ppt/slides/slide9.xml><?xml version="1.0" encoding="utf-8"?>
+<p:sld xmlns:a="http://schemas.openxmlformats.org/drawingml/2006/main" xmlns:r="http://schemas.openxmlformats.org/officeDocument/2006/relationships" xmlns:p="http://schemas.openxmlformats.org/presentationml/2006/main">
+  <p:cSld>
+    <p:spTree>
+      <p:nvGrpSpPr>
+        <p:cNvPr id="1" name=""/>
+        <p:cNvGrpSpPr/>
+        <p:nvPr/>
+      </p:nvGrpSpPr>
+      <p:grpSpPr>
+        <a:xfrm>
+          <a:off x="0" y="0"/>
+          <a:ext cx="0" cy="0"/>
+          <a:chOff x="0" y="0"/>
+          <a:chExt cx="0" cy="0"/>
+        </a:xfrm>
+      </p:grpSpPr>
+      <p:sp>
+        <p:nvSpPr>
+          <p:cNvPr id="171" name="Titulo"/>
+          <p:cNvSpPr>
+            <a:spLocks noGrp="1"/>
+          </p:cNvSpPr>
+          <p:nvPr/>
+        </p:nvSpPr>
+        <p:spPr>
+          <a:xfrm>
+            <a:off x="640000" y="360000"/>
+            <a:ext cx="10900000" cy="900000"/>
+          </a:xfrm>
+          <a:prstGeom prst="rect">
+            <a:avLst/>
+          </a:prstGeom>
+        </p:spPr>
+        <p:txBody>
+          <a:bodyPr wrap="square" rtlCol="0">
+            <a:normAutofit/>
+          </a:bodyPr>
+          <a:lstStyle/>
+          <a:p>
+            <a:pPr marL="0" lvl="0">
+              <a:buNone/>
+            </a:pPr>
+            <a:r>
+              <a:rPr lang="es-PE" sz="2600" b="1" dirty="0">
+                <a:solidFill>
+                  <a:srgbClr val="1F2A44"/>
+                </a:solidFill>
+                <a:latin typeface="Calibri"/>
+              </a:rPr>
+              <a:t>Anexo - dispersion de tiempos y desviacion estandar (sin via aerea)</a:t>
+            </a:r>
+            <a:endParaRPr lang="es-PE" sz="2600"/>
+          </a:p>
+        </p:txBody>
+      </p:sp>
+      <p:pic>
+        <p:nvPicPr>
+          <p:cNvPr id="91" name="Chart"/>
+          <p:cNvPicPr>
+            <a:picLocks noChangeAspect="1"/>
+          </p:cNvPicPr>
+          <p:nvPr/>
+        </p:nvPicPr>
+        <p:blipFill>
+          <a:blip r:embed="rId2"/>
+          <a:stretch>
+            <a:fillRect/>
+          </a:stretch>
+        </p:blipFill>
+        <p:spPr>
+          <a:xfrm>
+            <a:off x="1071000" y="1330000"/>
+            <a:ext cx="10050000" cy="5653125"/>
+          </a:xfrm>
+          <a:prstGeom prst="rect">
+            <a:avLst/>
+          </a:prstGeom>
+        </p:spPr>
+      </p:pic>
+    </p:spTree>
+  </p:cSld>
+  <p:clrMapOvr>
+    <a:overrideClrMapping bg1="lt1" tx1="dk1" bg2="lt2" tx2="dk2" accent1="accent1" accent2="accent2" accent3="accent3" accent4="accent4" accent5="accent5" accent6="accent6" hlink="hlink" folHlink="folHlink"/>
+  </p:clrMapOvr>
+</p:sld>
+</file>
+
 <file path=ppt/theme/theme1.xml><?xml version="1.0" encoding="utf-8"?>
 <a:theme xmlns:a="http://schemas.openxmlformats.org/drawingml/2006/main" name="Office">
   <a:themeElements>

</xml_diff>

<commit_message>
Expresar media, mediana y desviacion estandar terrestre en minutos
Se cambia el formato de horas a minutos en las cifras de dispersion
(diapositiva 3) y en el eje y las bandas de referencia del grafico de
anexo (diapositiva 9), para facilitar la lectura.

Co-Authored-By: Claude Sonnet 5 <noreply@anthropic.com>
</commit_message>
<xml_diff>
--- a/datos/Resumen_tiempos_convenios_BS.pptx
+++ b/datos/Resumen_tiempos_convenios_BS.pptx
@@ -955,7 +955,7 @@
                 </a:solidFill>
                 <a:latin typeface="Calibri"/>
               </a:rPr>
-              <a:t>Sin via aerea (231 convenios): mediana 0 h 24 min, media 0 h 50 min, desviacion estandar 1 h 12 min.</a:t>
+              <a:t>Sin via aerea (231 convenios): mediana 24 min, media 50 min, desviacion estandar 72 min.</a:t>
             </a:r>
             <a:endParaRPr lang="es-PE" sz="1300"/>
           </a:p>
@@ -986,7 +986,7 @@
                 </a:solidFill>
                 <a:latin typeface="Calibri"/>
               </a:rPr>
-              <a:t>En ese grupo la mediana del tiempo de ruta es 2 h 16 min y la media es 2 h 51 min.</a:t>
+              <a:t>En ese grupo la mediana del tiempo de ruta es 136 min y la media es 171 min.</a:t>
             </a:r>
             <a:endParaRPr lang="es-PE" sz="1500"/>
           </a:p>
@@ -1001,7 +1001,7 @@
                 </a:solidFill>
                 <a:latin typeface="Calibri"/>
               </a:rPr>
-              <a:t>La media es mayor que la mediana porque unos pocos convenios de sierra (Cusco, Ayacucho) elevan el promedio; para la mitad del grupo el traslado sigue por debajo de 2 h 16 min. Ver el detalle punto a punto y las bandas de desviacion estandar en el anexo (ultima diapositiva).</a:t>
+              <a:t>La media es mayor que la mediana porque unos pocos convenios de sierra (Cusco, Ayacucho) elevan el promedio; para la mitad del grupo el traslado sigue por debajo de 136 min. Ver el detalle punto a punto y las bandas de desviacion estandar en el anexo (ultima diapositiva).</a:t>
             </a:r>
             <a:endParaRPr lang="es-PE" sz="1200"/>
           </a:p>

</xml_diff>